<commit_message>
Add MMLU, Qwen3-8B generalization, output-length sweep and quality diagnostics
- MMLU on all 14,042 questions for every configuration, paired McNemar tests with
  Bonferroni correction; quality table and figure now cover perplexity, GSM8K and MMLU
- Qwen3-8B (non-thinking) as a second model family: sweeps, quality, comparison table
- output-length sweep on HF and vLLM; serving table with requests/s
- chunked LM head for HF perplexity (14B BF16), per-position NLL, PPL diagnostics
- report: quality section rewritten, generalization subsection, detail tables in appendix
- slides: quality, generalization and six-rule takeaway slides
</commit_message>
<xml_diff>
--- a/final_project/slides/final_presentation.pptx
+++ b/final_project/slides/final_presentation.pptx
@@ -1350,7 +1350,7 @@
           <a:lstStyle/>
           <a:p>
             <a:r>
-              <a:t>Four rules: plan memory with the real ratio; for interactive serving use 4-bit weights with a fused kernel; for throughput use FP8 W8A8; treat bitsandbytes as a memory tool, not a speed-up.</a:t>
+              <a:t>Six rules: plan memory with the real ratio; for interactive serving use 4-bit weights with a fused kernel; for throughput use FP8 W8A8; treat bitsandbytes as a memory tool, not a speed-up; 8-bit formats with good kernels preserve quality while 4-bit costs one to three MMLU points; and at a fixed memory budget a larger 4-bit model beats a smaller 16-bit one.</a:t>
             </a:r>
           </a:p>
         </p:txBody>
@@ -5293,7 +5293,7 @@
         <p:spPr>
           <a:xfrm>
             <a:off x="457200" y="1133856"/>
-            <a:ext cx="4041648" cy="1417320"/>
+            <a:ext cx="2679192" cy="1417320"/>
           </a:xfrm>
           <a:prstGeom prst="roundRect">
             <a:avLst>
@@ -5344,8 +5344,8 @@
         </p:nvSpPr>
         <p:spPr>
           <a:xfrm>
-            <a:off x="585216" y="1280160"/>
-            <a:ext cx="402336" cy="402336"/>
+            <a:off x="566928" y="1261872"/>
+            <a:ext cx="329184" cy="329184"/>
           </a:xfrm>
           <a:prstGeom prst="ellipse">
             <a:avLst/>
@@ -5402,8 +5402,8 @@
         </p:blipFill>
         <p:spPr>
           <a:xfrm>
-            <a:off x="673729" y="1368673"/>
-            <a:ext cx="225308" cy="225308"/>
+            <a:off x="639348" y="1334292"/>
+            <a:ext cx="184343" cy="184343"/>
           </a:xfrm>
           <a:prstGeom prst="rect">
             <a:avLst/>
@@ -5418,8 +5418,8 @@
         </p:nvSpPr>
         <p:spPr>
           <a:xfrm>
-            <a:off x="1115568" y="1261872"/>
-            <a:ext cx="3255264" cy="438912"/>
+            <a:off x="969264" y="1225296"/>
+            <a:ext cx="2093976" cy="402336"/>
           </a:xfrm>
           <a:prstGeom prst="rect">
             <a:avLst/>
@@ -5434,7 +5434,7 @@
           <a:p>
             <a:pPr algn="l"/>
             <a:r>
-              <a:rPr sz="1200" b="1" i="0">
+              <a:rPr sz="1050" b="1" i="0">
                 <a:solidFill>
                   <a:srgbClr val="003865"/>
                 </a:solidFill>
@@ -5453,8 +5453,8 @@
         </p:nvSpPr>
         <p:spPr>
           <a:xfrm>
-            <a:off x="640080" y="1792224"/>
-            <a:ext cx="1417320" cy="566928"/>
+            <a:off x="585216" y="1682495"/>
+            <a:ext cx="914400" cy="731520"/>
           </a:xfrm>
           <a:prstGeom prst="rect">
             <a:avLst/>
@@ -5469,7 +5469,7 @@
           <a:p>
             <a:pPr algn="l"/>
             <a:r>
-              <a:rPr sz="2200" b="1" i="0">
+              <a:rPr sz="1900" b="1" i="0">
                 <a:solidFill>
                   <a:srgbClr val="00599B"/>
                 </a:solidFill>
@@ -5488,8 +5488,8 @@
         </p:nvSpPr>
         <p:spPr>
           <a:xfrm>
-            <a:off x="2103120" y="1773936"/>
-            <a:ext cx="2258568" cy="704088"/>
+            <a:off x="1499616" y="1645920"/>
+            <a:ext cx="1545336" cy="850392"/>
           </a:xfrm>
           <a:prstGeom prst="rect">
             <a:avLst/>
@@ -5504,7 +5504,7 @@
           <a:p>
             <a:pPr algn="l"/>
             <a:r>
-              <a:rPr sz="950" b="0" i="0">
+              <a:rPr sz="850" b="0" i="0">
                 <a:solidFill>
                   <a:srgbClr val="1F2933"/>
                 </a:solidFill>
@@ -5529,8 +5529,8 @@
         </p:nvSpPr>
         <p:spPr>
           <a:xfrm>
-            <a:off x="4645152" y="1133856"/>
-            <a:ext cx="4041648" cy="1417320"/>
+            <a:off x="3255264" y="1133856"/>
+            <a:ext cx="2679192" cy="1417320"/>
           </a:xfrm>
           <a:prstGeom prst="roundRect">
             <a:avLst>
@@ -5581,8 +5581,8 @@
         </p:nvSpPr>
         <p:spPr>
           <a:xfrm>
-            <a:off x="4773168" y="1280160"/>
-            <a:ext cx="402336" cy="402336"/>
+            <a:off x="3364991" y="1261872"/>
+            <a:ext cx="329184" cy="329184"/>
           </a:xfrm>
           <a:prstGeom prst="ellipse">
             <a:avLst/>
@@ -5639,8 +5639,8 @@
         </p:blipFill>
         <p:spPr>
           <a:xfrm>
-            <a:off x="4861681" y="1368673"/>
-            <a:ext cx="225308" cy="225308"/>
+            <a:off x="3437412" y="1334292"/>
+            <a:ext cx="184343" cy="184343"/>
           </a:xfrm>
           <a:prstGeom prst="rect">
             <a:avLst/>
@@ -5655,8 +5655,8 @@
         </p:nvSpPr>
         <p:spPr>
           <a:xfrm>
-            <a:off x="5303520" y="1261872"/>
-            <a:ext cx="3255264" cy="438912"/>
+            <a:off x="3767328" y="1225296"/>
+            <a:ext cx="2093976" cy="402336"/>
           </a:xfrm>
           <a:prstGeom prst="rect">
             <a:avLst/>
@@ -5671,7 +5671,7 @@
           <a:p>
             <a:pPr algn="l"/>
             <a:r>
-              <a:rPr sz="1200" b="1" i="0">
+              <a:rPr sz="1050" b="1" i="0">
                 <a:solidFill>
                   <a:srgbClr val="003865"/>
                 </a:solidFill>
@@ -5690,8 +5690,8 @@
         </p:nvSpPr>
         <p:spPr>
           <a:xfrm>
-            <a:off x="4828032" y="1792224"/>
-            <a:ext cx="1417320" cy="566928"/>
+            <a:off x="3383280" y="1682495"/>
+            <a:ext cx="914400" cy="731520"/>
           </a:xfrm>
           <a:prstGeom prst="rect">
             <a:avLst/>
@@ -5706,7 +5706,7 @@
           <a:p>
             <a:pPr algn="l"/>
             <a:r>
-              <a:rPr sz="2200" b="1" i="0">
+              <a:rPr sz="1900" b="1" i="0">
                 <a:solidFill>
                   <a:srgbClr val="00599B"/>
                 </a:solidFill>
@@ -5725,8 +5725,8 @@
         </p:nvSpPr>
         <p:spPr>
           <a:xfrm>
-            <a:off x="6291072" y="1773936"/>
-            <a:ext cx="2258568" cy="704088"/>
+            <a:off x="4297680" y="1645920"/>
+            <a:ext cx="1545336" cy="850392"/>
           </a:xfrm>
           <a:prstGeom prst="rect">
             <a:avLst/>
@@ -5741,7 +5741,7 @@
           <a:p>
             <a:pPr algn="l"/>
             <a:r>
-              <a:rPr sz="950" b="0" i="0">
+              <a:rPr sz="850" b="0" i="0">
                 <a:solidFill>
                   <a:srgbClr val="1F2933"/>
                 </a:solidFill>
@@ -5766,8 +5766,8 @@
         </p:nvSpPr>
         <p:spPr>
           <a:xfrm>
-            <a:off x="457200" y="2697480"/>
-            <a:ext cx="4041648" cy="1417320"/>
+            <a:off x="6053328" y="1133856"/>
+            <a:ext cx="2679192" cy="1417320"/>
           </a:xfrm>
           <a:prstGeom prst="roundRect">
             <a:avLst>
@@ -5818,8 +5818,8 @@
         </p:nvSpPr>
         <p:spPr>
           <a:xfrm>
-            <a:off x="585216" y="2843784"/>
-            <a:ext cx="402336" cy="402336"/>
+            <a:off x="6163056" y="1261872"/>
+            <a:ext cx="329184" cy="329184"/>
           </a:xfrm>
           <a:prstGeom prst="ellipse">
             <a:avLst/>
@@ -5876,8 +5876,8 @@
         </p:blipFill>
         <p:spPr>
           <a:xfrm>
-            <a:off x="673729" y="2932297"/>
-            <a:ext cx="225308" cy="225308"/>
+            <a:off x="6235476" y="1334292"/>
+            <a:ext cx="184343" cy="184343"/>
           </a:xfrm>
           <a:prstGeom prst="rect">
             <a:avLst/>
@@ -5892,8 +5892,8 @@
         </p:nvSpPr>
         <p:spPr>
           <a:xfrm>
-            <a:off x="1115568" y="2825496"/>
-            <a:ext cx="3255264" cy="438912"/>
+            <a:off x="6565392" y="1225296"/>
+            <a:ext cx="2093976" cy="402336"/>
           </a:xfrm>
           <a:prstGeom prst="rect">
             <a:avLst/>
@@ -5908,7 +5908,7 @@
           <a:p>
             <a:pPr algn="l"/>
             <a:r>
-              <a:rPr sz="1200" b="1" i="0">
+              <a:rPr sz="1050" b="1" i="0">
                 <a:solidFill>
                   <a:srgbClr val="003865"/>
                 </a:solidFill>
@@ -5927,8 +5927,8 @@
         </p:nvSpPr>
         <p:spPr>
           <a:xfrm>
-            <a:off x="640080" y="3355848"/>
-            <a:ext cx="1417320" cy="566928"/>
+            <a:off x="6181344" y="1682495"/>
+            <a:ext cx="914400" cy="731520"/>
           </a:xfrm>
           <a:prstGeom prst="rect">
             <a:avLst/>
@@ -5943,7 +5943,7 @@
           <a:p>
             <a:pPr algn="l"/>
             <a:r>
-              <a:rPr sz="2200" b="1" i="0">
+              <a:rPr sz="1900" b="1" i="0">
                 <a:solidFill>
                   <a:srgbClr val="00599B"/>
                 </a:solidFill>
@@ -5962,8 +5962,8 @@
         </p:nvSpPr>
         <p:spPr>
           <a:xfrm>
-            <a:off x="2103120" y="3337560"/>
-            <a:ext cx="2258568" cy="704088"/>
+            <a:off x="7095744" y="1645920"/>
+            <a:ext cx="1545336" cy="850392"/>
           </a:xfrm>
           <a:prstGeom prst="rect">
             <a:avLst/>
@@ -5978,7 +5978,7 @@
           <a:p>
             <a:pPr algn="l"/>
             <a:r>
-              <a:rPr sz="950" b="0" i="0">
+              <a:rPr sz="850" b="0" i="0">
                 <a:solidFill>
                   <a:srgbClr val="1F2933"/>
                 </a:solidFill>
@@ -6003,8 +6003,8 @@
         </p:nvSpPr>
         <p:spPr>
           <a:xfrm>
-            <a:off x="4645152" y="2697480"/>
-            <a:ext cx="4041648" cy="1417320"/>
+            <a:off x="457200" y="2679191"/>
+            <a:ext cx="2679192" cy="1417320"/>
           </a:xfrm>
           <a:prstGeom prst="roundRect">
             <a:avLst>
@@ -6055,8 +6055,8 @@
         </p:nvSpPr>
         <p:spPr>
           <a:xfrm>
-            <a:off x="4773168" y="2843784"/>
-            <a:ext cx="402336" cy="402336"/>
+            <a:off x="566928" y="2807207"/>
+            <a:ext cx="329184" cy="329184"/>
           </a:xfrm>
           <a:prstGeom prst="ellipse">
             <a:avLst/>
@@ -6113,8 +6113,8 @@
         </p:blipFill>
         <p:spPr>
           <a:xfrm>
-            <a:off x="4861681" y="2932297"/>
-            <a:ext cx="225308" cy="225308"/>
+            <a:off x="639348" y="2879628"/>
+            <a:ext cx="184343" cy="184343"/>
           </a:xfrm>
           <a:prstGeom prst="rect">
             <a:avLst/>
@@ -6129,8 +6129,8 @@
         </p:nvSpPr>
         <p:spPr>
           <a:xfrm>
-            <a:off x="5303520" y="2825496"/>
-            <a:ext cx="3255264" cy="438912"/>
+            <a:off x="969264" y="2770632"/>
+            <a:ext cx="2093976" cy="402336"/>
           </a:xfrm>
           <a:prstGeom prst="rect">
             <a:avLst/>
@@ -6145,7 +6145,7 @@
           <a:p>
             <a:pPr algn="l"/>
             <a:r>
-              <a:rPr sz="1200" b="1" i="0">
+              <a:rPr sz="1050" b="1" i="0">
                 <a:solidFill>
                   <a:srgbClr val="003865"/>
                 </a:solidFill>
@@ -6164,8 +6164,8 @@
         </p:nvSpPr>
         <p:spPr>
           <a:xfrm>
-            <a:off x="4828032" y="3355848"/>
-            <a:ext cx="1417320" cy="566928"/>
+            <a:off x="585216" y="3227832"/>
+            <a:ext cx="914400" cy="731520"/>
           </a:xfrm>
           <a:prstGeom prst="rect">
             <a:avLst/>
@@ -6180,7 +6180,7 @@
           <a:p>
             <a:pPr algn="l"/>
             <a:r>
-              <a:rPr sz="2200" b="1" i="0">
+              <a:rPr sz="1900" b="1" i="0">
                 <a:solidFill>
                   <a:srgbClr val="00599B"/>
                 </a:solidFill>
@@ -6199,8 +6199,8 @@
         </p:nvSpPr>
         <p:spPr>
           <a:xfrm>
-            <a:off x="6291072" y="3337560"/>
-            <a:ext cx="2258568" cy="704088"/>
+            <a:off x="1499616" y="3191256"/>
+            <a:ext cx="1545336" cy="850392"/>
           </a:xfrm>
           <a:prstGeom prst="rect">
             <a:avLst/>
@@ -6215,13 +6215,487 @@
           <a:p>
             <a:pPr algn="l"/>
             <a:r>
-              <a:rPr sz="950" b="0" i="0">
+              <a:rPr sz="850" b="0" i="0">
                 <a:solidFill>
                   <a:srgbClr val="1F2933"/>
                 </a:solidFill>
                 <a:latin typeface="Arial"/>
               </a:rPr>
-              <a:t>slower decode with LLM.int8() at batch size 1; NF4 wins only tiny batches of large models</a:t>
+              <a:t>slower decode with LLM.int8() at batch size 1; NF4 helps only tiny batches</a:t>
+            </a:r>
+          </a:p>
+        </p:txBody>
+      </p:sp>
+      <p:sp>
+        <p:nvSpPr>
+          <p:cNvPr id="28" name="Rounded Rectangle 27">
+            <a:extLst>
+              <a:ext uri="{C183D7F6-B498-43B3-948B-1728B52AA6E4}">
+                <adec:decorative xmlns:adec="http://schemas.microsoft.com/office/drawing/2017/decorative" val="1"/>
+              </a:ext>
+            </a:extLst>
+          </p:cNvPr>
+          <p:cNvSpPr/>
+          <p:nvPr/>
+        </p:nvSpPr>
+        <p:spPr>
+          <a:xfrm>
+            <a:off x="3255264" y="2679191"/>
+            <a:ext cx="2679192" cy="1417320"/>
+          </a:xfrm>
+          <a:prstGeom prst="roundRect">
+            <a:avLst>
+              <a:gd name="adj" fmla="val 5161"/>
+            </a:avLst>
+          </a:prstGeom>
+          <a:solidFill>
+            <a:srgbClr val="EDF3F9"/>
+          </a:solidFill>
+          <a:ln>
+            <a:noFill/>
+          </a:ln>
+          <a:effectLst/>
+        </p:spPr>
+        <p:style>
+          <a:lnRef idx="1">
+            <a:schemeClr val="accent1"/>
+          </a:lnRef>
+          <a:fillRef idx="3">
+            <a:schemeClr val="accent1"/>
+          </a:fillRef>
+          <a:effectRef idx="2">
+            <a:schemeClr val="accent1"/>
+          </a:effectRef>
+          <a:fontRef idx="minor">
+            <a:schemeClr val="lt1"/>
+          </a:fontRef>
+        </p:style>
+        <p:txBody>
+          <a:bodyPr rtlCol="0" anchor="ctr"/>
+          <a:lstStyle/>
+          <a:p>
+            <a:pPr algn="ctr"/>
+          </a:p>
+        </p:txBody>
+      </p:sp>
+      <p:sp>
+        <p:nvSpPr>
+          <p:cNvPr id="29" name="Oval 28">
+            <a:extLst>
+              <a:ext uri="{C183D7F6-B498-43B3-948B-1728B52AA6E4}">
+                <adec:decorative xmlns:adec="http://schemas.microsoft.com/office/drawing/2017/decorative" val="1"/>
+              </a:ext>
+            </a:extLst>
+          </p:cNvPr>
+          <p:cNvSpPr/>
+          <p:nvPr/>
+        </p:nvSpPr>
+        <p:spPr>
+          <a:xfrm>
+            <a:off x="3364991" y="2807207"/>
+            <a:ext cx="329184" cy="329184"/>
+          </a:xfrm>
+          <a:prstGeom prst="ellipse">
+            <a:avLst/>
+          </a:prstGeom>
+          <a:solidFill>
+            <a:srgbClr val="0064B1"/>
+          </a:solidFill>
+          <a:ln>
+            <a:noFill/>
+          </a:ln>
+          <a:effectLst/>
+        </p:spPr>
+        <p:style>
+          <a:lnRef idx="1">
+            <a:schemeClr val="accent1"/>
+          </a:lnRef>
+          <a:fillRef idx="3">
+            <a:schemeClr val="accent1"/>
+          </a:fillRef>
+          <a:effectRef idx="2">
+            <a:schemeClr val="accent1"/>
+          </a:effectRef>
+          <a:fontRef idx="minor">
+            <a:schemeClr val="lt1"/>
+          </a:fontRef>
+        </p:style>
+        <p:txBody>
+          <a:bodyPr rtlCol="0" anchor="ctr"/>
+          <a:lstStyle/>
+          <a:p>
+            <a:pPr algn="ctr"/>
+          </a:p>
+        </p:txBody>
+      </p:sp>
+      <p:pic>
+        <p:nvPicPr>
+          <p:cNvPr id="30" name="Picture 29" descr="">
+            <a:extLst>
+              <a:ext uri="{C183D7F6-B498-43B3-948B-1728B52AA6E4}">
+                <adec:decorative xmlns:adec="http://schemas.microsoft.com/office/drawing/2017/decorative" val="1"/>
+              </a:ext>
+            </a:extLst>
+          </p:cNvPr>
+          <p:cNvPicPr>
+            <a:picLocks noChangeAspect="1"/>
+          </p:cNvPicPr>
+          <p:nvPr/>
+        </p:nvPicPr>
+        <p:blipFill>
+          <a:blip r:embed="rId7"/>
+          <a:stretch>
+            <a:fillRect/>
+          </a:stretch>
+        </p:blipFill>
+        <p:spPr>
+          <a:xfrm>
+            <a:off x="3437412" y="2879628"/>
+            <a:ext cx="184343" cy="184343"/>
+          </a:xfrm>
+          <a:prstGeom prst="rect">
+            <a:avLst/>
+          </a:prstGeom>
+        </p:spPr>
+      </p:pic>
+      <p:sp>
+        <p:nvSpPr>
+          <p:cNvPr id="31" name="TextBox 30"/>
+          <p:cNvSpPr txBox="1"/>
+          <p:nvPr/>
+        </p:nvSpPr>
+        <p:spPr>
+          <a:xfrm>
+            <a:off x="3767328" y="2770632"/>
+            <a:ext cx="2093976" cy="402336"/>
+          </a:xfrm>
+          <a:prstGeom prst="rect">
+            <a:avLst/>
+          </a:prstGeom>
+          <a:noFill/>
+        </p:spPr>
+        <p:txBody>
+          <a:bodyPr wrap="square" lIns="0" tIns="0" rIns="0" bIns="0" anchor="ctr">
+            <a:noAutofit/>
+          </a:bodyPr>
+          <a:lstStyle/>
+          <a:p>
+            <a:pPr algn="l"/>
+            <a:r>
+              <a:rPr sz="1050" b="1" i="0">
+                <a:solidFill>
+                  <a:srgbClr val="003865"/>
+                </a:solidFill>
+                <a:latin typeface="Arial"/>
+              </a:rPr>
+              <a:t>Quality: 8-bit free, 4-bit not</a:t>
+            </a:r>
+          </a:p>
+        </p:txBody>
+      </p:sp>
+      <p:sp>
+        <p:nvSpPr>
+          <p:cNvPr id="32" name="TextBox 31"/>
+          <p:cNvSpPr txBox="1"/>
+          <p:nvPr/>
+        </p:nvSpPr>
+        <p:spPr>
+          <a:xfrm>
+            <a:off x="3383280" y="3227832"/>
+            <a:ext cx="914400" cy="731520"/>
+          </a:xfrm>
+          <a:prstGeom prst="rect">
+            <a:avLst/>
+          </a:prstGeom>
+          <a:noFill/>
+        </p:spPr>
+        <p:txBody>
+          <a:bodyPr wrap="square" lIns="0" tIns="0" rIns="0" bIns="0" anchor="ctr">
+            <a:noAutofit/>
+          </a:bodyPr>
+          <a:lstStyle/>
+          <a:p>
+            <a:pPr algn="l"/>
+            <a:r>
+              <a:rPr sz="1900" b="1" i="0">
+                <a:solidFill>
+                  <a:srgbClr val="00599B"/>
+                </a:solidFill>
+                <a:latin typeface="Arial"/>
+              </a:rPr>
+              <a:t>−2.8 pp</a:t>
+            </a:r>
+          </a:p>
+        </p:txBody>
+      </p:sp>
+      <p:sp>
+        <p:nvSpPr>
+          <p:cNvPr id="33" name="TextBox 32"/>
+          <p:cNvSpPr txBox="1"/>
+          <p:nvPr/>
+        </p:nvSpPr>
+        <p:spPr>
+          <a:xfrm>
+            <a:off x="4297680" y="3191256"/>
+            <a:ext cx="1545336" cy="850392"/>
+          </a:xfrm>
+          <a:prstGeom prst="rect">
+            <a:avLst/>
+          </a:prstGeom>
+          <a:noFill/>
+        </p:spPr>
+        <p:txBody>
+          <a:bodyPr wrap="square" lIns="0" tIns="0" rIns="0" bIns="0" anchor="ctr">
+            <a:noAutofit/>
+          </a:bodyPr>
+          <a:lstStyle/>
+          <a:p>
+            <a:pPr algn="l"/>
+            <a:r>
+              <a:rPr sz="850" b="0" i="0">
+                <a:solidFill>
+                  <a:srgbClr val="1F2933"/>
+                </a:solidFill>
+                <a:latin typeface="Arial"/>
+              </a:rPr>
+              <a:t>worst MMLU pp with 4-bit (3B); GPTQ-INT8 / FP8 within 0.9 pp everywhere</a:t>
+            </a:r>
+          </a:p>
+        </p:txBody>
+      </p:sp>
+      <p:sp>
+        <p:nvSpPr>
+          <p:cNvPr id="34" name="Rounded Rectangle 33">
+            <a:extLst>
+              <a:ext uri="{C183D7F6-B498-43B3-948B-1728B52AA6E4}">
+                <adec:decorative xmlns:adec="http://schemas.microsoft.com/office/drawing/2017/decorative" val="1"/>
+              </a:ext>
+            </a:extLst>
+          </p:cNvPr>
+          <p:cNvSpPr/>
+          <p:nvPr/>
+        </p:nvSpPr>
+        <p:spPr>
+          <a:xfrm>
+            <a:off x="6053328" y="2679191"/>
+            <a:ext cx="2679192" cy="1417320"/>
+          </a:xfrm>
+          <a:prstGeom prst="roundRect">
+            <a:avLst>
+              <a:gd name="adj" fmla="val 5161"/>
+            </a:avLst>
+          </a:prstGeom>
+          <a:solidFill>
+            <a:srgbClr val="EDF3F9"/>
+          </a:solidFill>
+          <a:ln>
+            <a:noFill/>
+          </a:ln>
+          <a:effectLst/>
+        </p:spPr>
+        <p:style>
+          <a:lnRef idx="1">
+            <a:schemeClr val="accent1"/>
+          </a:lnRef>
+          <a:fillRef idx="3">
+            <a:schemeClr val="accent1"/>
+          </a:fillRef>
+          <a:effectRef idx="2">
+            <a:schemeClr val="accent1"/>
+          </a:effectRef>
+          <a:fontRef idx="minor">
+            <a:schemeClr val="lt1"/>
+          </a:fontRef>
+        </p:style>
+        <p:txBody>
+          <a:bodyPr rtlCol="0" anchor="ctr"/>
+          <a:lstStyle/>
+          <a:p>
+            <a:pPr algn="ctr"/>
+          </a:p>
+        </p:txBody>
+      </p:sp>
+      <p:sp>
+        <p:nvSpPr>
+          <p:cNvPr id="35" name="Oval 34">
+            <a:extLst>
+              <a:ext uri="{C183D7F6-B498-43B3-948B-1728B52AA6E4}">
+                <adec:decorative xmlns:adec="http://schemas.microsoft.com/office/drawing/2017/decorative" val="1"/>
+              </a:ext>
+            </a:extLst>
+          </p:cNvPr>
+          <p:cNvSpPr/>
+          <p:nvPr/>
+        </p:nvSpPr>
+        <p:spPr>
+          <a:xfrm>
+            <a:off x="6163056" y="2807207"/>
+            <a:ext cx="329184" cy="329184"/>
+          </a:xfrm>
+          <a:prstGeom prst="ellipse">
+            <a:avLst/>
+          </a:prstGeom>
+          <a:solidFill>
+            <a:srgbClr val="0064B1"/>
+          </a:solidFill>
+          <a:ln>
+            <a:noFill/>
+          </a:ln>
+          <a:effectLst/>
+        </p:spPr>
+        <p:style>
+          <a:lnRef idx="1">
+            <a:schemeClr val="accent1"/>
+          </a:lnRef>
+          <a:fillRef idx="3">
+            <a:schemeClr val="accent1"/>
+          </a:fillRef>
+          <a:effectRef idx="2">
+            <a:schemeClr val="accent1"/>
+          </a:effectRef>
+          <a:fontRef idx="minor">
+            <a:schemeClr val="lt1"/>
+          </a:fontRef>
+        </p:style>
+        <p:txBody>
+          <a:bodyPr rtlCol="0" anchor="ctr"/>
+          <a:lstStyle/>
+          <a:p>
+            <a:pPr algn="ctr"/>
+          </a:p>
+        </p:txBody>
+      </p:sp>
+      <p:pic>
+        <p:nvPicPr>
+          <p:cNvPr id="36" name="Picture 35" descr="">
+            <a:extLst>
+              <a:ext uri="{C183D7F6-B498-43B3-948B-1728B52AA6E4}">
+                <adec:decorative xmlns:adec="http://schemas.microsoft.com/office/drawing/2017/decorative" val="1"/>
+              </a:ext>
+            </a:extLst>
+          </p:cNvPr>
+          <p:cNvPicPr>
+            <a:picLocks noChangeAspect="1"/>
+          </p:cNvPicPr>
+          <p:nvPr/>
+        </p:nvPicPr>
+        <p:blipFill>
+          <a:blip r:embed="rId8"/>
+          <a:stretch>
+            <a:fillRect/>
+          </a:stretch>
+        </p:blipFill>
+        <p:spPr>
+          <a:xfrm>
+            <a:off x="6235476" y="2879628"/>
+            <a:ext cx="184343" cy="184343"/>
+          </a:xfrm>
+          <a:prstGeom prst="rect">
+            <a:avLst/>
+          </a:prstGeom>
+        </p:spPr>
+      </p:pic>
+      <p:sp>
+        <p:nvSpPr>
+          <p:cNvPr id="37" name="TextBox 36"/>
+          <p:cNvSpPr txBox="1"/>
+          <p:nvPr/>
+        </p:nvSpPr>
+        <p:spPr>
+          <a:xfrm>
+            <a:off x="6565392" y="2770632"/>
+            <a:ext cx="2093976" cy="402336"/>
+          </a:xfrm>
+          <a:prstGeom prst="rect">
+            <a:avLst/>
+          </a:prstGeom>
+          <a:noFill/>
+        </p:spPr>
+        <p:txBody>
+          <a:bodyPr wrap="square" lIns="0" tIns="0" rIns="0" bIns="0" anchor="ctr">
+            <a:noAutofit/>
+          </a:bodyPr>
+          <a:lstStyle/>
+          <a:p>
+            <a:pPr algn="l"/>
+            <a:r>
+              <a:rPr sz="1050" b="1" i="0">
+                <a:solidFill>
+                  <a:srgbClr val="003865"/>
+                </a:solidFill>
+                <a:latin typeface="Arial"/>
+              </a:rPr>
+              <a:t>Spend memory on parameters</a:t>
+            </a:r>
+          </a:p>
+        </p:txBody>
+      </p:sp>
+      <p:sp>
+        <p:nvSpPr>
+          <p:cNvPr id="38" name="TextBox 37"/>
+          <p:cNvSpPr txBox="1"/>
+          <p:nvPr/>
+        </p:nvSpPr>
+        <p:spPr>
+          <a:xfrm>
+            <a:off x="6181344" y="3227832"/>
+            <a:ext cx="914400" cy="731520"/>
+          </a:xfrm>
+          <a:prstGeom prst="rect">
+            <a:avLst/>
+          </a:prstGeom>
+          <a:noFill/>
+        </p:spPr>
+        <p:txBody>
+          <a:bodyPr wrap="square" lIns="0" tIns="0" rIns="0" bIns="0" anchor="ctr">
+            <a:noAutofit/>
+          </a:bodyPr>
+          <a:lstStyle/>
+          <a:p>
+            <a:pPr algn="l"/>
+            <a:r>
+              <a:rPr sz="1900" b="1" i="0">
+                <a:solidFill>
+                  <a:srgbClr val="00599B"/>
+                </a:solidFill>
+                <a:latin typeface="Arial"/>
+              </a:rPr>
+              <a:t>75.1%</a:t>
+            </a:r>
+          </a:p>
+        </p:txBody>
+      </p:sp>
+      <p:sp>
+        <p:nvSpPr>
+          <p:cNvPr id="39" name="TextBox 38"/>
+          <p:cNvSpPr txBox="1"/>
+          <p:nvPr/>
+        </p:nvSpPr>
+        <p:spPr>
+          <a:xfrm>
+            <a:off x="7095744" y="3191256"/>
+            <a:ext cx="1545336" cy="850392"/>
+          </a:xfrm>
+          <a:prstGeom prst="rect">
+            <a:avLst/>
+          </a:prstGeom>
+          <a:noFill/>
+        </p:spPr>
+        <p:txBody>
+          <a:bodyPr wrap="square" lIns="0" tIns="0" rIns="0" bIns="0" anchor="ctr">
+            <a:noAutofit/>
+          </a:bodyPr>
+          <a:lstStyle/>
+          <a:p>
+            <a:pPr algn="l"/>
+            <a:r>
+              <a:rPr sz="850" b="0" i="0">
+                <a:solidFill>
+                  <a:srgbClr val="1F2933"/>
+                </a:solidFill>
+                <a:latin typeface="Arial"/>
+              </a:rPr>
+              <a:t>MMLU of 14B AWQ-INT4 vs 71.4% for 7B BF16, with less weight memory</a:t>
             </a:r>
           </a:p>
         </p:txBody>
@@ -9549,7 +10023,7 @@
                 </a:solidFill>
                 <a:latin typeface="Arial"/>
               </a:rPr>
-              <a:t>1.88×</a:t>
+              <a:t>1.90×</a:t>
             </a:r>
           </a:p>
         </p:txBody>
@@ -9672,7 +10146,7 @@
           <a:p>
             <a:r>
               <a:rPr sz="1400"/>
-              <a:t>Qwen2.5-7B: same 4-bit weights, opposite outcomes on two software stacks</a:t>
+              <a:t>Qwen2.5-7B at batch 1: low-bit decode ranges from 2.4× faster to 3.4× slower — the kernel decides</a:t>
             </a:r>
           </a:p>
         </p:txBody>
@@ -12222,14 +12696,14 @@
           <a:p>
             <a:r>
               <a:rPr sz="1400"/>
-              <a:t>GSM8K accuracy (1,319 questions) and WikiText-2 perplexity vs. weight memory</a:t>
+              <a:t>GSM8K (1,319 q.) · MMLU (14,042 q.) · WikiText-2 perplexity, with paired McNemar tests</a:t>
             </a:r>
           </a:p>
         </p:txBody>
       </p:sp>
       <p:pic>
         <p:nvPicPr>
-          <p:cNvPr id="4" name="Picture 3" descr="GSM8K accuracy and perplexity versus weight memory"/>
+          <p:cNvPr id="4" name="Picture 3" descr="GSM8K, MMLU and perplexity versus weight memory"/>
           <p:cNvPicPr>
             <a:picLocks noChangeAspect="1"/>
           </p:cNvPicPr>
@@ -12243,8 +12717,8 @@
         </p:blipFill>
         <p:spPr>
           <a:xfrm>
-            <a:off x="457200" y="1527475"/>
-            <a:ext cx="5669280" cy="2239424"/>
+            <a:off x="457200" y="1133856"/>
+            <a:ext cx="8229600" cy="2035639"/>
           </a:xfrm>
           <a:prstGeom prst="rect">
             <a:avLst/>
@@ -12265,12 +12739,12 @@
         </p:nvSpPr>
         <p:spPr>
           <a:xfrm>
-            <a:off x="6263640" y="1133856"/>
-            <a:ext cx="2423159" cy="947927"/>
+            <a:off x="457200" y="3291839"/>
+            <a:ext cx="2651760" cy="868680"/>
           </a:xfrm>
           <a:prstGeom prst="roundRect">
             <a:avLst>
-              <a:gd name="adj" fmla="val 7717"/>
+              <a:gd name="adj" fmla="val 8421"/>
             </a:avLst>
           </a:prstGeom>
           <a:solidFill>
@@ -12311,8 +12785,8 @@
         </p:nvSpPr>
         <p:spPr>
           <a:xfrm>
-            <a:off x="6391656" y="1207008"/>
-            <a:ext cx="2203703" cy="384048"/>
+            <a:off x="585216" y="3364991"/>
+            <a:ext cx="2432304" cy="384048"/>
           </a:xfrm>
           <a:prstGeom prst="rect">
             <a:avLst/>
@@ -12333,7 +12807,7 @@
                 </a:solidFill>
                 <a:latin typeface="Arial"/>
               </a:rPr>
-              <a:t>-0.2 to +0.9 pp</a:t>
+              <a:t>≤ 0.9 pp</a:t>
             </a:r>
           </a:p>
         </p:txBody>
@@ -12346,8 +12820,8 @@
         </p:nvSpPr>
         <p:spPr>
           <a:xfrm>
-            <a:off x="6391656" y="1591056"/>
-            <a:ext cx="2203703" cy="435863"/>
+            <a:off x="585216" y="3749039"/>
+            <a:ext cx="2432304" cy="356615"/>
           </a:xfrm>
           <a:prstGeom prst="rect">
             <a:avLst/>
@@ -12372,7 +12846,7 @@
                 </a:solidFill>
                 <a:latin typeface="Arial"/>
               </a:rPr>
-              <a:t>GSM8K change with 8-bit formats (7B)</a:t>
+              <a:t>GPTQ-INT8 / FP8 vs BF16, GSM8K + MMLU</a:t>
             </a:r>
           </a:p>
           <a:p>
@@ -12384,7 +12858,7 @@
                 </a:solidFill>
                 <a:latin typeface="Arial"/>
               </a:rPr>
-              <a:t>1 of 3 significant (McNemar p &lt; 0.05)</a:t>
+              <a:t>all sizes; only LLM.int8() on 3B loses (−1.1 MMLU pp)</a:t>
             </a:r>
           </a:p>
         </p:txBody>
@@ -12403,12 +12877,12 @@
         </p:nvSpPr>
         <p:spPr>
           <a:xfrm>
-            <a:off x="6263640" y="2173224"/>
-            <a:ext cx="2423159" cy="947927"/>
+            <a:off x="3246120" y="3291839"/>
+            <a:ext cx="2651760" cy="868680"/>
           </a:xfrm>
           <a:prstGeom prst="roundRect">
             <a:avLst>
-              <a:gd name="adj" fmla="val 7717"/>
+              <a:gd name="adj" fmla="val 8421"/>
             </a:avLst>
           </a:prstGeom>
           <a:solidFill>
@@ -12449,8 +12923,8 @@
         </p:nvSpPr>
         <p:spPr>
           <a:xfrm>
-            <a:off x="6391656" y="2246376"/>
-            <a:ext cx="2203703" cy="384048"/>
+            <a:off x="3374136" y="3364991"/>
+            <a:ext cx="2432304" cy="384048"/>
           </a:xfrm>
           <a:prstGeom prst="rect">
             <a:avLst/>
@@ -12471,7 +12945,7 @@
                 </a:solidFill>
                 <a:latin typeface="Arial"/>
               </a:rPr>
-              <a:t>-0.5 to +0.2 pp</a:t>
+              <a:t>−2.8 to −0.6 pp</a:t>
             </a:r>
           </a:p>
         </p:txBody>
@@ -12484,8 +12958,8 @@
         </p:nvSpPr>
         <p:spPr>
           <a:xfrm>
-            <a:off x="6391656" y="2630424"/>
-            <a:ext cx="2203703" cy="435863"/>
+            <a:off x="3374136" y="3749039"/>
+            <a:ext cx="2432304" cy="356615"/>
           </a:xfrm>
           <a:prstGeom prst="rect">
             <a:avLst/>
@@ -12510,7 +12984,7 @@
                 </a:solidFill>
                 <a:latin typeface="Arial"/>
               </a:rPr>
-              <a:t>GSM8K change with 4-bit formats (7B)</a:t>
+              <a:t>MMLU change with 4-bit formats</a:t>
             </a:r>
           </a:p>
           <a:p>
@@ -12522,7 +12996,7 @@
                 </a:solidFill>
                 <a:latin typeface="Arial"/>
               </a:rPr>
-              <a:t>none significant (McNemar p ≥ 0.05)</a:t>
+              <a:t>3B −2.8…−2.2 · 7B −1.6…−0.6 · 14B −1.9…−0.6</a:t>
             </a:r>
           </a:p>
         </p:txBody>
@@ -12541,12 +13015,12 @@
         </p:nvSpPr>
         <p:spPr>
           <a:xfrm>
-            <a:off x="6263640" y="3212591"/>
-            <a:ext cx="2423159" cy="947927"/>
+            <a:off x="6035040" y="3291839"/>
+            <a:ext cx="2651760" cy="868680"/>
           </a:xfrm>
           <a:prstGeom prst="roundRect">
             <a:avLst>
-              <a:gd name="adj" fmla="val 7717"/>
+              <a:gd name="adj" fmla="val 8421"/>
             </a:avLst>
           </a:prstGeom>
           <a:solidFill>
@@ -12587,8 +13061,8 @@
         </p:nvSpPr>
         <p:spPr>
           <a:xfrm>
-            <a:off x="6391656" y="3285743"/>
-            <a:ext cx="2203703" cy="384048"/>
+            <a:off x="6163055" y="3364991"/>
+            <a:ext cx="2432304" cy="384048"/>
           </a:xfrm>
           <a:prstGeom prst="rect">
             <a:avLst/>
@@ -12609,7 +13083,7 @@
                 </a:solidFill>
                 <a:latin typeface="Arial"/>
               </a:rPr>
-              <a:t>93.9% vs 90.8%</a:t>
+              <a:t>+3.1 / +3.7 pp</a:t>
             </a:r>
           </a:p>
         </p:txBody>
@@ -12622,8 +13096,8 @@
         </p:nvSpPr>
         <p:spPr>
           <a:xfrm>
-            <a:off x="6391656" y="3669791"/>
-            <a:ext cx="2203703" cy="435863"/>
+            <a:off x="6163055" y="3749039"/>
+            <a:ext cx="2432304" cy="356615"/>
           </a:xfrm>
           <a:prstGeom prst="rect">
             <a:avLst/>
@@ -12648,7 +13122,7 @@
                 </a:solidFill>
                 <a:latin typeface="Arial"/>
               </a:rPr>
-              <a:t>14B AWQ-INT4 vs 7B BF16 on GSM8K</a:t>
+              <a:t>14B AWQ-INT4 vs 7B BF16 (GSM8K / MMLU)</a:t>
             </a:r>
           </a:p>
           <a:p>
@@ -12660,7 +13134,7 @@
                 </a:solidFill>
                 <a:latin typeface="Arial"/>
               </a:rPr>
-              <a:t>0.66× the weight memory of 7B BF16</a:t>
+              <a:t>0.66× the weight memory, McNemar p &lt; 0.001</a:t>
             </a:r>
           </a:p>
         </p:txBody>

</xml_diff>

<commit_message>
Final results, report and slides
- 14B HF quality (NF4, LLM.int8()) and MMLU complete; Qwen3-8B quality complete
- report: compiled main.pdf; 14B NF4 capacity result, NF4 speedup trend across sizes,
  model-specific quality caveat from Qwen3-8B, detail tables in the appendix
- slides: generalization slide, quality and takeaway slides from the report's numbers
- README key findings and results regenerated; run_all.sh covers every experiment
</commit_message>
<xml_diff>
--- a/final_project/slides/final_presentation.pptx
+++ b/final_project/slides/final_presentation.pptx
@@ -22,6 +22,7 @@
     <p:sldId id="264" r:id="rId20"/>
     <p:sldId id="265" r:id="rId21"/>
     <p:sldId id="266" r:id="rId22"/>
+    <p:sldId id="267" r:id="rId23"/>
   </p:sldIdLst>
   <p:sldSz cx="9144000" cy="5143500" type="screen16x9"/>
   <p:notesSz cx="6858000" cy="9144000"/>
@@ -790,6 +791,76 @@
           <a:lstStyle/>
           <a:p>
             <a:r>
+              <a:t>Six rules: plan memory with the real ratio; for interactive serving use 4-bit weights with a fused kernel; for throughput use FP8 W8A8; treat bitsandbytes as a memory tool, not a speed-up; 8-bit formats with good kernels preserve quality while 4-bit costs one to three MMLU points; and at a fixed memory budget a larger 4-bit model beats a smaller 16-bit one.</a:t>
+            </a:r>
+          </a:p>
+        </p:txBody>
+      </p:sp>
+      <p:sp>
+        <p:nvSpPr>
+          <p:cNvPr id="4" name="Slide Number Placeholder 3"/>
+          <p:cNvSpPr>
+            <a:spLocks noGrp="1"/>
+          </p:cNvSpPr>
+          <p:nvPr>
+            <p:ph type="sldNum" idx="5" sz="quarter"/>
+          </p:nvPr>
+        </p:nvSpPr>
+        <p:spPr/>
+      </p:sp>
+    </p:spTree>
+  </p:cSld>
+  <p:clrMapOvr>
+    <a:masterClrMapping/>
+  </p:clrMapOvr>
+</p:notes>
+</file>
+
+<file path=ppt/notesSlides/notesSlide11.xml><?xml version="1.0" encoding="utf-8"?>
+<p:notes xmlns:a="http://schemas.openxmlformats.org/drawingml/2006/main" xmlns:p="http://schemas.openxmlformats.org/presentationml/2006/main" xmlns:r="http://schemas.openxmlformats.org/officeDocument/2006/relationships">
+  <p:cSld>
+    <p:spTree>
+      <p:nvGrpSpPr>
+        <p:cNvPr id="1" name=""/>
+        <p:cNvGrpSpPr/>
+        <p:nvPr/>
+      </p:nvGrpSpPr>
+      <p:grpSpPr>
+        <a:xfrm>
+          <a:off x="0" y="0"/>
+          <a:ext cx="0" cy="0"/>
+          <a:chOff x="0" y="0"/>
+          <a:chExt cx="0" cy="0"/>
+        </a:xfrm>
+      </p:grpSpPr>
+      <p:sp>
+        <p:nvSpPr>
+          <p:cNvPr id="2" name="Slide Image Placeholder 1"/>
+          <p:cNvSpPr>
+            <a:spLocks noGrp="1"/>
+          </p:cNvSpPr>
+          <p:nvPr>
+            <p:ph type="sldImg" idx="2"/>
+          </p:nvPr>
+        </p:nvSpPr>
+        <p:spPr/>
+      </p:sp>
+      <p:sp>
+        <p:nvSpPr>
+          <p:cNvPr id="3" name="Notes Placeholder 2"/>
+          <p:cNvSpPr>
+            <a:spLocks noGrp="1"/>
+          </p:cNvSpPr>
+          <p:nvPr>
+            <p:ph type="body" idx="3" sz="quarter"/>
+          </p:nvPr>
+        </p:nvSpPr>
+        <p:spPr/>
+        <p:txBody>
+          <a:bodyPr/>
+          <a:lstStyle/>
+          <a:p>
+            <a:r>
               <a:t>Division of work as planned in the proposal; everyone shared analysis and writing.</a:t>
             </a:r>
           </a:p>
@@ -1350,7 +1421,7 @@
           <a:lstStyle/>
           <a:p>
             <a:r>
-              <a:t>Six rules: plan memory with the real ratio; for interactive serving use 4-bit weights with a fused kernel; for throughput use FP8 W8A8; treat bitsandbytes as a memory tool, not a speed-up; 8-bit formats with good kernels preserve quality while 4-bit costs one to three MMLU points; and at a fixed memory budget a larger 4-bit model beats a smaller 16-bit one.</a:t>
+              <a:t>Qwen3-8B reproduces the decode speedups of AWQ and FP8 and the LLM.int8() slowdown within a few percent. NF4 turns from a small gain into a loss because the 36-layer model is host-bound at batch 1, exactly like the 36-layer Qwen2.5-3B.</a:t>
             </a:r>
           </a:p>
         </p:txBody>
@@ -5246,7 +5317,7 @@
           <a:p>
             <a:r>
               <a:rPr sz="2800"/>
-              <a:t>Takeaways: When Does Quantization Pay Off?</a:t>
+              <a:t>Does It Generalize? Qwen3-8B</a:t>
             </a:r>
           </a:p>
         </p:txBody>
@@ -5273,14 +5344,38 @@
           <a:p>
             <a:r>
               <a:rPr sz="1400"/>
-              <a:t>Bit-width alone predicts little — the kernel and the regime decide</a:t>
-            </a:r>
-          </a:p>
-        </p:txBody>
-      </p:sp>
-      <p:sp>
-        <p:nvSpPr>
-          <p:cNvPr id="4" name="Rounded Rectangle 3">
+              <a:t>Qwen3-8B (36 layers, 8 KV heads, non-thinking): the systems picture carries over</a:t>
+            </a:r>
+          </a:p>
+        </p:txBody>
+      </p:sp>
+      <p:pic>
+        <p:nvPicPr>
+          <p:cNvPr id="4" name="Picture 3" descr="Decode speedup and MMLU change for Qwen2.5-7B and Qwen3-8B"/>
+          <p:cNvPicPr>
+            <a:picLocks noChangeAspect="1"/>
+          </p:cNvPicPr>
+          <p:nvPr/>
+        </p:nvPicPr>
+        <p:blipFill>
+          <a:blip r:embed="rId3"/>
+          <a:stretch>
+            <a:fillRect/>
+          </a:stretch>
+        </p:blipFill>
+        <p:spPr>
+          <a:xfrm>
+            <a:off x="1282480" y="1133856"/>
+            <a:ext cx="6579039" cy="2048255"/>
+          </a:xfrm>
+          <a:prstGeom prst="rect">
+            <a:avLst/>
+          </a:prstGeom>
+        </p:spPr>
+      </p:pic>
+      <p:sp>
+        <p:nvSpPr>
+          <p:cNvPr id="5" name="Rounded Rectangle 4">
             <a:extLst>
               <a:ext uri="{C183D7F6-B498-43B3-948B-1728B52AA6E4}">
                 <adec:decorative xmlns:adec="http://schemas.microsoft.com/office/drawing/2017/decorative" val="1"/>
@@ -5292,12 +5387,12 @@
         </p:nvSpPr>
         <p:spPr>
           <a:xfrm>
-            <a:off x="457200" y="1133856"/>
-            <a:ext cx="2679192" cy="1417320"/>
+            <a:off x="457200" y="3291839"/>
+            <a:ext cx="2651760" cy="868680"/>
           </a:xfrm>
           <a:prstGeom prst="roundRect">
             <a:avLst>
-              <a:gd name="adj" fmla="val 5161"/>
+              <a:gd name="adj" fmla="val 8421"/>
             </a:avLst>
           </a:prstGeom>
           <a:solidFill>
@@ -5332,7 +5427,93 @@
       </p:sp>
       <p:sp>
         <p:nvSpPr>
-          <p:cNvPr id="5" name="Oval 4">
+          <p:cNvPr id="6" name="TextBox 5"/>
+          <p:cNvSpPr txBox="1"/>
+          <p:nvPr/>
+        </p:nvSpPr>
+        <p:spPr>
+          <a:xfrm>
+            <a:off x="585216" y="3364991"/>
+            <a:ext cx="2432304" cy="384048"/>
+          </a:xfrm>
+          <a:prstGeom prst="rect">
+            <a:avLst/>
+          </a:prstGeom>
+          <a:noFill/>
+        </p:spPr>
+        <p:txBody>
+          <a:bodyPr wrap="square" lIns="0" tIns="0" rIns="0" bIns="0" anchor="ctr">
+            <a:noAutofit/>
+          </a:bodyPr>
+          <a:lstStyle/>
+          <a:p>
+            <a:pPr algn="l"/>
+            <a:r>
+              <a:rPr sz="2000" b="1" i="0">
+                <a:solidFill>
+                  <a:srgbClr val="003865"/>
+                </a:solidFill>
+                <a:latin typeface="Arial"/>
+              </a:rPr>
+              <a:t>2.33× vs 2.44×</a:t>
+            </a:r>
+          </a:p>
+        </p:txBody>
+      </p:sp>
+      <p:sp>
+        <p:nvSpPr>
+          <p:cNvPr id="7" name="TextBox 6"/>
+          <p:cNvSpPr txBox="1"/>
+          <p:nvPr/>
+        </p:nvSpPr>
+        <p:spPr>
+          <a:xfrm>
+            <a:off x="585216" y="3749039"/>
+            <a:ext cx="2432304" cy="356615"/>
+          </a:xfrm>
+          <a:prstGeom prst="rect">
+            <a:avLst/>
+          </a:prstGeom>
+          <a:noFill/>
+        </p:spPr>
+        <p:txBody>
+          <a:bodyPr wrap="square" lIns="0" tIns="0" rIns="0" bIns="0" anchor="t">
+            <a:noAutofit/>
+          </a:bodyPr>
+          <a:lstStyle/>
+          <a:p>
+            <a:pPr algn="l">
+              <a:spcAft>
+                <a:spcPts val="200"/>
+              </a:spcAft>
+            </a:pPr>
+            <a:r>
+              <a:rPr sz="850" b="0" i="0">
+                <a:solidFill>
+                  <a:srgbClr val="1F2933"/>
+                </a:solidFill>
+                <a:latin typeface="Arial"/>
+              </a:rPr>
+              <a:t>AWQ-INT4 decode speedup at B=1</a:t>
+            </a:r>
+          </a:p>
+          <a:p>
+            <a:pPr algn="l"/>
+            <a:r>
+              <a:rPr sz="750" b="0" i="0">
+                <a:solidFill>
+                  <a:srgbClr val="5B6770"/>
+                </a:solidFill>
+                <a:latin typeface="Arial"/>
+              </a:rPr>
+              <a:t>Qwen3-8B vs Qwen2.5-7B; FP8 1.54× vs 1.59×</a:t>
+            </a:r>
+          </a:p>
+        </p:txBody>
+      </p:sp>
+      <p:sp>
+        <p:nvSpPr>
+          <p:cNvPr id="8" name="Rounded Rectangle 7">
             <a:extLst>
               <a:ext uri="{C183D7F6-B498-43B3-948B-1728B52AA6E4}">
                 <adec:decorative xmlns:adec="http://schemas.microsoft.com/office/drawing/2017/decorative" val="1"/>
@@ -5344,14 +5525,16 @@
         </p:nvSpPr>
         <p:spPr>
           <a:xfrm>
-            <a:off x="566928" y="1261872"/>
-            <a:ext cx="329184" cy="329184"/>
-          </a:xfrm>
-          <a:prstGeom prst="ellipse">
-            <a:avLst/>
+            <a:off x="3246120" y="3291839"/>
+            <a:ext cx="2651760" cy="868680"/>
+          </a:xfrm>
+          <a:prstGeom prst="roundRect">
+            <a:avLst>
+              <a:gd name="adj" fmla="val 8421"/>
+            </a:avLst>
           </a:prstGeom>
           <a:solidFill>
-            <a:srgbClr val="0064B1"/>
+            <a:srgbClr val="EDF3F9"/>
           </a:solidFill>
           <a:ln>
             <a:noFill/>
@@ -5380,46 +5563,16 @@
           </a:p>
         </p:txBody>
       </p:sp>
-      <p:pic>
-        <p:nvPicPr>
-          <p:cNvPr id="6" name="Picture 5" descr="">
-            <a:extLst>
-              <a:ext uri="{C183D7F6-B498-43B3-948B-1728B52AA6E4}">
-                <adec:decorative xmlns:adec="http://schemas.microsoft.com/office/drawing/2017/decorative" val="1"/>
-              </a:ext>
-            </a:extLst>
-          </p:cNvPr>
-          <p:cNvPicPr>
-            <a:picLocks noChangeAspect="1"/>
-          </p:cNvPicPr>
-          <p:nvPr/>
-        </p:nvPicPr>
-        <p:blipFill>
-          <a:blip r:embed="rId3"/>
-          <a:stretch>
-            <a:fillRect/>
-          </a:stretch>
-        </p:blipFill>
-        <p:spPr>
-          <a:xfrm>
-            <a:off x="639348" y="1334292"/>
-            <a:ext cx="184343" cy="184343"/>
-          </a:xfrm>
-          <a:prstGeom prst="rect">
-            <a:avLst/>
-          </a:prstGeom>
-        </p:spPr>
-      </p:pic>
-      <p:sp>
-        <p:nvSpPr>
-          <p:cNvPr id="7" name="TextBox 6"/>
+      <p:sp>
+        <p:nvSpPr>
+          <p:cNvPr id="9" name="TextBox 8"/>
           <p:cNvSpPr txBox="1"/>
           <p:nvPr/>
         </p:nvSpPr>
         <p:spPr>
           <a:xfrm>
-            <a:off x="969264" y="1225296"/>
-            <a:ext cx="2093976" cy="402336"/>
+            <a:off x="3374136" y="3364991"/>
+            <a:ext cx="2432304" cy="384048"/>
           </a:xfrm>
           <a:prstGeom prst="rect">
             <a:avLst/>
@@ -5434,27 +5587,27 @@
           <a:p>
             <a:pPr algn="l"/>
             <a:r>
-              <a:rPr sz="1050" b="1" i="0">
+              <a:rPr sz="2000" b="1" i="0">
                 <a:solidFill>
                   <a:srgbClr val="003865"/>
                 </a:solidFill>
                 <a:latin typeface="Arial"/>
               </a:rPr>
-              <a:t>Plan memory with the real ratio</a:t>
-            </a:r>
-          </a:p>
-        </p:txBody>
-      </p:sp>
-      <p:sp>
-        <p:nvSpPr>
-          <p:cNvPr id="8" name="TextBox 7"/>
+              <a:t>0.90×</a:t>
+            </a:r>
+          </a:p>
+        </p:txBody>
+      </p:sp>
+      <p:sp>
+        <p:nvSpPr>
+          <p:cNvPr id="10" name="TextBox 9"/>
           <p:cNvSpPr txBox="1"/>
           <p:nvPr/>
         </p:nvSpPr>
         <p:spPr>
           <a:xfrm>
-            <a:off x="585216" y="1682495"/>
-            <a:ext cx="914400" cy="731520"/>
+            <a:off x="3374136" y="3749039"/>
+            <a:ext cx="2432304" cy="356615"/>
           </a:xfrm>
           <a:prstGeom prst="rect">
             <a:avLst/>
@@ -5462,62 +5615,43 @@
           <a:noFill/>
         </p:spPr>
         <p:txBody>
-          <a:bodyPr wrap="square" lIns="0" tIns="0" rIns="0" bIns="0" anchor="ctr">
+          <a:bodyPr wrap="square" lIns="0" tIns="0" rIns="0" bIns="0" anchor="t">
             <a:noAutofit/>
           </a:bodyPr>
           <a:lstStyle/>
           <a:p>
-            <a:pPr algn="l"/>
-            <a:r>
-              <a:rPr sz="1900" b="1" i="0">
-                <a:solidFill>
-                  <a:srgbClr val="00599B"/>
+            <a:pPr algn="l">
+              <a:spcAft>
+                <a:spcPts val="200"/>
+              </a:spcAft>
+            </a:pPr>
+            <a:r>
+              <a:rPr sz="850" b="0" i="0">
+                <a:solidFill>
+                  <a:srgbClr val="1F2933"/>
                 </a:solidFill>
                 <a:latin typeface="Arial"/>
               </a:rPr>
-              <a:t>2.6×</a:t>
-            </a:r>
-          </a:p>
-        </p:txBody>
-      </p:sp>
-      <p:sp>
-        <p:nvSpPr>
-          <p:cNvPr id="9" name="TextBox 8"/>
-          <p:cNvSpPr txBox="1"/>
-          <p:nvPr/>
-        </p:nvSpPr>
-        <p:spPr>
-          <a:xfrm>
-            <a:off x="1499616" y="1645920"/>
-            <a:ext cx="1545336" cy="850392"/>
-          </a:xfrm>
-          <a:prstGeom prst="rect">
-            <a:avLst/>
-          </a:prstGeom>
-          <a:noFill/>
-        </p:spPr>
-        <p:txBody>
-          <a:bodyPr wrap="square" lIns="0" tIns="0" rIns="0" bIns="0" anchor="ctr">
-            <a:noAutofit/>
-          </a:bodyPr>
-          <a:lstStyle/>
+              <a:t>NF4 at B=1 on Qwen3-8B</a:t>
+            </a:r>
+          </a:p>
           <a:p>
             <a:pPr algn="l"/>
             <a:r>
-              <a:rPr sz="850" b="0" i="0">
-                <a:solidFill>
-                  <a:srgbClr val="1F2933"/>
+              <a:rPr sz="750" b="0" i="0">
+                <a:solidFill>
+                  <a:srgbClr val="5B6770"/>
                 </a:solidFill>
                 <a:latin typeface="Arial"/>
               </a:rPr>
-              <a:t>4-bit weight saving on Qwen2.5-7B, not 4×; KV cache and activations stay 16-bit</a:t>
-            </a:r>
-          </a:p>
-        </p:txBody>
-      </p:sp>
-      <p:sp>
-        <p:nvSpPr>
-          <p:cNvPr id="10" name="Rounded Rectangle 9">
+              <a:t>36 layers → host-bound, as on Qwen2.5-3B</a:t>
+            </a:r>
+          </a:p>
+        </p:txBody>
+      </p:sp>
+      <p:sp>
+        <p:nvSpPr>
+          <p:cNvPr id="11" name="Rounded Rectangle 10">
             <a:extLst>
               <a:ext uri="{C183D7F6-B498-43B3-948B-1728B52AA6E4}">
                 <adec:decorative xmlns:adec="http://schemas.microsoft.com/office/drawing/2017/decorative" val="1"/>
@@ -5529,12 +5663,12 @@
         </p:nvSpPr>
         <p:spPr>
           <a:xfrm>
-            <a:off x="3255264" y="1133856"/>
-            <a:ext cx="2679192" cy="1417320"/>
+            <a:off x="6035040" y="3291839"/>
+            <a:ext cx="2651760" cy="868680"/>
           </a:xfrm>
           <a:prstGeom prst="roundRect">
             <a:avLst>
-              <a:gd name="adj" fmla="val 5161"/>
+              <a:gd name="adj" fmla="val 8421"/>
             </a:avLst>
           </a:prstGeom>
           <a:solidFill>
@@ -5569,94 +5703,14 @@
       </p:sp>
       <p:sp>
         <p:nvSpPr>
-          <p:cNvPr id="11" name="Oval 10">
-            <a:extLst>
-              <a:ext uri="{C183D7F6-B498-43B3-948B-1728B52AA6E4}">
-                <adec:decorative xmlns:adec="http://schemas.microsoft.com/office/drawing/2017/decorative" val="1"/>
-              </a:ext>
-            </a:extLst>
-          </p:cNvPr>
-          <p:cNvSpPr/>
-          <p:nvPr/>
-        </p:nvSpPr>
-        <p:spPr>
-          <a:xfrm>
-            <a:off x="3364991" y="1261872"/>
-            <a:ext cx="329184" cy="329184"/>
-          </a:xfrm>
-          <a:prstGeom prst="ellipse">
-            <a:avLst/>
-          </a:prstGeom>
-          <a:solidFill>
-            <a:srgbClr val="0064B1"/>
-          </a:solidFill>
-          <a:ln>
-            <a:noFill/>
-          </a:ln>
-          <a:effectLst/>
-        </p:spPr>
-        <p:style>
-          <a:lnRef idx="1">
-            <a:schemeClr val="accent1"/>
-          </a:lnRef>
-          <a:fillRef idx="3">
-            <a:schemeClr val="accent1"/>
-          </a:fillRef>
-          <a:effectRef idx="2">
-            <a:schemeClr val="accent1"/>
-          </a:effectRef>
-          <a:fontRef idx="minor">
-            <a:schemeClr val="lt1"/>
-          </a:fontRef>
-        </p:style>
-        <p:txBody>
-          <a:bodyPr rtlCol="0" anchor="ctr"/>
-          <a:lstStyle/>
-          <a:p>
-            <a:pPr algn="ctr"/>
-          </a:p>
-        </p:txBody>
-      </p:sp>
-      <p:pic>
-        <p:nvPicPr>
-          <p:cNvPr id="12" name="Picture 11" descr="">
-            <a:extLst>
-              <a:ext uri="{C183D7F6-B498-43B3-948B-1728B52AA6E4}">
-                <adec:decorative xmlns:adec="http://schemas.microsoft.com/office/drawing/2017/decorative" val="1"/>
-              </a:ext>
-            </a:extLst>
-          </p:cNvPr>
-          <p:cNvPicPr>
-            <a:picLocks noChangeAspect="1"/>
-          </p:cNvPicPr>
-          <p:nvPr/>
-        </p:nvPicPr>
-        <p:blipFill>
-          <a:blip r:embed="rId4"/>
-          <a:stretch>
-            <a:fillRect/>
-          </a:stretch>
-        </p:blipFill>
-        <p:spPr>
-          <a:xfrm>
-            <a:off x="3437412" y="1334292"/>
-            <a:ext cx="184343" cy="184343"/>
-          </a:xfrm>
-          <a:prstGeom prst="rect">
-            <a:avLst/>
-          </a:prstGeom>
-        </p:spPr>
-      </p:pic>
-      <p:sp>
-        <p:nvSpPr>
-          <p:cNvPr id="13" name="TextBox 12"/>
+          <p:cNvPr id="12" name="TextBox 11"/>
           <p:cNvSpPr txBox="1"/>
           <p:nvPr/>
         </p:nvSpPr>
         <p:spPr>
           <a:xfrm>
-            <a:off x="3767328" y="1225296"/>
-            <a:ext cx="2093976" cy="402336"/>
+            <a:off x="6163055" y="3364991"/>
+            <a:ext cx="2432304" cy="384048"/>
           </a:xfrm>
           <a:prstGeom prst="rect">
             <a:avLst/>
@@ -5671,27 +5725,27 @@
           <a:p>
             <a:pPr algn="l"/>
             <a:r>
-              <a:rPr sz="1050" b="1" i="0">
+              <a:rPr sz="2000" b="1" i="0">
                 <a:solidFill>
                   <a:srgbClr val="003865"/>
                 </a:solidFill>
                 <a:latin typeface="Arial"/>
               </a:rPr>
-              <a:t>Few users: 4-bit + fused kernel</a:t>
-            </a:r>
-          </a:p>
-        </p:txBody>
-      </p:sp>
-      <p:sp>
-        <p:nvSpPr>
-          <p:cNvPr id="14" name="TextBox 13"/>
+              <a:t>2.6×</a:t>
+            </a:r>
+          </a:p>
+        </p:txBody>
+      </p:sp>
+      <p:sp>
+        <p:nvSpPr>
+          <p:cNvPr id="13" name="TextBox 12"/>
           <p:cNvSpPr txBox="1"/>
           <p:nvPr/>
         </p:nvSpPr>
         <p:spPr>
           <a:xfrm>
-            <a:off x="3383280" y="1682495"/>
-            <a:ext cx="914400" cy="731520"/>
+            <a:off x="6163055" y="3749039"/>
+            <a:ext cx="2432304" cy="356615"/>
           </a:xfrm>
           <a:prstGeom prst="rect">
             <a:avLst/>
@@ -5699,1003 +5753,36 @@
           <a:noFill/>
         </p:spPr>
         <p:txBody>
-          <a:bodyPr wrap="square" lIns="0" tIns="0" rIns="0" bIns="0" anchor="ctr">
+          <a:bodyPr wrap="square" lIns="0" tIns="0" rIns="0" bIns="0" anchor="t">
             <a:noAutofit/>
           </a:bodyPr>
           <a:lstStyle/>
           <a:p>
-            <a:pPr algn="l"/>
-            <a:r>
-              <a:rPr sz="1900" b="1" i="0">
-                <a:solidFill>
-                  <a:srgbClr val="00599B"/>
+            <a:pPr algn="l">
+              <a:spcAft>
+                <a:spcPts val="200"/>
+              </a:spcAft>
+            </a:pPr>
+            <a:r>
+              <a:rPr sz="850" b="0" i="0">
+                <a:solidFill>
+                  <a:srgbClr val="1F2933"/>
                 </a:solidFill>
                 <a:latin typeface="Arial"/>
               </a:rPr>
-              <a:t>2.4×</a:t>
-            </a:r>
-          </a:p>
-        </p:txBody>
-      </p:sp>
-      <p:sp>
-        <p:nvSpPr>
-          <p:cNvPr id="15" name="TextBox 14"/>
-          <p:cNvSpPr txBox="1"/>
-          <p:nvPr/>
-        </p:nvSpPr>
-        <p:spPr>
-          <a:xfrm>
-            <a:off x="4297680" y="1645920"/>
-            <a:ext cx="1545336" cy="850392"/>
-          </a:xfrm>
-          <a:prstGeom prst="rect">
-            <a:avLst/>
-          </a:prstGeom>
-          <a:noFill/>
-        </p:spPr>
-        <p:txBody>
-          <a:bodyPr wrap="square" lIns="0" tIns="0" rIns="0" bIns="0" anchor="ctr">
-            <a:noAutofit/>
-          </a:bodyPr>
-          <a:lstStyle/>
+              <a:t>KV-cache bytes per token vs Qwen2.5-7B</a:t>
+            </a:r>
+          </a:p>
           <a:p>
             <a:pPr algn="l"/>
             <a:r>
-              <a:rPr sz="850" b="0" i="0">
-                <a:solidFill>
-                  <a:srgbClr val="1F2933"/>
+              <a:rPr sz="750" b="0" i="0">
+                <a:solidFill>
+                  <a:srgbClr val="5B6770"/>
                 </a:solidFill>
                 <a:latin typeface="Arial"/>
               </a:rPr>
-              <a:t>faster decode with AWQ-INT4 + Marlin at batch size 1</a:t>
-            </a:r>
-          </a:p>
-        </p:txBody>
-      </p:sp>
-      <p:sp>
-        <p:nvSpPr>
-          <p:cNvPr id="16" name="Rounded Rectangle 15">
-            <a:extLst>
-              <a:ext uri="{C183D7F6-B498-43B3-948B-1728B52AA6E4}">
-                <adec:decorative xmlns:adec="http://schemas.microsoft.com/office/drawing/2017/decorative" val="1"/>
-              </a:ext>
-            </a:extLst>
-          </p:cNvPr>
-          <p:cNvSpPr/>
-          <p:nvPr/>
-        </p:nvSpPr>
-        <p:spPr>
-          <a:xfrm>
-            <a:off x="6053328" y="1133856"/>
-            <a:ext cx="2679192" cy="1417320"/>
-          </a:xfrm>
-          <a:prstGeom prst="roundRect">
-            <a:avLst>
-              <a:gd name="adj" fmla="val 5161"/>
-            </a:avLst>
-          </a:prstGeom>
-          <a:solidFill>
-            <a:srgbClr val="EDF3F9"/>
-          </a:solidFill>
-          <a:ln>
-            <a:noFill/>
-          </a:ln>
-          <a:effectLst/>
-        </p:spPr>
-        <p:style>
-          <a:lnRef idx="1">
-            <a:schemeClr val="accent1"/>
-          </a:lnRef>
-          <a:fillRef idx="3">
-            <a:schemeClr val="accent1"/>
-          </a:fillRef>
-          <a:effectRef idx="2">
-            <a:schemeClr val="accent1"/>
-          </a:effectRef>
-          <a:fontRef idx="minor">
-            <a:schemeClr val="lt1"/>
-          </a:fontRef>
-        </p:style>
-        <p:txBody>
-          <a:bodyPr rtlCol="0" anchor="ctr"/>
-          <a:lstStyle/>
-          <a:p>
-            <a:pPr algn="ctr"/>
-          </a:p>
-        </p:txBody>
-      </p:sp>
-      <p:sp>
-        <p:nvSpPr>
-          <p:cNvPr id="17" name="Oval 16">
-            <a:extLst>
-              <a:ext uri="{C183D7F6-B498-43B3-948B-1728B52AA6E4}">
-                <adec:decorative xmlns:adec="http://schemas.microsoft.com/office/drawing/2017/decorative" val="1"/>
-              </a:ext>
-            </a:extLst>
-          </p:cNvPr>
-          <p:cNvSpPr/>
-          <p:nvPr/>
-        </p:nvSpPr>
-        <p:spPr>
-          <a:xfrm>
-            <a:off x="6163056" y="1261872"/>
-            <a:ext cx="329184" cy="329184"/>
-          </a:xfrm>
-          <a:prstGeom prst="ellipse">
-            <a:avLst/>
-          </a:prstGeom>
-          <a:solidFill>
-            <a:srgbClr val="0064B1"/>
-          </a:solidFill>
-          <a:ln>
-            <a:noFill/>
-          </a:ln>
-          <a:effectLst/>
-        </p:spPr>
-        <p:style>
-          <a:lnRef idx="1">
-            <a:schemeClr val="accent1"/>
-          </a:lnRef>
-          <a:fillRef idx="3">
-            <a:schemeClr val="accent1"/>
-          </a:fillRef>
-          <a:effectRef idx="2">
-            <a:schemeClr val="accent1"/>
-          </a:effectRef>
-          <a:fontRef idx="minor">
-            <a:schemeClr val="lt1"/>
-          </a:fontRef>
-        </p:style>
-        <p:txBody>
-          <a:bodyPr rtlCol="0" anchor="ctr"/>
-          <a:lstStyle/>
-          <a:p>
-            <a:pPr algn="ctr"/>
-          </a:p>
-        </p:txBody>
-      </p:sp>
-      <p:pic>
-        <p:nvPicPr>
-          <p:cNvPr id="18" name="Picture 17" descr="">
-            <a:extLst>
-              <a:ext uri="{C183D7F6-B498-43B3-948B-1728B52AA6E4}">
-                <adec:decorative xmlns:adec="http://schemas.microsoft.com/office/drawing/2017/decorative" val="1"/>
-              </a:ext>
-            </a:extLst>
-          </p:cNvPr>
-          <p:cNvPicPr>
-            <a:picLocks noChangeAspect="1"/>
-          </p:cNvPicPr>
-          <p:nvPr/>
-        </p:nvPicPr>
-        <p:blipFill>
-          <a:blip r:embed="rId5"/>
-          <a:stretch>
-            <a:fillRect/>
-          </a:stretch>
-        </p:blipFill>
-        <p:spPr>
-          <a:xfrm>
-            <a:off x="6235476" y="1334292"/>
-            <a:ext cx="184343" cy="184343"/>
-          </a:xfrm>
-          <a:prstGeom prst="rect">
-            <a:avLst/>
-          </a:prstGeom>
-        </p:spPr>
-      </p:pic>
-      <p:sp>
-        <p:nvSpPr>
-          <p:cNvPr id="19" name="TextBox 18"/>
-          <p:cNvSpPr txBox="1"/>
-          <p:nvPr/>
-        </p:nvSpPr>
-        <p:spPr>
-          <a:xfrm>
-            <a:off x="6565392" y="1225296"/>
-            <a:ext cx="2093976" cy="402336"/>
-          </a:xfrm>
-          <a:prstGeom prst="rect">
-            <a:avLst/>
-          </a:prstGeom>
-          <a:noFill/>
-        </p:spPr>
-        <p:txBody>
-          <a:bodyPr wrap="square" lIns="0" tIns="0" rIns="0" bIns="0" anchor="ctr">
-            <a:noAutofit/>
-          </a:bodyPr>
-          <a:lstStyle/>
-          <a:p>
-            <a:pPr algn="l"/>
-            <a:r>
-              <a:rPr sz="1050" b="1" i="0">
-                <a:solidFill>
-                  <a:srgbClr val="003865"/>
-                </a:solidFill>
-                <a:latin typeface="Arial"/>
-              </a:rPr>
-              <a:t>High throughput: FP8 W8A8</a:t>
-            </a:r>
-          </a:p>
-        </p:txBody>
-      </p:sp>
-      <p:sp>
-        <p:nvSpPr>
-          <p:cNvPr id="20" name="TextBox 19"/>
-          <p:cNvSpPr txBox="1"/>
-          <p:nvPr/>
-        </p:nvSpPr>
-        <p:spPr>
-          <a:xfrm>
-            <a:off x="6181344" y="1682495"/>
-            <a:ext cx="914400" cy="731520"/>
-          </a:xfrm>
-          <a:prstGeom prst="rect">
-            <a:avLst/>
-          </a:prstGeom>
-          <a:noFill/>
-        </p:spPr>
-        <p:txBody>
-          <a:bodyPr wrap="square" lIns="0" tIns="0" rIns="0" bIns="0" anchor="ctr">
-            <a:noAutofit/>
-          </a:bodyPr>
-          <a:lstStyle/>
-          <a:p>
-            <a:pPr algn="l"/>
-            <a:r>
-              <a:rPr sz="1900" b="1" i="0">
-                <a:solidFill>
-                  <a:srgbClr val="00599B"/>
-                </a:solidFill>
-                <a:latin typeface="Arial"/>
-              </a:rPr>
-              <a:t>1.7×</a:t>
-            </a:r>
-          </a:p>
-        </p:txBody>
-      </p:sp>
-      <p:sp>
-        <p:nvSpPr>
-          <p:cNvPr id="21" name="TextBox 20"/>
-          <p:cNvSpPr txBox="1"/>
-          <p:nvPr/>
-        </p:nvSpPr>
-        <p:spPr>
-          <a:xfrm>
-            <a:off x="7095744" y="1645920"/>
-            <a:ext cx="1545336" cy="850392"/>
-          </a:xfrm>
-          <a:prstGeom prst="rect">
-            <a:avLst/>
-          </a:prstGeom>
-          <a:noFill/>
-        </p:spPr>
-        <p:txBody>
-          <a:bodyPr wrap="square" lIns="0" tIns="0" rIns="0" bIns="0" anchor="ctr">
-            <a:noAutofit/>
-          </a:bodyPr>
-          <a:lstStyle/>
-          <a:p>
-            <a:pPr algn="l"/>
-            <a:r>
-              <a:rPr sz="850" b="0" i="0">
-                <a:solidFill>
-                  <a:srgbClr val="1F2933"/>
-                </a:solidFill>
-                <a:latin typeface="Arial"/>
-              </a:rPr>
-              <a:t>the BF16 throughput at batch 256, where 4-bit weight-only gains have vanished</a:t>
-            </a:r>
-          </a:p>
-        </p:txBody>
-      </p:sp>
-      <p:sp>
-        <p:nvSpPr>
-          <p:cNvPr id="22" name="Rounded Rectangle 21">
-            <a:extLst>
-              <a:ext uri="{C183D7F6-B498-43B3-948B-1728B52AA6E4}">
-                <adec:decorative xmlns:adec="http://schemas.microsoft.com/office/drawing/2017/decorative" val="1"/>
-              </a:ext>
-            </a:extLst>
-          </p:cNvPr>
-          <p:cNvSpPr/>
-          <p:nvPr/>
-        </p:nvSpPr>
-        <p:spPr>
-          <a:xfrm>
-            <a:off x="457200" y="2679191"/>
-            <a:ext cx="2679192" cy="1417320"/>
-          </a:xfrm>
-          <a:prstGeom prst="roundRect">
-            <a:avLst>
-              <a:gd name="adj" fmla="val 5161"/>
-            </a:avLst>
-          </a:prstGeom>
-          <a:solidFill>
-            <a:srgbClr val="EDF3F9"/>
-          </a:solidFill>
-          <a:ln>
-            <a:noFill/>
-          </a:ln>
-          <a:effectLst/>
-        </p:spPr>
-        <p:style>
-          <a:lnRef idx="1">
-            <a:schemeClr val="accent1"/>
-          </a:lnRef>
-          <a:fillRef idx="3">
-            <a:schemeClr val="accent1"/>
-          </a:fillRef>
-          <a:effectRef idx="2">
-            <a:schemeClr val="accent1"/>
-          </a:effectRef>
-          <a:fontRef idx="minor">
-            <a:schemeClr val="lt1"/>
-          </a:fontRef>
-        </p:style>
-        <p:txBody>
-          <a:bodyPr rtlCol="0" anchor="ctr"/>
-          <a:lstStyle/>
-          <a:p>
-            <a:pPr algn="ctr"/>
-          </a:p>
-        </p:txBody>
-      </p:sp>
-      <p:sp>
-        <p:nvSpPr>
-          <p:cNvPr id="23" name="Oval 22">
-            <a:extLst>
-              <a:ext uri="{C183D7F6-B498-43B3-948B-1728B52AA6E4}">
-                <adec:decorative xmlns:adec="http://schemas.microsoft.com/office/drawing/2017/decorative" val="1"/>
-              </a:ext>
-            </a:extLst>
-          </p:cNvPr>
-          <p:cNvSpPr/>
-          <p:nvPr/>
-        </p:nvSpPr>
-        <p:spPr>
-          <a:xfrm>
-            <a:off x="566928" y="2807207"/>
-            <a:ext cx="329184" cy="329184"/>
-          </a:xfrm>
-          <a:prstGeom prst="ellipse">
-            <a:avLst/>
-          </a:prstGeom>
-          <a:solidFill>
-            <a:srgbClr val="0064B1"/>
-          </a:solidFill>
-          <a:ln>
-            <a:noFill/>
-          </a:ln>
-          <a:effectLst/>
-        </p:spPr>
-        <p:style>
-          <a:lnRef idx="1">
-            <a:schemeClr val="accent1"/>
-          </a:lnRef>
-          <a:fillRef idx="3">
-            <a:schemeClr val="accent1"/>
-          </a:fillRef>
-          <a:effectRef idx="2">
-            <a:schemeClr val="accent1"/>
-          </a:effectRef>
-          <a:fontRef idx="minor">
-            <a:schemeClr val="lt1"/>
-          </a:fontRef>
-        </p:style>
-        <p:txBody>
-          <a:bodyPr rtlCol="0" anchor="ctr"/>
-          <a:lstStyle/>
-          <a:p>
-            <a:pPr algn="ctr"/>
-          </a:p>
-        </p:txBody>
-      </p:sp>
-      <p:pic>
-        <p:nvPicPr>
-          <p:cNvPr id="24" name="Picture 23" descr="">
-            <a:extLst>
-              <a:ext uri="{C183D7F6-B498-43B3-948B-1728B52AA6E4}">
-                <adec:decorative xmlns:adec="http://schemas.microsoft.com/office/drawing/2017/decorative" val="1"/>
-              </a:ext>
-            </a:extLst>
-          </p:cNvPr>
-          <p:cNvPicPr>
-            <a:picLocks noChangeAspect="1"/>
-          </p:cNvPicPr>
-          <p:nvPr/>
-        </p:nvPicPr>
-        <p:blipFill>
-          <a:blip r:embed="rId6"/>
-          <a:stretch>
-            <a:fillRect/>
-          </a:stretch>
-        </p:blipFill>
-        <p:spPr>
-          <a:xfrm>
-            <a:off x="639348" y="2879628"/>
-            <a:ext cx="184343" cy="184343"/>
-          </a:xfrm>
-          <a:prstGeom prst="rect">
-            <a:avLst/>
-          </a:prstGeom>
-        </p:spPr>
-      </p:pic>
-      <p:sp>
-        <p:nvSpPr>
-          <p:cNvPr id="25" name="TextBox 24"/>
-          <p:cNvSpPr txBox="1"/>
-          <p:nvPr/>
-        </p:nvSpPr>
-        <p:spPr>
-          <a:xfrm>
-            <a:off x="969264" y="2770632"/>
-            <a:ext cx="2093976" cy="402336"/>
-          </a:xfrm>
-          <a:prstGeom prst="rect">
-            <a:avLst/>
-          </a:prstGeom>
-          <a:noFill/>
-        </p:spPr>
-        <p:txBody>
-          <a:bodyPr wrap="square" lIns="0" tIns="0" rIns="0" bIns="0" anchor="ctr">
-            <a:noAutofit/>
-          </a:bodyPr>
-          <a:lstStyle/>
-          <a:p>
-            <a:pPr algn="l"/>
-            <a:r>
-              <a:rPr sz="1050" b="1" i="0">
-                <a:solidFill>
-                  <a:srgbClr val="003865"/>
-                </a:solidFill>
-                <a:latin typeface="Arial"/>
-              </a:rPr>
-              <a:t>bitsandbytes: memory, not speed</a:t>
-            </a:r>
-          </a:p>
-        </p:txBody>
-      </p:sp>
-      <p:sp>
-        <p:nvSpPr>
-          <p:cNvPr id="26" name="TextBox 25"/>
-          <p:cNvSpPr txBox="1"/>
-          <p:nvPr/>
-        </p:nvSpPr>
-        <p:spPr>
-          <a:xfrm>
-            <a:off x="585216" y="3227832"/>
-            <a:ext cx="914400" cy="731520"/>
-          </a:xfrm>
-          <a:prstGeom prst="rect">
-            <a:avLst/>
-          </a:prstGeom>
-          <a:noFill/>
-        </p:spPr>
-        <p:txBody>
-          <a:bodyPr wrap="square" lIns="0" tIns="0" rIns="0" bIns="0" anchor="ctr">
-            <a:noAutofit/>
-          </a:bodyPr>
-          <a:lstStyle/>
-          <a:p>
-            <a:pPr algn="l"/>
-            <a:r>
-              <a:rPr sz="1900" b="1" i="0">
-                <a:solidFill>
-                  <a:srgbClr val="00599B"/>
-                </a:solidFill>
-                <a:latin typeface="Arial"/>
-              </a:rPr>
-              <a:t>3.4×</a:t>
-            </a:r>
-          </a:p>
-        </p:txBody>
-      </p:sp>
-      <p:sp>
-        <p:nvSpPr>
-          <p:cNvPr id="27" name="TextBox 26"/>
-          <p:cNvSpPr txBox="1"/>
-          <p:nvPr/>
-        </p:nvSpPr>
-        <p:spPr>
-          <a:xfrm>
-            <a:off x="1499616" y="3191256"/>
-            <a:ext cx="1545336" cy="850392"/>
-          </a:xfrm>
-          <a:prstGeom prst="rect">
-            <a:avLst/>
-          </a:prstGeom>
-          <a:noFill/>
-        </p:spPr>
-        <p:txBody>
-          <a:bodyPr wrap="square" lIns="0" tIns="0" rIns="0" bIns="0" anchor="ctr">
-            <a:noAutofit/>
-          </a:bodyPr>
-          <a:lstStyle/>
-          <a:p>
-            <a:pPr algn="l"/>
-            <a:r>
-              <a:rPr sz="850" b="0" i="0">
-                <a:solidFill>
-                  <a:srgbClr val="1F2933"/>
-                </a:solidFill>
-                <a:latin typeface="Arial"/>
-              </a:rPr>
-              <a:t>slower decode with LLM.int8() at batch size 1; NF4 helps only tiny batches</a:t>
-            </a:r>
-          </a:p>
-        </p:txBody>
-      </p:sp>
-      <p:sp>
-        <p:nvSpPr>
-          <p:cNvPr id="28" name="Rounded Rectangle 27">
-            <a:extLst>
-              <a:ext uri="{C183D7F6-B498-43B3-948B-1728B52AA6E4}">
-                <adec:decorative xmlns:adec="http://schemas.microsoft.com/office/drawing/2017/decorative" val="1"/>
-              </a:ext>
-            </a:extLst>
-          </p:cNvPr>
-          <p:cNvSpPr/>
-          <p:nvPr/>
-        </p:nvSpPr>
-        <p:spPr>
-          <a:xfrm>
-            <a:off x="3255264" y="2679191"/>
-            <a:ext cx="2679192" cy="1417320"/>
-          </a:xfrm>
-          <a:prstGeom prst="roundRect">
-            <a:avLst>
-              <a:gd name="adj" fmla="val 5161"/>
-            </a:avLst>
-          </a:prstGeom>
-          <a:solidFill>
-            <a:srgbClr val="EDF3F9"/>
-          </a:solidFill>
-          <a:ln>
-            <a:noFill/>
-          </a:ln>
-          <a:effectLst/>
-        </p:spPr>
-        <p:style>
-          <a:lnRef idx="1">
-            <a:schemeClr val="accent1"/>
-          </a:lnRef>
-          <a:fillRef idx="3">
-            <a:schemeClr val="accent1"/>
-          </a:fillRef>
-          <a:effectRef idx="2">
-            <a:schemeClr val="accent1"/>
-          </a:effectRef>
-          <a:fontRef idx="minor">
-            <a:schemeClr val="lt1"/>
-          </a:fontRef>
-        </p:style>
-        <p:txBody>
-          <a:bodyPr rtlCol="0" anchor="ctr"/>
-          <a:lstStyle/>
-          <a:p>
-            <a:pPr algn="ctr"/>
-          </a:p>
-        </p:txBody>
-      </p:sp>
-      <p:sp>
-        <p:nvSpPr>
-          <p:cNvPr id="29" name="Oval 28">
-            <a:extLst>
-              <a:ext uri="{C183D7F6-B498-43B3-948B-1728B52AA6E4}">
-                <adec:decorative xmlns:adec="http://schemas.microsoft.com/office/drawing/2017/decorative" val="1"/>
-              </a:ext>
-            </a:extLst>
-          </p:cNvPr>
-          <p:cNvSpPr/>
-          <p:nvPr/>
-        </p:nvSpPr>
-        <p:spPr>
-          <a:xfrm>
-            <a:off x="3364991" y="2807207"/>
-            <a:ext cx="329184" cy="329184"/>
-          </a:xfrm>
-          <a:prstGeom prst="ellipse">
-            <a:avLst/>
-          </a:prstGeom>
-          <a:solidFill>
-            <a:srgbClr val="0064B1"/>
-          </a:solidFill>
-          <a:ln>
-            <a:noFill/>
-          </a:ln>
-          <a:effectLst/>
-        </p:spPr>
-        <p:style>
-          <a:lnRef idx="1">
-            <a:schemeClr val="accent1"/>
-          </a:lnRef>
-          <a:fillRef idx="3">
-            <a:schemeClr val="accent1"/>
-          </a:fillRef>
-          <a:effectRef idx="2">
-            <a:schemeClr val="accent1"/>
-          </a:effectRef>
-          <a:fontRef idx="minor">
-            <a:schemeClr val="lt1"/>
-          </a:fontRef>
-        </p:style>
-        <p:txBody>
-          <a:bodyPr rtlCol="0" anchor="ctr"/>
-          <a:lstStyle/>
-          <a:p>
-            <a:pPr algn="ctr"/>
-          </a:p>
-        </p:txBody>
-      </p:sp>
-      <p:pic>
-        <p:nvPicPr>
-          <p:cNvPr id="30" name="Picture 29" descr="">
-            <a:extLst>
-              <a:ext uri="{C183D7F6-B498-43B3-948B-1728B52AA6E4}">
-                <adec:decorative xmlns:adec="http://schemas.microsoft.com/office/drawing/2017/decorative" val="1"/>
-              </a:ext>
-            </a:extLst>
-          </p:cNvPr>
-          <p:cNvPicPr>
-            <a:picLocks noChangeAspect="1"/>
-          </p:cNvPicPr>
-          <p:nvPr/>
-        </p:nvPicPr>
-        <p:blipFill>
-          <a:blip r:embed="rId7"/>
-          <a:stretch>
-            <a:fillRect/>
-          </a:stretch>
-        </p:blipFill>
-        <p:spPr>
-          <a:xfrm>
-            <a:off x="3437412" y="2879628"/>
-            <a:ext cx="184343" cy="184343"/>
-          </a:xfrm>
-          <a:prstGeom prst="rect">
-            <a:avLst/>
-          </a:prstGeom>
-        </p:spPr>
-      </p:pic>
-      <p:sp>
-        <p:nvSpPr>
-          <p:cNvPr id="31" name="TextBox 30"/>
-          <p:cNvSpPr txBox="1"/>
-          <p:nvPr/>
-        </p:nvSpPr>
-        <p:spPr>
-          <a:xfrm>
-            <a:off x="3767328" y="2770632"/>
-            <a:ext cx="2093976" cy="402336"/>
-          </a:xfrm>
-          <a:prstGeom prst="rect">
-            <a:avLst/>
-          </a:prstGeom>
-          <a:noFill/>
-        </p:spPr>
-        <p:txBody>
-          <a:bodyPr wrap="square" lIns="0" tIns="0" rIns="0" bIns="0" anchor="ctr">
-            <a:noAutofit/>
-          </a:bodyPr>
-          <a:lstStyle/>
-          <a:p>
-            <a:pPr algn="l"/>
-            <a:r>
-              <a:rPr sz="1050" b="1" i="0">
-                <a:solidFill>
-                  <a:srgbClr val="003865"/>
-                </a:solidFill>
-                <a:latin typeface="Arial"/>
-              </a:rPr>
-              <a:t>Quality: 8-bit free, 4-bit not</a:t>
-            </a:r>
-          </a:p>
-        </p:txBody>
-      </p:sp>
-      <p:sp>
-        <p:nvSpPr>
-          <p:cNvPr id="32" name="TextBox 31"/>
-          <p:cNvSpPr txBox="1"/>
-          <p:nvPr/>
-        </p:nvSpPr>
-        <p:spPr>
-          <a:xfrm>
-            <a:off x="3383280" y="3227832"/>
-            <a:ext cx="914400" cy="731520"/>
-          </a:xfrm>
-          <a:prstGeom prst="rect">
-            <a:avLst/>
-          </a:prstGeom>
-          <a:noFill/>
-        </p:spPr>
-        <p:txBody>
-          <a:bodyPr wrap="square" lIns="0" tIns="0" rIns="0" bIns="0" anchor="ctr">
-            <a:noAutofit/>
-          </a:bodyPr>
-          <a:lstStyle/>
-          <a:p>
-            <a:pPr algn="l"/>
-            <a:r>
-              <a:rPr sz="1900" b="1" i="0">
-                <a:solidFill>
-                  <a:srgbClr val="00599B"/>
-                </a:solidFill>
-                <a:latin typeface="Arial"/>
-              </a:rPr>
-              <a:t>−2.8 pp</a:t>
-            </a:r>
-          </a:p>
-        </p:txBody>
-      </p:sp>
-      <p:sp>
-        <p:nvSpPr>
-          <p:cNvPr id="33" name="TextBox 32"/>
-          <p:cNvSpPr txBox="1"/>
-          <p:nvPr/>
-        </p:nvSpPr>
-        <p:spPr>
-          <a:xfrm>
-            <a:off x="4297680" y="3191256"/>
-            <a:ext cx="1545336" cy="850392"/>
-          </a:xfrm>
-          <a:prstGeom prst="rect">
-            <a:avLst/>
-          </a:prstGeom>
-          <a:noFill/>
-        </p:spPr>
-        <p:txBody>
-          <a:bodyPr wrap="square" lIns="0" tIns="0" rIns="0" bIns="0" anchor="ctr">
-            <a:noAutofit/>
-          </a:bodyPr>
-          <a:lstStyle/>
-          <a:p>
-            <a:pPr algn="l"/>
-            <a:r>
-              <a:rPr sz="850" b="0" i="0">
-                <a:solidFill>
-                  <a:srgbClr val="1F2933"/>
-                </a:solidFill>
-                <a:latin typeface="Arial"/>
-              </a:rPr>
-              <a:t>worst MMLU pp with 4-bit (3B); GPTQ-INT8 / FP8 within 0.9 pp everywhere</a:t>
-            </a:r>
-          </a:p>
-        </p:txBody>
-      </p:sp>
-      <p:sp>
-        <p:nvSpPr>
-          <p:cNvPr id="34" name="Rounded Rectangle 33">
-            <a:extLst>
-              <a:ext uri="{C183D7F6-B498-43B3-948B-1728B52AA6E4}">
-                <adec:decorative xmlns:adec="http://schemas.microsoft.com/office/drawing/2017/decorative" val="1"/>
-              </a:ext>
-            </a:extLst>
-          </p:cNvPr>
-          <p:cNvSpPr/>
-          <p:nvPr/>
-        </p:nvSpPr>
-        <p:spPr>
-          <a:xfrm>
-            <a:off x="6053328" y="2679191"/>
-            <a:ext cx="2679192" cy="1417320"/>
-          </a:xfrm>
-          <a:prstGeom prst="roundRect">
-            <a:avLst>
-              <a:gd name="adj" fmla="val 5161"/>
-            </a:avLst>
-          </a:prstGeom>
-          <a:solidFill>
-            <a:srgbClr val="EDF3F9"/>
-          </a:solidFill>
-          <a:ln>
-            <a:noFill/>
-          </a:ln>
-          <a:effectLst/>
-        </p:spPr>
-        <p:style>
-          <a:lnRef idx="1">
-            <a:schemeClr val="accent1"/>
-          </a:lnRef>
-          <a:fillRef idx="3">
-            <a:schemeClr val="accent1"/>
-          </a:fillRef>
-          <a:effectRef idx="2">
-            <a:schemeClr val="accent1"/>
-          </a:effectRef>
-          <a:fontRef idx="minor">
-            <a:schemeClr val="lt1"/>
-          </a:fontRef>
-        </p:style>
-        <p:txBody>
-          <a:bodyPr rtlCol="0" anchor="ctr"/>
-          <a:lstStyle/>
-          <a:p>
-            <a:pPr algn="ctr"/>
-          </a:p>
-        </p:txBody>
-      </p:sp>
-      <p:sp>
-        <p:nvSpPr>
-          <p:cNvPr id="35" name="Oval 34">
-            <a:extLst>
-              <a:ext uri="{C183D7F6-B498-43B3-948B-1728B52AA6E4}">
-                <adec:decorative xmlns:adec="http://schemas.microsoft.com/office/drawing/2017/decorative" val="1"/>
-              </a:ext>
-            </a:extLst>
-          </p:cNvPr>
-          <p:cNvSpPr/>
-          <p:nvPr/>
-        </p:nvSpPr>
-        <p:spPr>
-          <a:xfrm>
-            <a:off x="6163056" y="2807207"/>
-            <a:ext cx="329184" cy="329184"/>
-          </a:xfrm>
-          <a:prstGeom prst="ellipse">
-            <a:avLst/>
-          </a:prstGeom>
-          <a:solidFill>
-            <a:srgbClr val="0064B1"/>
-          </a:solidFill>
-          <a:ln>
-            <a:noFill/>
-          </a:ln>
-          <a:effectLst/>
-        </p:spPr>
-        <p:style>
-          <a:lnRef idx="1">
-            <a:schemeClr val="accent1"/>
-          </a:lnRef>
-          <a:fillRef idx="3">
-            <a:schemeClr val="accent1"/>
-          </a:fillRef>
-          <a:effectRef idx="2">
-            <a:schemeClr val="accent1"/>
-          </a:effectRef>
-          <a:fontRef idx="minor">
-            <a:schemeClr val="lt1"/>
-          </a:fontRef>
-        </p:style>
-        <p:txBody>
-          <a:bodyPr rtlCol="0" anchor="ctr"/>
-          <a:lstStyle/>
-          <a:p>
-            <a:pPr algn="ctr"/>
-          </a:p>
-        </p:txBody>
-      </p:sp>
-      <p:pic>
-        <p:nvPicPr>
-          <p:cNvPr id="36" name="Picture 35" descr="">
-            <a:extLst>
-              <a:ext uri="{C183D7F6-B498-43B3-948B-1728B52AA6E4}">
-                <adec:decorative xmlns:adec="http://schemas.microsoft.com/office/drawing/2017/decorative" val="1"/>
-              </a:ext>
-            </a:extLst>
-          </p:cNvPr>
-          <p:cNvPicPr>
-            <a:picLocks noChangeAspect="1"/>
-          </p:cNvPicPr>
-          <p:nvPr/>
-        </p:nvPicPr>
-        <p:blipFill>
-          <a:blip r:embed="rId8"/>
-          <a:stretch>
-            <a:fillRect/>
-          </a:stretch>
-        </p:blipFill>
-        <p:spPr>
-          <a:xfrm>
-            <a:off x="6235476" y="2879628"/>
-            <a:ext cx="184343" cy="184343"/>
-          </a:xfrm>
-          <a:prstGeom prst="rect">
-            <a:avLst/>
-          </a:prstGeom>
-        </p:spPr>
-      </p:pic>
-      <p:sp>
-        <p:nvSpPr>
-          <p:cNvPr id="37" name="TextBox 36"/>
-          <p:cNvSpPr txBox="1"/>
-          <p:nvPr/>
-        </p:nvSpPr>
-        <p:spPr>
-          <a:xfrm>
-            <a:off x="6565392" y="2770632"/>
-            <a:ext cx="2093976" cy="402336"/>
-          </a:xfrm>
-          <a:prstGeom prst="rect">
-            <a:avLst/>
-          </a:prstGeom>
-          <a:noFill/>
-        </p:spPr>
-        <p:txBody>
-          <a:bodyPr wrap="square" lIns="0" tIns="0" rIns="0" bIns="0" anchor="ctr">
-            <a:noAutofit/>
-          </a:bodyPr>
-          <a:lstStyle/>
-          <a:p>
-            <a:pPr algn="l"/>
-            <a:r>
-              <a:rPr sz="1050" b="1" i="0">
-                <a:solidFill>
-                  <a:srgbClr val="003865"/>
-                </a:solidFill>
-                <a:latin typeface="Arial"/>
-              </a:rPr>
-              <a:t>Spend memory on parameters</a:t>
-            </a:r>
-          </a:p>
-        </p:txBody>
-      </p:sp>
-      <p:sp>
-        <p:nvSpPr>
-          <p:cNvPr id="38" name="TextBox 37"/>
-          <p:cNvSpPr txBox="1"/>
-          <p:nvPr/>
-        </p:nvSpPr>
-        <p:spPr>
-          <a:xfrm>
-            <a:off x="6181344" y="3227832"/>
-            <a:ext cx="914400" cy="731520"/>
-          </a:xfrm>
-          <a:prstGeom prst="rect">
-            <a:avLst/>
-          </a:prstGeom>
-          <a:noFill/>
-        </p:spPr>
-        <p:txBody>
-          <a:bodyPr wrap="square" lIns="0" tIns="0" rIns="0" bIns="0" anchor="ctr">
-            <a:noAutofit/>
-          </a:bodyPr>
-          <a:lstStyle/>
-          <a:p>
-            <a:pPr algn="l"/>
-            <a:r>
-              <a:rPr sz="1900" b="1" i="0">
-                <a:solidFill>
-                  <a:srgbClr val="00599B"/>
-                </a:solidFill>
-                <a:latin typeface="Arial"/>
-              </a:rPr>
-              <a:t>75.1%</a:t>
-            </a:r>
-          </a:p>
-        </p:txBody>
-      </p:sp>
-      <p:sp>
-        <p:nvSpPr>
-          <p:cNvPr id="39" name="TextBox 38"/>
-          <p:cNvSpPr txBox="1"/>
-          <p:nvPr/>
-        </p:nvSpPr>
-        <p:spPr>
-          <a:xfrm>
-            <a:off x="7095744" y="3191256"/>
-            <a:ext cx="1545336" cy="850392"/>
-          </a:xfrm>
-          <a:prstGeom prst="rect">
-            <a:avLst/>
-          </a:prstGeom>
-          <a:noFill/>
-        </p:spPr>
-        <p:txBody>
-          <a:bodyPr wrap="square" lIns="0" tIns="0" rIns="0" bIns="0" anchor="ctr">
-            <a:noAutofit/>
-          </a:bodyPr>
-          <a:lstStyle/>
-          <a:p>
-            <a:pPr algn="l"/>
-            <a:r>
-              <a:rPr sz="850" b="0" i="0">
-                <a:solidFill>
-                  <a:srgbClr val="1F2933"/>
-                </a:solidFill>
-                <a:latin typeface="Arial"/>
-              </a:rPr>
-              <a:t>MMLU of 14B AWQ-INT4 vs 71.4% for 7B BF16, with less weight memory</a:t>
+              <a:t>B=256 overflows the cache in every format</a:t>
             </a:r>
           </a:p>
         </p:txBody>
@@ -6740,7 +5827,7 @@
           <a:p>
             <a:r>
               <a:rPr sz="2800"/>
-              <a:t>Team and References</a:t>
+              <a:t>Takeaways: When Does Quantization Pay Off?</a:t>
             </a:r>
           </a:p>
         </p:txBody>
@@ -6767,7 +5854,7 @@
           <a:p>
             <a:r>
               <a:rPr sz="1400"/>
-              <a:t>Who did what, and what we built on</a:t>
+              <a:t>Bit-width alone predicts little — the kernel and the regime decide</a:t>
             </a:r>
           </a:p>
         </p:txBody>
@@ -6787,11 +5874,11 @@
         <p:spPr>
           <a:xfrm>
             <a:off x="457200" y="1133856"/>
-            <a:ext cx="2651760" cy="960120"/>
+            <a:ext cx="2679192" cy="1417320"/>
           </a:xfrm>
           <a:prstGeom prst="roundRect">
             <a:avLst>
-              <a:gd name="adj" fmla="val 7619"/>
+              <a:gd name="adj" fmla="val 5161"/>
             </a:avLst>
           </a:prstGeom>
           <a:solidFill>
@@ -6838,8 +5925,8 @@
         </p:nvSpPr>
         <p:spPr>
           <a:xfrm>
-            <a:off x="594360" y="1271016"/>
-            <a:ext cx="384048" cy="384048"/>
+            <a:off x="566928" y="1261872"/>
+            <a:ext cx="329184" cy="329184"/>
           </a:xfrm>
           <a:prstGeom prst="ellipse">
             <a:avLst/>
@@ -6896,8 +5983,8 @@
         </p:blipFill>
         <p:spPr>
           <a:xfrm>
-            <a:off x="678850" y="1355506"/>
-            <a:ext cx="215066" cy="215066"/>
+            <a:off x="639348" y="1334292"/>
+            <a:ext cx="184343" cy="184343"/>
           </a:xfrm>
           <a:prstGeom prst="rect">
             <a:avLst/>
@@ -6912,8 +5999,8 @@
         </p:nvSpPr>
         <p:spPr>
           <a:xfrm>
-            <a:off x="1060704" y="1243584"/>
-            <a:ext cx="1965960" cy="219456"/>
+            <a:off x="969264" y="1225296"/>
+            <a:ext cx="2093976" cy="402336"/>
           </a:xfrm>
           <a:prstGeom prst="rect">
             <a:avLst/>
@@ -6928,13 +6015,13 @@
           <a:p>
             <a:pPr algn="l"/>
             <a:r>
-              <a:rPr sz="1150" b="1" i="0">
+              <a:rPr sz="1050" b="1" i="0">
                 <a:solidFill>
                   <a:srgbClr val="003865"/>
                 </a:solidFill>
                 <a:latin typeface="Arial"/>
               </a:rPr>
-              <a:t>Sijia Zhong</a:t>
+              <a:t>Plan memory with the real ratio</a:t>
             </a:r>
           </a:p>
         </p:txBody>
@@ -6947,8 +6034,8 @@
         </p:nvSpPr>
         <p:spPr>
           <a:xfrm>
-            <a:off x="1060704" y="1463040"/>
-            <a:ext cx="1965960" cy="201168"/>
+            <a:off x="585216" y="1682495"/>
+            <a:ext cx="914400" cy="731520"/>
           </a:xfrm>
           <a:prstGeom prst="rect">
             <a:avLst/>
@@ -6963,13 +6050,13 @@
           <a:p>
             <a:pPr algn="l"/>
             <a:r>
-              <a:rPr sz="900" b="0" i="0">
+              <a:rPr sz="1900" b="1" i="0">
                 <a:solidFill>
                   <a:srgbClr val="00599B"/>
                 </a:solidFill>
                 <a:latin typeface="Arial"/>
               </a:rPr>
-              <a:t>Baseline + memory (Q1)</a:t>
+              <a:t>2.6×</a:t>
             </a:r>
           </a:p>
         </p:txBody>
@@ -6982,8 +6069,8 @@
         </p:nvSpPr>
         <p:spPr>
           <a:xfrm>
-            <a:off x="603504" y="1737360"/>
-            <a:ext cx="2377440" cy="329184"/>
+            <a:off x="1499616" y="1645920"/>
+            <a:ext cx="1545336" cy="850392"/>
           </a:xfrm>
           <a:prstGeom prst="rect">
             <a:avLst/>
@@ -6991,7 +6078,7 @@
           <a:noFill/>
         </p:spPr>
         <p:txBody>
-          <a:bodyPr wrap="square" lIns="0" tIns="0" rIns="0" bIns="0" anchor="t">
+          <a:bodyPr wrap="square" lIns="0" tIns="0" rIns="0" bIns="0" anchor="ctr">
             <a:noAutofit/>
           </a:bodyPr>
           <a:lstStyle/>
@@ -7004,7 +6091,7 @@
                 </a:solidFill>
                 <a:latin typeface="Arial"/>
               </a:rPr>
-              <a:t>Benchmark harness, memory model, capacity</a:t>
+              <a:t>4-bit weight saving on Qwen2.5-7B, not 4×; KV cache and activations stay 16-bit</a:t>
             </a:r>
           </a:p>
         </p:txBody>
@@ -7023,12 +6110,12 @@
         </p:nvSpPr>
         <p:spPr>
           <a:xfrm>
-            <a:off x="3246120" y="1133856"/>
-            <a:ext cx="2651760" cy="960120"/>
+            <a:off x="3255264" y="1133856"/>
+            <a:ext cx="2679192" cy="1417320"/>
           </a:xfrm>
           <a:prstGeom prst="roundRect">
             <a:avLst>
-              <a:gd name="adj" fmla="val 7619"/>
+              <a:gd name="adj" fmla="val 5161"/>
             </a:avLst>
           </a:prstGeom>
           <a:solidFill>
@@ -7075,8 +6162,8 @@
         </p:nvSpPr>
         <p:spPr>
           <a:xfrm>
-            <a:off x="3383279" y="1271016"/>
-            <a:ext cx="384048" cy="384048"/>
+            <a:off x="3364991" y="1261872"/>
+            <a:ext cx="329184" cy="329184"/>
           </a:xfrm>
           <a:prstGeom prst="ellipse">
             <a:avLst/>
@@ -7133,8 +6220,8 @@
         </p:blipFill>
         <p:spPr>
           <a:xfrm>
-            <a:off x="3467770" y="1355506"/>
-            <a:ext cx="215066" cy="215066"/>
+            <a:off x="3437412" y="1334292"/>
+            <a:ext cx="184343" cy="184343"/>
           </a:xfrm>
           <a:prstGeom prst="rect">
             <a:avLst/>
@@ -7149,8 +6236,8 @@
         </p:nvSpPr>
         <p:spPr>
           <a:xfrm>
-            <a:off x="3849624" y="1243584"/>
-            <a:ext cx="1965960" cy="219456"/>
+            <a:off x="3767328" y="1225296"/>
+            <a:ext cx="2093976" cy="402336"/>
           </a:xfrm>
           <a:prstGeom prst="rect">
             <a:avLst/>
@@ -7165,13 +6252,13 @@
           <a:p>
             <a:pPr algn="l"/>
             <a:r>
-              <a:rPr sz="1150" b="1" i="0">
+              <a:rPr sz="1050" b="1" i="0">
                 <a:solidFill>
                   <a:srgbClr val="003865"/>
                 </a:solidFill>
                 <a:latin typeface="Arial"/>
               </a:rPr>
-              <a:t>Zheng Zheng</a:t>
+              <a:t>Few users: 4-bit + fused kernel</a:t>
             </a:r>
           </a:p>
         </p:txBody>
@@ -7184,8 +6271,8 @@
         </p:nvSpPr>
         <p:spPr>
           <a:xfrm>
-            <a:off x="3849624" y="1463040"/>
-            <a:ext cx="1965960" cy="201168"/>
+            <a:off x="3383280" y="1682495"/>
+            <a:ext cx="914400" cy="731520"/>
           </a:xfrm>
           <a:prstGeom prst="rect">
             <a:avLst/>
@@ -7200,13 +6287,13 @@
           <a:p>
             <a:pPr algn="l"/>
             <a:r>
-              <a:rPr sz="900" b="0" i="0">
+              <a:rPr sz="1900" b="1" i="0">
                 <a:solidFill>
                   <a:srgbClr val="00599B"/>
                 </a:solidFill>
                 <a:latin typeface="Arial"/>
               </a:rPr>
-              <a:t>Controlled sweeps (Q2)</a:t>
+              <a:t>2.4×</a:t>
             </a:r>
           </a:p>
         </p:txBody>
@@ -7219,8 +6306,8 @@
         </p:nvSpPr>
         <p:spPr>
           <a:xfrm>
-            <a:off x="3392424" y="1737360"/>
-            <a:ext cx="2377440" cy="329184"/>
+            <a:off x="4297680" y="1645920"/>
+            <a:ext cx="1545336" cy="850392"/>
           </a:xfrm>
           <a:prstGeom prst="rect">
             <a:avLst/>
@@ -7228,7 +6315,7 @@
           <a:noFill/>
         </p:spPr>
         <p:txBody>
-          <a:bodyPr wrap="square" lIns="0" tIns="0" rIns="0" bIns="0" anchor="t">
+          <a:bodyPr wrap="square" lIns="0" tIns="0" rIns="0" bIns="0" anchor="ctr">
             <a:noAutofit/>
           </a:bodyPr>
           <a:lstStyle/>
@@ -7241,7 +6328,7 @@
                 </a:solidFill>
                 <a:latin typeface="Arial"/>
               </a:rPr>
-              <a:t>Precision × batch × length grids, kernels, profiling</a:t>
+              <a:t>faster decode with AWQ-INT4 + Marlin at batch size 1</a:t>
             </a:r>
           </a:p>
         </p:txBody>
@@ -7260,12 +6347,12 @@
         </p:nvSpPr>
         <p:spPr>
           <a:xfrm>
-            <a:off x="6035040" y="1133856"/>
-            <a:ext cx="2651760" cy="960120"/>
+            <a:off x="6053328" y="1133856"/>
+            <a:ext cx="2679192" cy="1417320"/>
           </a:xfrm>
           <a:prstGeom prst="roundRect">
             <a:avLst>
-              <a:gd name="adj" fmla="val 7619"/>
+              <a:gd name="adj" fmla="val 5161"/>
             </a:avLst>
           </a:prstGeom>
           <a:solidFill>
@@ -7312,8 +6399,8 @@
         </p:nvSpPr>
         <p:spPr>
           <a:xfrm>
-            <a:off x="6172200" y="1271016"/>
-            <a:ext cx="384048" cy="384048"/>
+            <a:off x="6163056" y="1261872"/>
+            <a:ext cx="329184" cy="329184"/>
           </a:xfrm>
           <a:prstGeom prst="ellipse">
             <a:avLst/>
@@ -7370,8 +6457,8 @@
         </p:blipFill>
         <p:spPr>
           <a:xfrm>
-            <a:off x="6256690" y="1355506"/>
-            <a:ext cx="215066" cy="215066"/>
+            <a:off x="6235476" y="1334292"/>
+            <a:ext cx="184343" cy="184343"/>
           </a:xfrm>
           <a:prstGeom prst="rect">
             <a:avLst/>
@@ -7386,8 +6473,8 @@
         </p:nvSpPr>
         <p:spPr>
           <a:xfrm>
-            <a:off x="6638544" y="1243584"/>
-            <a:ext cx="1965960" cy="219456"/>
+            <a:off x="6565392" y="1225296"/>
+            <a:ext cx="2093976" cy="402336"/>
           </a:xfrm>
           <a:prstGeom prst="rect">
             <a:avLst/>
@@ -7402,6 +6489,1500 @@
           <a:p>
             <a:pPr algn="l"/>
             <a:r>
+              <a:rPr sz="1050" b="1" i="0">
+                <a:solidFill>
+                  <a:srgbClr val="003865"/>
+                </a:solidFill>
+                <a:latin typeface="Arial"/>
+              </a:rPr>
+              <a:t>High throughput: FP8 W8A8</a:t>
+            </a:r>
+          </a:p>
+        </p:txBody>
+      </p:sp>
+      <p:sp>
+        <p:nvSpPr>
+          <p:cNvPr id="20" name="TextBox 19"/>
+          <p:cNvSpPr txBox="1"/>
+          <p:nvPr/>
+        </p:nvSpPr>
+        <p:spPr>
+          <a:xfrm>
+            <a:off x="6181344" y="1682495"/>
+            <a:ext cx="914400" cy="731520"/>
+          </a:xfrm>
+          <a:prstGeom prst="rect">
+            <a:avLst/>
+          </a:prstGeom>
+          <a:noFill/>
+        </p:spPr>
+        <p:txBody>
+          <a:bodyPr wrap="square" lIns="0" tIns="0" rIns="0" bIns="0" anchor="ctr">
+            <a:noAutofit/>
+          </a:bodyPr>
+          <a:lstStyle/>
+          <a:p>
+            <a:pPr algn="l"/>
+            <a:r>
+              <a:rPr sz="1900" b="1" i="0">
+                <a:solidFill>
+                  <a:srgbClr val="00599B"/>
+                </a:solidFill>
+                <a:latin typeface="Arial"/>
+              </a:rPr>
+              <a:t>1.7×</a:t>
+            </a:r>
+          </a:p>
+        </p:txBody>
+      </p:sp>
+      <p:sp>
+        <p:nvSpPr>
+          <p:cNvPr id="21" name="TextBox 20"/>
+          <p:cNvSpPr txBox="1"/>
+          <p:nvPr/>
+        </p:nvSpPr>
+        <p:spPr>
+          <a:xfrm>
+            <a:off x="7095744" y="1645920"/>
+            <a:ext cx="1545336" cy="850392"/>
+          </a:xfrm>
+          <a:prstGeom prst="rect">
+            <a:avLst/>
+          </a:prstGeom>
+          <a:noFill/>
+        </p:spPr>
+        <p:txBody>
+          <a:bodyPr wrap="square" lIns="0" tIns="0" rIns="0" bIns="0" anchor="ctr">
+            <a:noAutofit/>
+          </a:bodyPr>
+          <a:lstStyle/>
+          <a:p>
+            <a:pPr algn="l"/>
+            <a:r>
+              <a:rPr sz="850" b="0" i="0">
+                <a:solidFill>
+                  <a:srgbClr val="1F2933"/>
+                </a:solidFill>
+                <a:latin typeface="Arial"/>
+              </a:rPr>
+              <a:t>the BF16 throughput at batch 256, where 4-bit weight-only gains have vanished</a:t>
+            </a:r>
+          </a:p>
+        </p:txBody>
+      </p:sp>
+      <p:sp>
+        <p:nvSpPr>
+          <p:cNvPr id="22" name="Rounded Rectangle 21">
+            <a:extLst>
+              <a:ext uri="{C183D7F6-B498-43B3-948B-1728B52AA6E4}">
+                <adec:decorative xmlns:adec="http://schemas.microsoft.com/office/drawing/2017/decorative" val="1"/>
+              </a:ext>
+            </a:extLst>
+          </p:cNvPr>
+          <p:cNvSpPr/>
+          <p:nvPr/>
+        </p:nvSpPr>
+        <p:spPr>
+          <a:xfrm>
+            <a:off x="457200" y="2679191"/>
+            <a:ext cx="2679192" cy="1417320"/>
+          </a:xfrm>
+          <a:prstGeom prst="roundRect">
+            <a:avLst>
+              <a:gd name="adj" fmla="val 5161"/>
+            </a:avLst>
+          </a:prstGeom>
+          <a:solidFill>
+            <a:srgbClr val="EDF3F9"/>
+          </a:solidFill>
+          <a:ln>
+            <a:noFill/>
+          </a:ln>
+          <a:effectLst/>
+        </p:spPr>
+        <p:style>
+          <a:lnRef idx="1">
+            <a:schemeClr val="accent1"/>
+          </a:lnRef>
+          <a:fillRef idx="3">
+            <a:schemeClr val="accent1"/>
+          </a:fillRef>
+          <a:effectRef idx="2">
+            <a:schemeClr val="accent1"/>
+          </a:effectRef>
+          <a:fontRef idx="minor">
+            <a:schemeClr val="lt1"/>
+          </a:fontRef>
+        </p:style>
+        <p:txBody>
+          <a:bodyPr rtlCol="0" anchor="ctr"/>
+          <a:lstStyle/>
+          <a:p>
+            <a:pPr algn="ctr"/>
+          </a:p>
+        </p:txBody>
+      </p:sp>
+      <p:sp>
+        <p:nvSpPr>
+          <p:cNvPr id="23" name="Oval 22">
+            <a:extLst>
+              <a:ext uri="{C183D7F6-B498-43B3-948B-1728B52AA6E4}">
+                <adec:decorative xmlns:adec="http://schemas.microsoft.com/office/drawing/2017/decorative" val="1"/>
+              </a:ext>
+            </a:extLst>
+          </p:cNvPr>
+          <p:cNvSpPr/>
+          <p:nvPr/>
+        </p:nvSpPr>
+        <p:spPr>
+          <a:xfrm>
+            <a:off x="566928" y="2807207"/>
+            <a:ext cx="329184" cy="329184"/>
+          </a:xfrm>
+          <a:prstGeom prst="ellipse">
+            <a:avLst/>
+          </a:prstGeom>
+          <a:solidFill>
+            <a:srgbClr val="0064B1"/>
+          </a:solidFill>
+          <a:ln>
+            <a:noFill/>
+          </a:ln>
+          <a:effectLst/>
+        </p:spPr>
+        <p:style>
+          <a:lnRef idx="1">
+            <a:schemeClr val="accent1"/>
+          </a:lnRef>
+          <a:fillRef idx="3">
+            <a:schemeClr val="accent1"/>
+          </a:fillRef>
+          <a:effectRef idx="2">
+            <a:schemeClr val="accent1"/>
+          </a:effectRef>
+          <a:fontRef idx="minor">
+            <a:schemeClr val="lt1"/>
+          </a:fontRef>
+        </p:style>
+        <p:txBody>
+          <a:bodyPr rtlCol="0" anchor="ctr"/>
+          <a:lstStyle/>
+          <a:p>
+            <a:pPr algn="ctr"/>
+          </a:p>
+        </p:txBody>
+      </p:sp>
+      <p:pic>
+        <p:nvPicPr>
+          <p:cNvPr id="24" name="Picture 23" descr="">
+            <a:extLst>
+              <a:ext uri="{C183D7F6-B498-43B3-948B-1728B52AA6E4}">
+                <adec:decorative xmlns:adec="http://schemas.microsoft.com/office/drawing/2017/decorative" val="1"/>
+              </a:ext>
+            </a:extLst>
+          </p:cNvPr>
+          <p:cNvPicPr>
+            <a:picLocks noChangeAspect="1"/>
+          </p:cNvPicPr>
+          <p:nvPr/>
+        </p:nvPicPr>
+        <p:blipFill>
+          <a:blip r:embed="rId6"/>
+          <a:stretch>
+            <a:fillRect/>
+          </a:stretch>
+        </p:blipFill>
+        <p:spPr>
+          <a:xfrm>
+            <a:off x="639348" y="2879628"/>
+            <a:ext cx="184343" cy="184343"/>
+          </a:xfrm>
+          <a:prstGeom prst="rect">
+            <a:avLst/>
+          </a:prstGeom>
+        </p:spPr>
+      </p:pic>
+      <p:sp>
+        <p:nvSpPr>
+          <p:cNvPr id="25" name="TextBox 24"/>
+          <p:cNvSpPr txBox="1"/>
+          <p:nvPr/>
+        </p:nvSpPr>
+        <p:spPr>
+          <a:xfrm>
+            <a:off x="969264" y="2770632"/>
+            <a:ext cx="2093976" cy="402336"/>
+          </a:xfrm>
+          <a:prstGeom prst="rect">
+            <a:avLst/>
+          </a:prstGeom>
+          <a:noFill/>
+        </p:spPr>
+        <p:txBody>
+          <a:bodyPr wrap="square" lIns="0" tIns="0" rIns="0" bIns="0" anchor="ctr">
+            <a:noAutofit/>
+          </a:bodyPr>
+          <a:lstStyle/>
+          <a:p>
+            <a:pPr algn="l"/>
+            <a:r>
+              <a:rPr sz="1050" b="1" i="0">
+                <a:solidFill>
+                  <a:srgbClr val="003865"/>
+                </a:solidFill>
+                <a:latin typeface="Arial"/>
+              </a:rPr>
+              <a:t>bitsandbytes: memory, not speed</a:t>
+            </a:r>
+          </a:p>
+        </p:txBody>
+      </p:sp>
+      <p:sp>
+        <p:nvSpPr>
+          <p:cNvPr id="26" name="TextBox 25"/>
+          <p:cNvSpPr txBox="1"/>
+          <p:nvPr/>
+        </p:nvSpPr>
+        <p:spPr>
+          <a:xfrm>
+            <a:off x="585216" y="3227832"/>
+            <a:ext cx="914400" cy="731520"/>
+          </a:xfrm>
+          <a:prstGeom prst="rect">
+            <a:avLst/>
+          </a:prstGeom>
+          <a:noFill/>
+        </p:spPr>
+        <p:txBody>
+          <a:bodyPr wrap="square" lIns="0" tIns="0" rIns="0" bIns="0" anchor="ctr">
+            <a:noAutofit/>
+          </a:bodyPr>
+          <a:lstStyle/>
+          <a:p>
+            <a:pPr algn="l"/>
+            <a:r>
+              <a:rPr sz="1900" b="1" i="0">
+                <a:solidFill>
+                  <a:srgbClr val="00599B"/>
+                </a:solidFill>
+                <a:latin typeface="Arial"/>
+              </a:rPr>
+              <a:t>3.4×</a:t>
+            </a:r>
+          </a:p>
+        </p:txBody>
+      </p:sp>
+      <p:sp>
+        <p:nvSpPr>
+          <p:cNvPr id="27" name="TextBox 26"/>
+          <p:cNvSpPr txBox="1"/>
+          <p:nvPr/>
+        </p:nvSpPr>
+        <p:spPr>
+          <a:xfrm>
+            <a:off x="1499616" y="3191256"/>
+            <a:ext cx="1545336" cy="850392"/>
+          </a:xfrm>
+          <a:prstGeom prst="rect">
+            <a:avLst/>
+          </a:prstGeom>
+          <a:noFill/>
+        </p:spPr>
+        <p:txBody>
+          <a:bodyPr wrap="square" lIns="0" tIns="0" rIns="0" bIns="0" anchor="ctr">
+            <a:noAutofit/>
+          </a:bodyPr>
+          <a:lstStyle/>
+          <a:p>
+            <a:pPr algn="l"/>
+            <a:r>
+              <a:rPr sz="850" b="0" i="0">
+                <a:solidFill>
+                  <a:srgbClr val="1F2933"/>
+                </a:solidFill>
+                <a:latin typeface="Arial"/>
+              </a:rPr>
+              <a:t>slower decode with LLM.int8() at batch size 1; NF4 helps only tiny batches</a:t>
+            </a:r>
+          </a:p>
+        </p:txBody>
+      </p:sp>
+      <p:sp>
+        <p:nvSpPr>
+          <p:cNvPr id="28" name="Rounded Rectangle 27">
+            <a:extLst>
+              <a:ext uri="{C183D7F6-B498-43B3-948B-1728B52AA6E4}">
+                <adec:decorative xmlns:adec="http://schemas.microsoft.com/office/drawing/2017/decorative" val="1"/>
+              </a:ext>
+            </a:extLst>
+          </p:cNvPr>
+          <p:cNvSpPr/>
+          <p:nvPr/>
+        </p:nvSpPr>
+        <p:spPr>
+          <a:xfrm>
+            <a:off x="3255264" y="2679191"/>
+            <a:ext cx="2679192" cy="1417320"/>
+          </a:xfrm>
+          <a:prstGeom prst="roundRect">
+            <a:avLst>
+              <a:gd name="adj" fmla="val 5161"/>
+            </a:avLst>
+          </a:prstGeom>
+          <a:solidFill>
+            <a:srgbClr val="EDF3F9"/>
+          </a:solidFill>
+          <a:ln>
+            <a:noFill/>
+          </a:ln>
+          <a:effectLst/>
+        </p:spPr>
+        <p:style>
+          <a:lnRef idx="1">
+            <a:schemeClr val="accent1"/>
+          </a:lnRef>
+          <a:fillRef idx="3">
+            <a:schemeClr val="accent1"/>
+          </a:fillRef>
+          <a:effectRef idx="2">
+            <a:schemeClr val="accent1"/>
+          </a:effectRef>
+          <a:fontRef idx="minor">
+            <a:schemeClr val="lt1"/>
+          </a:fontRef>
+        </p:style>
+        <p:txBody>
+          <a:bodyPr rtlCol="0" anchor="ctr"/>
+          <a:lstStyle/>
+          <a:p>
+            <a:pPr algn="ctr"/>
+          </a:p>
+        </p:txBody>
+      </p:sp>
+      <p:sp>
+        <p:nvSpPr>
+          <p:cNvPr id="29" name="Oval 28">
+            <a:extLst>
+              <a:ext uri="{C183D7F6-B498-43B3-948B-1728B52AA6E4}">
+                <adec:decorative xmlns:adec="http://schemas.microsoft.com/office/drawing/2017/decorative" val="1"/>
+              </a:ext>
+            </a:extLst>
+          </p:cNvPr>
+          <p:cNvSpPr/>
+          <p:nvPr/>
+        </p:nvSpPr>
+        <p:spPr>
+          <a:xfrm>
+            <a:off x="3364991" y="2807207"/>
+            <a:ext cx="329184" cy="329184"/>
+          </a:xfrm>
+          <a:prstGeom prst="ellipse">
+            <a:avLst/>
+          </a:prstGeom>
+          <a:solidFill>
+            <a:srgbClr val="0064B1"/>
+          </a:solidFill>
+          <a:ln>
+            <a:noFill/>
+          </a:ln>
+          <a:effectLst/>
+        </p:spPr>
+        <p:style>
+          <a:lnRef idx="1">
+            <a:schemeClr val="accent1"/>
+          </a:lnRef>
+          <a:fillRef idx="3">
+            <a:schemeClr val="accent1"/>
+          </a:fillRef>
+          <a:effectRef idx="2">
+            <a:schemeClr val="accent1"/>
+          </a:effectRef>
+          <a:fontRef idx="minor">
+            <a:schemeClr val="lt1"/>
+          </a:fontRef>
+        </p:style>
+        <p:txBody>
+          <a:bodyPr rtlCol="0" anchor="ctr"/>
+          <a:lstStyle/>
+          <a:p>
+            <a:pPr algn="ctr"/>
+          </a:p>
+        </p:txBody>
+      </p:sp>
+      <p:pic>
+        <p:nvPicPr>
+          <p:cNvPr id="30" name="Picture 29" descr="">
+            <a:extLst>
+              <a:ext uri="{C183D7F6-B498-43B3-948B-1728B52AA6E4}">
+                <adec:decorative xmlns:adec="http://schemas.microsoft.com/office/drawing/2017/decorative" val="1"/>
+              </a:ext>
+            </a:extLst>
+          </p:cNvPr>
+          <p:cNvPicPr>
+            <a:picLocks noChangeAspect="1"/>
+          </p:cNvPicPr>
+          <p:nvPr/>
+        </p:nvPicPr>
+        <p:blipFill>
+          <a:blip r:embed="rId7"/>
+          <a:stretch>
+            <a:fillRect/>
+          </a:stretch>
+        </p:blipFill>
+        <p:spPr>
+          <a:xfrm>
+            <a:off x="3437412" y="2879628"/>
+            <a:ext cx="184343" cy="184343"/>
+          </a:xfrm>
+          <a:prstGeom prst="rect">
+            <a:avLst/>
+          </a:prstGeom>
+        </p:spPr>
+      </p:pic>
+      <p:sp>
+        <p:nvSpPr>
+          <p:cNvPr id="31" name="TextBox 30"/>
+          <p:cNvSpPr txBox="1"/>
+          <p:nvPr/>
+        </p:nvSpPr>
+        <p:spPr>
+          <a:xfrm>
+            <a:off x="3767328" y="2770632"/>
+            <a:ext cx="2093976" cy="402336"/>
+          </a:xfrm>
+          <a:prstGeom prst="rect">
+            <a:avLst/>
+          </a:prstGeom>
+          <a:noFill/>
+        </p:spPr>
+        <p:txBody>
+          <a:bodyPr wrap="square" lIns="0" tIns="0" rIns="0" bIns="0" anchor="ctr">
+            <a:noAutofit/>
+          </a:bodyPr>
+          <a:lstStyle/>
+          <a:p>
+            <a:pPr algn="l"/>
+            <a:r>
+              <a:rPr sz="1050" b="1" i="0">
+                <a:solidFill>
+                  <a:srgbClr val="003865"/>
+                </a:solidFill>
+                <a:latin typeface="Arial"/>
+              </a:rPr>
+              <a:t>Quality: small, but per model</a:t>
+            </a:r>
+          </a:p>
+        </p:txBody>
+      </p:sp>
+      <p:sp>
+        <p:nvSpPr>
+          <p:cNvPr id="32" name="TextBox 31"/>
+          <p:cNvSpPr txBox="1"/>
+          <p:nvPr/>
+        </p:nvSpPr>
+        <p:spPr>
+          <a:xfrm>
+            <a:off x="3383280" y="3227832"/>
+            <a:ext cx="914400" cy="731520"/>
+          </a:xfrm>
+          <a:prstGeom prst="rect">
+            <a:avLst/>
+          </a:prstGeom>
+          <a:noFill/>
+        </p:spPr>
+        <p:txBody>
+          <a:bodyPr wrap="square" lIns="0" tIns="0" rIns="0" bIns="0" anchor="ctr">
+            <a:noAutofit/>
+          </a:bodyPr>
+          <a:lstStyle/>
+          <a:p>
+            <a:pPr algn="l"/>
+            <a:r>
+              <a:rPr sz="1900" b="1" i="0">
+                <a:solidFill>
+                  <a:srgbClr val="00599B"/>
+                </a:solidFill>
+                <a:latin typeface="Arial"/>
+              </a:rPr>
+              <a:t>−2.8 pp</a:t>
+            </a:r>
+          </a:p>
+        </p:txBody>
+      </p:sp>
+      <p:sp>
+        <p:nvSpPr>
+          <p:cNvPr id="33" name="TextBox 32"/>
+          <p:cNvSpPr txBox="1"/>
+          <p:nvPr/>
+        </p:nvSpPr>
+        <p:spPr>
+          <a:xfrm>
+            <a:off x="4297680" y="3191256"/>
+            <a:ext cx="1545336" cy="850392"/>
+          </a:xfrm>
+          <a:prstGeom prst="rect">
+            <a:avLst/>
+          </a:prstGeom>
+          <a:noFill/>
+        </p:spPr>
+        <p:txBody>
+          <a:bodyPr wrap="square" lIns="0" tIns="0" rIns="0" bIns="0" anchor="ctr">
+            <a:noAutofit/>
+          </a:bodyPr>
+          <a:lstStyle/>
+          <a:p>
+            <a:pPr algn="l"/>
+            <a:r>
+              <a:rPr sz="850" b="0" i="0">
+                <a:solidFill>
+                  <a:srgbClr val="1F2933"/>
+                </a:solidFill>
+                <a:latin typeface="Arial"/>
+              </a:rPr>
+              <a:t>worst 4-bit MMLU loss (Qwen2.5-3B); 8-bit within 0.9 pp, yet FP8 = AWQ on Qwen3-8B — measure it</a:t>
+            </a:r>
+          </a:p>
+        </p:txBody>
+      </p:sp>
+      <p:sp>
+        <p:nvSpPr>
+          <p:cNvPr id="34" name="Rounded Rectangle 33">
+            <a:extLst>
+              <a:ext uri="{C183D7F6-B498-43B3-948B-1728B52AA6E4}">
+                <adec:decorative xmlns:adec="http://schemas.microsoft.com/office/drawing/2017/decorative" val="1"/>
+              </a:ext>
+            </a:extLst>
+          </p:cNvPr>
+          <p:cNvSpPr/>
+          <p:nvPr/>
+        </p:nvSpPr>
+        <p:spPr>
+          <a:xfrm>
+            <a:off x="6053328" y="2679191"/>
+            <a:ext cx="2679192" cy="1417320"/>
+          </a:xfrm>
+          <a:prstGeom prst="roundRect">
+            <a:avLst>
+              <a:gd name="adj" fmla="val 5161"/>
+            </a:avLst>
+          </a:prstGeom>
+          <a:solidFill>
+            <a:srgbClr val="EDF3F9"/>
+          </a:solidFill>
+          <a:ln>
+            <a:noFill/>
+          </a:ln>
+          <a:effectLst/>
+        </p:spPr>
+        <p:style>
+          <a:lnRef idx="1">
+            <a:schemeClr val="accent1"/>
+          </a:lnRef>
+          <a:fillRef idx="3">
+            <a:schemeClr val="accent1"/>
+          </a:fillRef>
+          <a:effectRef idx="2">
+            <a:schemeClr val="accent1"/>
+          </a:effectRef>
+          <a:fontRef idx="minor">
+            <a:schemeClr val="lt1"/>
+          </a:fontRef>
+        </p:style>
+        <p:txBody>
+          <a:bodyPr rtlCol="0" anchor="ctr"/>
+          <a:lstStyle/>
+          <a:p>
+            <a:pPr algn="ctr"/>
+          </a:p>
+        </p:txBody>
+      </p:sp>
+      <p:sp>
+        <p:nvSpPr>
+          <p:cNvPr id="35" name="Oval 34">
+            <a:extLst>
+              <a:ext uri="{C183D7F6-B498-43B3-948B-1728B52AA6E4}">
+                <adec:decorative xmlns:adec="http://schemas.microsoft.com/office/drawing/2017/decorative" val="1"/>
+              </a:ext>
+            </a:extLst>
+          </p:cNvPr>
+          <p:cNvSpPr/>
+          <p:nvPr/>
+        </p:nvSpPr>
+        <p:spPr>
+          <a:xfrm>
+            <a:off x="6163056" y="2807207"/>
+            <a:ext cx="329184" cy="329184"/>
+          </a:xfrm>
+          <a:prstGeom prst="ellipse">
+            <a:avLst/>
+          </a:prstGeom>
+          <a:solidFill>
+            <a:srgbClr val="0064B1"/>
+          </a:solidFill>
+          <a:ln>
+            <a:noFill/>
+          </a:ln>
+          <a:effectLst/>
+        </p:spPr>
+        <p:style>
+          <a:lnRef idx="1">
+            <a:schemeClr val="accent1"/>
+          </a:lnRef>
+          <a:fillRef idx="3">
+            <a:schemeClr val="accent1"/>
+          </a:fillRef>
+          <a:effectRef idx="2">
+            <a:schemeClr val="accent1"/>
+          </a:effectRef>
+          <a:fontRef idx="minor">
+            <a:schemeClr val="lt1"/>
+          </a:fontRef>
+        </p:style>
+        <p:txBody>
+          <a:bodyPr rtlCol="0" anchor="ctr"/>
+          <a:lstStyle/>
+          <a:p>
+            <a:pPr algn="ctr"/>
+          </a:p>
+        </p:txBody>
+      </p:sp>
+      <p:pic>
+        <p:nvPicPr>
+          <p:cNvPr id="36" name="Picture 35" descr="">
+            <a:extLst>
+              <a:ext uri="{C183D7F6-B498-43B3-948B-1728B52AA6E4}">
+                <adec:decorative xmlns:adec="http://schemas.microsoft.com/office/drawing/2017/decorative" val="1"/>
+              </a:ext>
+            </a:extLst>
+          </p:cNvPr>
+          <p:cNvPicPr>
+            <a:picLocks noChangeAspect="1"/>
+          </p:cNvPicPr>
+          <p:nvPr/>
+        </p:nvPicPr>
+        <p:blipFill>
+          <a:blip r:embed="rId8"/>
+          <a:stretch>
+            <a:fillRect/>
+          </a:stretch>
+        </p:blipFill>
+        <p:spPr>
+          <a:xfrm>
+            <a:off x="6235476" y="2879628"/>
+            <a:ext cx="184343" cy="184343"/>
+          </a:xfrm>
+          <a:prstGeom prst="rect">
+            <a:avLst/>
+          </a:prstGeom>
+        </p:spPr>
+      </p:pic>
+      <p:sp>
+        <p:nvSpPr>
+          <p:cNvPr id="37" name="TextBox 36"/>
+          <p:cNvSpPr txBox="1"/>
+          <p:nvPr/>
+        </p:nvSpPr>
+        <p:spPr>
+          <a:xfrm>
+            <a:off x="6565392" y="2770632"/>
+            <a:ext cx="2093976" cy="402336"/>
+          </a:xfrm>
+          <a:prstGeom prst="rect">
+            <a:avLst/>
+          </a:prstGeom>
+          <a:noFill/>
+        </p:spPr>
+        <p:txBody>
+          <a:bodyPr wrap="square" lIns="0" tIns="0" rIns="0" bIns="0" anchor="ctr">
+            <a:noAutofit/>
+          </a:bodyPr>
+          <a:lstStyle/>
+          <a:p>
+            <a:pPr algn="l"/>
+            <a:r>
+              <a:rPr sz="1050" b="1" i="0">
+                <a:solidFill>
+                  <a:srgbClr val="003865"/>
+                </a:solidFill>
+                <a:latin typeface="Arial"/>
+              </a:rPr>
+              <a:t>Spend memory on parameters</a:t>
+            </a:r>
+          </a:p>
+        </p:txBody>
+      </p:sp>
+      <p:sp>
+        <p:nvSpPr>
+          <p:cNvPr id="38" name="TextBox 37"/>
+          <p:cNvSpPr txBox="1"/>
+          <p:nvPr/>
+        </p:nvSpPr>
+        <p:spPr>
+          <a:xfrm>
+            <a:off x="6181344" y="3227832"/>
+            <a:ext cx="914400" cy="731520"/>
+          </a:xfrm>
+          <a:prstGeom prst="rect">
+            <a:avLst/>
+          </a:prstGeom>
+          <a:noFill/>
+        </p:spPr>
+        <p:txBody>
+          <a:bodyPr wrap="square" lIns="0" tIns="0" rIns="0" bIns="0" anchor="ctr">
+            <a:noAutofit/>
+          </a:bodyPr>
+          <a:lstStyle/>
+          <a:p>
+            <a:pPr algn="l"/>
+            <a:r>
+              <a:rPr sz="1900" b="1" i="0">
+                <a:solidFill>
+                  <a:srgbClr val="00599B"/>
+                </a:solidFill>
+                <a:latin typeface="Arial"/>
+              </a:rPr>
+              <a:t>75.1%</a:t>
+            </a:r>
+          </a:p>
+        </p:txBody>
+      </p:sp>
+      <p:sp>
+        <p:nvSpPr>
+          <p:cNvPr id="39" name="TextBox 38"/>
+          <p:cNvSpPr txBox="1"/>
+          <p:nvPr/>
+        </p:nvSpPr>
+        <p:spPr>
+          <a:xfrm>
+            <a:off x="7095744" y="3191256"/>
+            <a:ext cx="1545336" cy="850392"/>
+          </a:xfrm>
+          <a:prstGeom prst="rect">
+            <a:avLst/>
+          </a:prstGeom>
+          <a:noFill/>
+        </p:spPr>
+        <p:txBody>
+          <a:bodyPr wrap="square" lIns="0" tIns="0" rIns="0" bIns="0" anchor="ctr">
+            <a:noAutofit/>
+          </a:bodyPr>
+          <a:lstStyle/>
+          <a:p>
+            <a:pPr algn="l"/>
+            <a:r>
+              <a:rPr sz="850" b="0" i="0">
+                <a:solidFill>
+                  <a:srgbClr val="1F2933"/>
+                </a:solidFill>
+                <a:latin typeface="Arial"/>
+              </a:rPr>
+              <a:t>MMLU of 14B AWQ-INT4 vs 71.4% for 7B BF16, with less weight memory</a:t>
+            </a:r>
+          </a:p>
+        </p:txBody>
+      </p:sp>
+    </p:spTree>
+  </p:cSld>
+  <p:clrMapOvr>
+    <a:masterClrMapping/>
+  </p:clrMapOvr>
+</p:sld>
+</file>
+
+<file path=ppt/slides/slide12.xml><?xml version="1.0" encoding="utf-8"?>
+<p:sld xmlns:a="http://schemas.openxmlformats.org/drawingml/2006/main" xmlns:p="http://schemas.openxmlformats.org/presentationml/2006/main" xmlns:r="http://schemas.openxmlformats.org/officeDocument/2006/relationships">
+  <p:cSld>
+    <p:spTree>
+      <p:nvGrpSpPr>
+        <p:cNvPr id="1" name=""/>
+        <p:cNvGrpSpPr/>
+        <p:nvPr/>
+      </p:nvGrpSpPr>
+      <p:grpSpPr/>
+      <p:sp>
+        <p:nvSpPr>
+          <p:cNvPr id="2" name="Title 1"/>
+          <p:cNvSpPr>
+            <a:spLocks noGrp="1"/>
+          </p:cNvSpPr>
+          <p:nvPr>
+            <p:ph type="title"/>
+          </p:nvPr>
+        </p:nvSpPr>
+        <p:spPr>
+          <a:xfrm>
+            <a:off x="457200" y="128016"/>
+            <a:ext cx="8229600" cy="603504"/>
+          </a:xfrm>
+        </p:spPr>
+        <p:txBody>
+          <a:bodyPr/>
+          <a:lstStyle/>
+          <a:p>
+            <a:r>
+              <a:rPr sz="2800"/>
+              <a:t>Team and References</a:t>
+            </a:r>
+          </a:p>
+        </p:txBody>
+      </p:sp>
+      <p:sp>
+        <p:nvSpPr>
+          <p:cNvPr id="3" name="Content Placeholder 2"/>
+          <p:cNvSpPr>
+            <a:spLocks noGrp="1"/>
+          </p:cNvSpPr>
+          <p:nvPr>
+            <p:ph idx="10" sz="quarter"/>
+          </p:nvPr>
+        </p:nvSpPr>
+        <p:spPr>
+          <a:xfrm>
+            <a:off x="457200" y="694944"/>
+            <a:ext cx="8229600" cy="310896"/>
+          </a:xfrm>
+        </p:spPr>
+        <p:txBody>
+          <a:bodyPr/>
+          <a:lstStyle/>
+          <a:p>
+            <a:r>
+              <a:rPr sz="1400"/>
+              <a:t>Who did what, and what we built on</a:t>
+            </a:r>
+          </a:p>
+        </p:txBody>
+      </p:sp>
+      <p:sp>
+        <p:nvSpPr>
+          <p:cNvPr id="4" name="Rounded Rectangle 3">
+            <a:extLst>
+              <a:ext uri="{C183D7F6-B498-43B3-948B-1728B52AA6E4}">
+                <adec:decorative xmlns:adec="http://schemas.microsoft.com/office/drawing/2017/decorative" val="1"/>
+              </a:ext>
+            </a:extLst>
+          </p:cNvPr>
+          <p:cNvSpPr/>
+          <p:nvPr/>
+        </p:nvSpPr>
+        <p:spPr>
+          <a:xfrm>
+            <a:off x="457200" y="1133856"/>
+            <a:ext cx="2651760" cy="960120"/>
+          </a:xfrm>
+          <a:prstGeom prst="roundRect">
+            <a:avLst>
+              <a:gd name="adj" fmla="val 7619"/>
+            </a:avLst>
+          </a:prstGeom>
+          <a:solidFill>
+            <a:srgbClr val="EDF3F9"/>
+          </a:solidFill>
+          <a:ln>
+            <a:noFill/>
+          </a:ln>
+          <a:effectLst/>
+        </p:spPr>
+        <p:style>
+          <a:lnRef idx="1">
+            <a:schemeClr val="accent1"/>
+          </a:lnRef>
+          <a:fillRef idx="3">
+            <a:schemeClr val="accent1"/>
+          </a:fillRef>
+          <a:effectRef idx="2">
+            <a:schemeClr val="accent1"/>
+          </a:effectRef>
+          <a:fontRef idx="minor">
+            <a:schemeClr val="lt1"/>
+          </a:fontRef>
+        </p:style>
+        <p:txBody>
+          <a:bodyPr rtlCol="0" anchor="ctr"/>
+          <a:lstStyle/>
+          <a:p>
+            <a:pPr algn="ctr"/>
+          </a:p>
+        </p:txBody>
+      </p:sp>
+      <p:sp>
+        <p:nvSpPr>
+          <p:cNvPr id="5" name="Oval 4">
+            <a:extLst>
+              <a:ext uri="{C183D7F6-B498-43B3-948B-1728B52AA6E4}">
+                <adec:decorative xmlns:adec="http://schemas.microsoft.com/office/drawing/2017/decorative" val="1"/>
+              </a:ext>
+            </a:extLst>
+          </p:cNvPr>
+          <p:cNvSpPr/>
+          <p:nvPr/>
+        </p:nvSpPr>
+        <p:spPr>
+          <a:xfrm>
+            <a:off x="594360" y="1271016"/>
+            <a:ext cx="384048" cy="384048"/>
+          </a:xfrm>
+          <a:prstGeom prst="ellipse">
+            <a:avLst/>
+          </a:prstGeom>
+          <a:solidFill>
+            <a:srgbClr val="0064B1"/>
+          </a:solidFill>
+          <a:ln>
+            <a:noFill/>
+          </a:ln>
+          <a:effectLst/>
+        </p:spPr>
+        <p:style>
+          <a:lnRef idx="1">
+            <a:schemeClr val="accent1"/>
+          </a:lnRef>
+          <a:fillRef idx="3">
+            <a:schemeClr val="accent1"/>
+          </a:fillRef>
+          <a:effectRef idx="2">
+            <a:schemeClr val="accent1"/>
+          </a:effectRef>
+          <a:fontRef idx="minor">
+            <a:schemeClr val="lt1"/>
+          </a:fontRef>
+        </p:style>
+        <p:txBody>
+          <a:bodyPr rtlCol="0" anchor="ctr"/>
+          <a:lstStyle/>
+          <a:p>
+            <a:pPr algn="ctr"/>
+          </a:p>
+        </p:txBody>
+      </p:sp>
+      <p:pic>
+        <p:nvPicPr>
+          <p:cNvPr id="6" name="Picture 5" descr="">
+            <a:extLst>
+              <a:ext uri="{C183D7F6-B498-43B3-948B-1728B52AA6E4}">
+                <adec:decorative xmlns:adec="http://schemas.microsoft.com/office/drawing/2017/decorative" val="1"/>
+              </a:ext>
+            </a:extLst>
+          </p:cNvPr>
+          <p:cNvPicPr>
+            <a:picLocks noChangeAspect="1"/>
+          </p:cNvPicPr>
+          <p:nvPr/>
+        </p:nvPicPr>
+        <p:blipFill>
+          <a:blip r:embed="rId3"/>
+          <a:stretch>
+            <a:fillRect/>
+          </a:stretch>
+        </p:blipFill>
+        <p:spPr>
+          <a:xfrm>
+            <a:off x="678850" y="1355506"/>
+            <a:ext cx="215066" cy="215066"/>
+          </a:xfrm>
+          <a:prstGeom prst="rect">
+            <a:avLst/>
+          </a:prstGeom>
+        </p:spPr>
+      </p:pic>
+      <p:sp>
+        <p:nvSpPr>
+          <p:cNvPr id="7" name="TextBox 6"/>
+          <p:cNvSpPr txBox="1"/>
+          <p:nvPr/>
+        </p:nvSpPr>
+        <p:spPr>
+          <a:xfrm>
+            <a:off x="1060704" y="1243584"/>
+            <a:ext cx="1965960" cy="219456"/>
+          </a:xfrm>
+          <a:prstGeom prst="rect">
+            <a:avLst/>
+          </a:prstGeom>
+          <a:noFill/>
+        </p:spPr>
+        <p:txBody>
+          <a:bodyPr wrap="square" lIns="0" tIns="0" rIns="0" bIns="0" anchor="ctr">
+            <a:noAutofit/>
+          </a:bodyPr>
+          <a:lstStyle/>
+          <a:p>
+            <a:pPr algn="l"/>
+            <a:r>
+              <a:rPr sz="1150" b="1" i="0">
+                <a:solidFill>
+                  <a:srgbClr val="003865"/>
+                </a:solidFill>
+                <a:latin typeface="Arial"/>
+              </a:rPr>
+              <a:t>Sijia Zhong</a:t>
+            </a:r>
+          </a:p>
+        </p:txBody>
+      </p:sp>
+      <p:sp>
+        <p:nvSpPr>
+          <p:cNvPr id="8" name="TextBox 7"/>
+          <p:cNvSpPr txBox="1"/>
+          <p:nvPr/>
+        </p:nvSpPr>
+        <p:spPr>
+          <a:xfrm>
+            <a:off x="1060704" y="1463040"/>
+            <a:ext cx="1965960" cy="201168"/>
+          </a:xfrm>
+          <a:prstGeom prst="rect">
+            <a:avLst/>
+          </a:prstGeom>
+          <a:noFill/>
+        </p:spPr>
+        <p:txBody>
+          <a:bodyPr wrap="square" lIns="0" tIns="0" rIns="0" bIns="0" anchor="ctr">
+            <a:noAutofit/>
+          </a:bodyPr>
+          <a:lstStyle/>
+          <a:p>
+            <a:pPr algn="l"/>
+            <a:r>
+              <a:rPr sz="900" b="0" i="0">
+                <a:solidFill>
+                  <a:srgbClr val="00599B"/>
+                </a:solidFill>
+                <a:latin typeface="Arial"/>
+              </a:rPr>
+              <a:t>Baseline + memory (Q1)</a:t>
+            </a:r>
+          </a:p>
+        </p:txBody>
+      </p:sp>
+      <p:sp>
+        <p:nvSpPr>
+          <p:cNvPr id="9" name="TextBox 8"/>
+          <p:cNvSpPr txBox="1"/>
+          <p:nvPr/>
+        </p:nvSpPr>
+        <p:spPr>
+          <a:xfrm>
+            <a:off x="603504" y="1737360"/>
+            <a:ext cx="2377440" cy="329184"/>
+          </a:xfrm>
+          <a:prstGeom prst="rect">
+            <a:avLst/>
+          </a:prstGeom>
+          <a:noFill/>
+        </p:spPr>
+        <p:txBody>
+          <a:bodyPr wrap="square" lIns="0" tIns="0" rIns="0" bIns="0" anchor="t">
+            <a:noAutofit/>
+          </a:bodyPr>
+          <a:lstStyle/>
+          <a:p>
+            <a:pPr algn="l"/>
+            <a:r>
+              <a:rPr sz="850" b="0" i="0">
+                <a:solidFill>
+                  <a:srgbClr val="1F2933"/>
+                </a:solidFill>
+                <a:latin typeface="Arial"/>
+              </a:rPr>
+              <a:t>Benchmark harness, memory model, capacity</a:t>
+            </a:r>
+          </a:p>
+        </p:txBody>
+      </p:sp>
+      <p:sp>
+        <p:nvSpPr>
+          <p:cNvPr id="10" name="Rounded Rectangle 9">
+            <a:extLst>
+              <a:ext uri="{C183D7F6-B498-43B3-948B-1728B52AA6E4}">
+                <adec:decorative xmlns:adec="http://schemas.microsoft.com/office/drawing/2017/decorative" val="1"/>
+              </a:ext>
+            </a:extLst>
+          </p:cNvPr>
+          <p:cNvSpPr/>
+          <p:nvPr/>
+        </p:nvSpPr>
+        <p:spPr>
+          <a:xfrm>
+            <a:off x="3246120" y="1133856"/>
+            <a:ext cx="2651760" cy="960120"/>
+          </a:xfrm>
+          <a:prstGeom prst="roundRect">
+            <a:avLst>
+              <a:gd name="adj" fmla="val 7619"/>
+            </a:avLst>
+          </a:prstGeom>
+          <a:solidFill>
+            <a:srgbClr val="EDF3F9"/>
+          </a:solidFill>
+          <a:ln>
+            <a:noFill/>
+          </a:ln>
+          <a:effectLst/>
+        </p:spPr>
+        <p:style>
+          <a:lnRef idx="1">
+            <a:schemeClr val="accent1"/>
+          </a:lnRef>
+          <a:fillRef idx="3">
+            <a:schemeClr val="accent1"/>
+          </a:fillRef>
+          <a:effectRef idx="2">
+            <a:schemeClr val="accent1"/>
+          </a:effectRef>
+          <a:fontRef idx="minor">
+            <a:schemeClr val="lt1"/>
+          </a:fontRef>
+        </p:style>
+        <p:txBody>
+          <a:bodyPr rtlCol="0" anchor="ctr"/>
+          <a:lstStyle/>
+          <a:p>
+            <a:pPr algn="ctr"/>
+          </a:p>
+        </p:txBody>
+      </p:sp>
+      <p:sp>
+        <p:nvSpPr>
+          <p:cNvPr id="11" name="Oval 10">
+            <a:extLst>
+              <a:ext uri="{C183D7F6-B498-43B3-948B-1728B52AA6E4}">
+                <adec:decorative xmlns:adec="http://schemas.microsoft.com/office/drawing/2017/decorative" val="1"/>
+              </a:ext>
+            </a:extLst>
+          </p:cNvPr>
+          <p:cNvSpPr/>
+          <p:nvPr/>
+        </p:nvSpPr>
+        <p:spPr>
+          <a:xfrm>
+            <a:off x="3383279" y="1271016"/>
+            <a:ext cx="384048" cy="384048"/>
+          </a:xfrm>
+          <a:prstGeom prst="ellipse">
+            <a:avLst/>
+          </a:prstGeom>
+          <a:solidFill>
+            <a:srgbClr val="0064B1"/>
+          </a:solidFill>
+          <a:ln>
+            <a:noFill/>
+          </a:ln>
+          <a:effectLst/>
+        </p:spPr>
+        <p:style>
+          <a:lnRef idx="1">
+            <a:schemeClr val="accent1"/>
+          </a:lnRef>
+          <a:fillRef idx="3">
+            <a:schemeClr val="accent1"/>
+          </a:fillRef>
+          <a:effectRef idx="2">
+            <a:schemeClr val="accent1"/>
+          </a:effectRef>
+          <a:fontRef idx="minor">
+            <a:schemeClr val="lt1"/>
+          </a:fontRef>
+        </p:style>
+        <p:txBody>
+          <a:bodyPr rtlCol="0" anchor="ctr"/>
+          <a:lstStyle/>
+          <a:p>
+            <a:pPr algn="ctr"/>
+          </a:p>
+        </p:txBody>
+      </p:sp>
+      <p:pic>
+        <p:nvPicPr>
+          <p:cNvPr id="12" name="Picture 11" descr="">
+            <a:extLst>
+              <a:ext uri="{C183D7F6-B498-43B3-948B-1728B52AA6E4}">
+                <adec:decorative xmlns:adec="http://schemas.microsoft.com/office/drawing/2017/decorative" val="1"/>
+              </a:ext>
+            </a:extLst>
+          </p:cNvPr>
+          <p:cNvPicPr>
+            <a:picLocks noChangeAspect="1"/>
+          </p:cNvPicPr>
+          <p:nvPr/>
+        </p:nvPicPr>
+        <p:blipFill>
+          <a:blip r:embed="rId4"/>
+          <a:stretch>
+            <a:fillRect/>
+          </a:stretch>
+        </p:blipFill>
+        <p:spPr>
+          <a:xfrm>
+            <a:off x="3467770" y="1355506"/>
+            <a:ext cx="215066" cy="215066"/>
+          </a:xfrm>
+          <a:prstGeom prst="rect">
+            <a:avLst/>
+          </a:prstGeom>
+        </p:spPr>
+      </p:pic>
+      <p:sp>
+        <p:nvSpPr>
+          <p:cNvPr id="13" name="TextBox 12"/>
+          <p:cNvSpPr txBox="1"/>
+          <p:nvPr/>
+        </p:nvSpPr>
+        <p:spPr>
+          <a:xfrm>
+            <a:off x="3849624" y="1243584"/>
+            <a:ext cx="1965960" cy="219456"/>
+          </a:xfrm>
+          <a:prstGeom prst="rect">
+            <a:avLst/>
+          </a:prstGeom>
+          <a:noFill/>
+        </p:spPr>
+        <p:txBody>
+          <a:bodyPr wrap="square" lIns="0" tIns="0" rIns="0" bIns="0" anchor="ctr">
+            <a:noAutofit/>
+          </a:bodyPr>
+          <a:lstStyle/>
+          <a:p>
+            <a:pPr algn="l"/>
+            <a:r>
+              <a:rPr sz="1150" b="1" i="0">
+                <a:solidFill>
+                  <a:srgbClr val="003865"/>
+                </a:solidFill>
+                <a:latin typeface="Arial"/>
+              </a:rPr>
+              <a:t>Zheng Zheng</a:t>
+            </a:r>
+          </a:p>
+        </p:txBody>
+      </p:sp>
+      <p:sp>
+        <p:nvSpPr>
+          <p:cNvPr id="14" name="TextBox 13"/>
+          <p:cNvSpPr txBox="1"/>
+          <p:nvPr/>
+        </p:nvSpPr>
+        <p:spPr>
+          <a:xfrm>
+            <a:off x="3849624" y="1463040"/>
+            <a:ext cx="1965960" cy="201168"/>
+          </a:xfrm>
+          <a:prstGeom prst="rect">
+            <a:avLst/>
+          </a:prstGeom>
+          <a:noFill/>
+        </p:spPr>
+        <p:txBody>
+          <a:bodyPr wrap="square" lIns="0" tIns="0" rIns="0" bIns="0" anchor="ctr">
+            <a:noAutofit/>
+          </a:bodyPr>
+          <a:lstStyle/>
+          <a:p>
+            <a:pPr algn="l"/>
+            <a:r>
+              <a:rPr sz="900" b="0" i="0">
+                <a:solidFill>
+                  <a:srgbClr val="00599B"/>
+                </a:solidFill>
+                <a:latin typeface="Arial"/>
+              </a:rPr>
+              <a:t>Controlled sweeps (Q2)</a:t>
+            </a:r>
+          </a:p>
+        </p:txBody>
+      </p:sp>
+      <p:sp>
+        <p:nvSpPr>
+          <p:cNvPr id="15" name="TextBox 14"/>
+          <p:cNvSpPr txBox="1"/>
+          <p:nvPr/>
+        </p:nvSpPr>
+        <p:spPr>
+          <a:xfrm>
+            <a:off x="3392424" y="1737360"/>
+            <a:ext cx="2377440" cy="329184"/>
+          </a:xfrm>
+          <a:prstGeom prst="rect">
+            <a:avLst/>
+          </a:prstGeom>
+          <a:noFill/>
+        </p:spPr>
+        <p:txBody>
+          <a:bodyPr wrap="square" lIns="0" tIns="0" rIns="0" bIns="0" anchor="t">
+            <a:noAutofit/>
+          </a:bodyPr>
+          <a:lstStyle/>
+          <a:p>
+            <a:pPr algn="l"/>
+            <a:r>
+              <a:rPr sz="850" b="0" i="0">
+                <a:solidFill>
+                  <a:srgbClr val="1F2933"/>
+                </a:solidFill>
+                <a:latin typeface="Arial"/>
+              </a:rPr>
+              <a:t>Precision × batch × length grids, kernels, profiling</a:t>
+            </a:r>
+          </a:p>
+        </p:txBody>
+      </p:sp>
+      <p:sp>
+        <p:nvSpPr>
+          <p:cNvPr id="16" name="Rounded Rectangle 15">
+            <a:extLst>
+              <a:ext uri="{C183D7F6-B498-43B3-948B-1728B52AA6E4}">
+                <adec:decorative xmlns:adec="http://schemas.microsoft.com/office/drawing/2017/decorative" val="1"/>
+              </a:ext>
+            </a:extLst>
+          </p:cNvPr>
+          <p:cNvSpPr/>
+          <p:nvPr/>
+        </p:nvSpPr>
+        <p:spPr>
+          <a:xfrm>
+            <a:off x="6035040" y="1133856"/>
+            <a:ext cx="2651760" cy="960120"/>
+          </a:xfrm>
+          <a:prstGeom prst="roundRect">
+            <a:avLst>
+              <a:gd name="adj" fmla="val 7619"/>
+            </a:avLst>
+          </a:prstGeom>
+          <a:solidFill>
+            <a:srgbClr val="EDF3F9"/>
+          </a:solidFill>
+          <a:ln>
+            <a:noFill/>
+          </a:ln>
+          <a:effectLst/>
+        </p:spPr>
+        <p:style>
+          <a:lnRef idx="1">
+            <a:schemeClr val="accent1"/>
+          </a:lnRef>
+          <a:fillRef idx="3">
+            <a:schemeClr val="accent1"/>
+          </a:fillRef>
+          <a:effectRef idx="2">
+            <a:schemeClr val="accent1"/>
+          </a:effectRef>
+          <a:fontRef idx="minor">
+            <a:schemeClr val="lt1"/>
+          </a:fontRef>
+        </p:style>
+        <p:txBody>
+          <a:bodyPr rtlCol="0" anchor="ctr"/>
+          <a:lstStyle/>
+          <a:p>
+            <a:pPr algn="ctr"/>
+          </a:p>
+        </p:txBody>
+      </p:sp>
+      <p:sp>
+        <p:nvSpPr>
+          <p:cNvPr id="17" name="Oval 16">
+            <a:extLst>
+              <a:ext uri="{C183D7F6-B498-43B3-948B-1728B52AA6E4}">
+                <adec:decorative xmlns:adec="http://schemas.microsoft.com/office/drawing/2017/decorative" val="1"/>
+              </a:ext>
+            </a:extLst>
+          </p:cNvPr>
+          <p:cNvSpPr/>
+          <p:nvPr/>
+        </p:nvSpPr>
+        <p:spPr>
+          <a:xfrm>
+            <a:off x="6172200" y="1271016"/>
+            <a:ext cx="384048" cy="384048"/>
+          </a:xfrm>
+          <a:prstGeom prst="ellipse">
+            <a:avLst/>
+          </a:prstGeom>
+          <a:solidFill>
+            <a:srgbClr val="0064B1"/>
+          </a:solidFill>
+          <a:ln>
+            <a:noFill/>
+          </a:ln>
+          <a:effectLst/>
+        </p:spPr>
+        <p:style>
+          <a:lnRef idx="1">
+            <a:schemeClr val="accent1"/>
+          </a:lnRef>
+          <a:fillRef idx="3">
+            <a:schemeClr val="accent1"/>
+          </a:fillRef>
+          <a:effectRef idx="2">
+            <a:schemeClr val="accent1"/>
+          </a:effectRef>
+          <a:fontRef idx="minor">
+            <a:schemeClr val="lt1"/>
+          </a:fontRef>
+        </p:style>
+        <p:txBody>
+          <a:bodyPr rtlCol="0" anchor="ctr"/>
+          <a:lstStyle/>
+          <a:p>
+            <a:pPr algn="ctr"/>
+          </a:p>
+        </p:txBody>
+      </p:sp>
+      <p:pic>
+        <p:nvPicPr>
+          <p:cNvPr id="18" name="Picture 17" descr="">
+            <a:extLst>
+              <a:ext uri="{C183D7F6-B498-43B3-948B-1728B52AA6E4}">
+                <adec:decorative xmlns:adec="http://schemas.microsoft.com/office/drawing/2017/decorative" val="1"/>
+              </a:ext>
+            </a:extLst>
+          </p:cNvPr>
+          <p:cNvPicPr>
+            <a:picLocks noChangeAspect="1"/>
+          </p:cNvPicPr>
+          <p:nvPr/>
+        </p:nvPicPr>
+        <p:blipFill>
+          <a:blip r:embed="rId5"/>
+          <a:stretch>
+            <a:fillRect/>
+          </a:stretch>
+        </p:blipFill>
+        <p:spPr>
+          <a:xfrm>
+            <a:off x="6256690" y="1355506"/>
+            <a:ext cx="215066" cy="215066"/>
+          </a:xfrm>
+          <a:prstGeom prst="rect">
+            <a:avLst/>
+          </a:prstGeom>
+        </p:spPr>
+      </p:pic>
+      <p:sp>
+        <p:nvSpPr>
+          <p:cNvPr id="19" name="TextBox 18"/>
+          <p:cNvSpPr txBox="1"/>
+          <p:nvPr/>
+        </p:nvSpPr>
+        <p:spPr>
+          <a:xfrm>
+            <a:off x="6638544" y="1243584"/>
+            <a:ext cx="1965960" cy="219456"/>
+          </a:xfrm>
+          <a:prstGeom prst="rect">
+            <a:avLst/>
+          </a:prstGeom>
+          <a:noFill/>
+        </p:spPr>
+        <p:txBody>
+          <a:bodyPr wrap="square" lIns="0" tIns="0" rIns="0" bIns="0" anchor="ctr">
+            <a:noAutofit/>
+          </a:bodyPr>
+          <a:lstStyle/>
+          <a:p>
+            <a:pPr algn="l"/>
+            <a:r>
               <a:rPr sz="1150" b="1" i="0">
                 <a:solidFill>
                   <a:srgbClr val="003865"/>
@@ -7478,7 +8059,7 @@
                 </a:solidFill>
                 <a:latin typeface="Arial"/>
               </a:rPr>
-              <a:t>ShareGPT serving, WikiText-2, GSM8K</a:t>
+              <a:t>ShareGPT serving, WikiText-2, GSM8K, MMLU</a:t>
             </a:r>
           </a:p>
         </p:txBody>
@@ -7692,7 +8273,7 @@
                 </a:solidFill>
                 <a:latin typeface="Arial"/>
               </a:rPr>
-              <a:t>Qwen Team, Qwen2.5 Technical Report, 2024  ·  Merity et al., WikiText (ICLR 2017)  ·  Cobbe et al., GSM8K, 2021</a:t>
+              <a:t>Qwen Team, Qwen2.5 / Qwen3 Technical Reports, 2024/2025  ·  Merity et al., WikiText (ICLR 2017)  ·  Cobbe et al., GSM8K, 2021  ·  Hendrycks et al., MMLU (ICLR 2021)</a:t>
             </a:r>
           </a:p>
         </p:txBody>
@@ -7808,7 +8389,7 @@
           <a:p>
             <a:r>
               <a:rPr sz="1400"/>
-              <a:t>2 backends × 8 configurations × 3 model sizes — every number measured on one GPU</a:t>
+              <a:t>2 backends × 8 configurations × 4 models (Qwen2.5-3B/7B/14B, Qwen3-8B) on one GPU</a:t>
             </a:r>
           </a:p>
         </p:txBody>
@@ -8110,7 +8691,7 @@
                 </a:solidFill>
                 <a:latin typeface="Arial"/>
               </a:rPr>
-              <a:t>Qwen2.5-3B / 7B / 14B-Instruct</a:t>
+              <a:t>Qwen2.5-3B / 7B / 14B-Instruct; Qwen3-8B as a second family</a:t>
             </a:r>
           </a:p>
         </p:txBody>
@@ -9493,7 +10074,7 @@
                 </a:solidFill>
                 <a:latin typeface="Arial"/>
               </a:rPr>
-              <a:t>batch 1–256 × prompt 128–2048 tokens, exactly 128 output tokens</a:t>
+              <a:t>batch 1–256 × prompt 128–2048 tokens × 32–512 output tokens</a:t>
             </a:r>
           </a:p>
           <a:p>
@@ -9543,7 +10124,7 @@
                 </a:solidFill>
                 <a:latin typeface="Arial"/>
               </a:rPr>
-              <a:t>WikiText-2 perplexity, GSM8K (all 1,319 questions)</a:t>
+              <a:t>WikiText-2 perplexity, GSM8K (1,319 q.), MMLU (14,042 q.), paired McNemar tests</a:t>
             </a:r>
           </a:p>
           <a:p>

</xml_diff>

<commit_message>
Add Qwen3-32B: runs on the 32 GB GPU only at 4 bits
- vLLM AWQ-INT4 and HF NF4: sweep, perplexity, GSM8K, MMLU; paired tests against Qwen3-8B BF16
- the AWQ checkpoint's FP16 activations overflow in 13 of 146 perplexity windows; BF16 rerun
  reported and flagged, loader falls back to a forced-dtype run only when the default is not finite
- report: Qwen3-32B paragraph, 32B rows in the quality table; figure and slide updated
</commit_message>
<xml_diff>
--- a/final_project/slides/final_presentation.pptx
+++ b/final_project/slides/final_presentation.pptx
@@ -5317,7 +5317,7 @@
           <a:p>
             <a:r>
               <a:rPr sz="2800"/>
-              <a:t>Does It Generalize? Qwen3-8B</a:t>
+              <a:t>Does It Generalize? Qwen3-8B and 32B</a:t>
             </a:r>
           </a:p>
         </p:txBody>
@@ -5344,7 +5344,7 @@
           <a:p>
             <a:r>
               <a:rPr sz="1400"/>
-              <a:t>Qwen3-8B (36 layers, 8 KV heads, non-thinking): the systems picture carries over</a:t>
+              <a:t>Qwen3-8B reproduces the systems picture; Qwen3-32B runs on this GPU only at 4 bits</a:t>
             </a:r>
           </a:p>
         </p:txBody>
@@ -5365,8 +5365,8 @@
         </p:blipFill>
         <p:spPr>
           <a:xfrm>
-            <a:off x="1282480" y="1133856"/>
-            <a:ext cx="6579039" cy="2048255"/>
+            <a:off x="457200" y="1133856"/>
+            <a:ext cx="8229600" cy="1706585"/>
           </a:xfrm>
           <a:prstGeom prst="rect">
             <a:avLst/>
@@ -5731,7 +5731,7 @@
                 </a:solidFill>
                 <a:latin typeface="Arial"/>
               </a:rPr>
-              <a:t>2.6×</a:t>
+              <a:t>78.1% vs 69.6%</a:t>
             </a:r>
           </a:p>
         </p:txBody>
@@ -5770,7 +5770,7 @@
                 </a:solidFill>
                 <a:latin typeface="Arial"/>
               </a:rPr>
-              <a:t>KV-cache bytes per token vs Qwen2.5-7B</a:t>
+              <a:t>MMLU: 32B AWQ-INT4 vs 8B BF16</a:t>
             </a:r>
           </a:p>
           <a:p>
@@ -5782,7 +5782,7 @@
                 </a:solidFill>
                 <a:latin typeface="Arial"/>
               </a:rPr>
-              <a:t>B=256 overflows the cache in every format</a:t>
+              <a:t>19.6 vs 16.4 GB; BF16 32B needs 66 GB</a:t>
             </a:r>
           </a:p>
         </p:txBody>
@@ -8389,7 +8389,7 @@
           <a:p>
             <a:r>
               <a:rPr sz="1400"/>
-              <a:t>2 backends × 8 configurations × 4 models (Qwen2.5-3B/7B/14B, Qwen3-8B) on one GPU</a:t>
+              <a:t>2 backends × 8 configurations × 5 models (Qwen2.5-3B/7B/14B, Qwen3-8B/32B) on one GPU</a:t>
             </a:r>
           </a:p>
         </p:txBody>
@@ -8691,7 +8691,7 @@
                 </a:solidFill>
                 <a:latin typeface="Arial"/>
               </a:rPr>
-              <a:t>Qwen2.5-3B / 7B / 14B-Instruct; Qwen3-8B as a second family</a:t>
+              <a:t>Qwen2.5-3B / 7B / 14B-Instruct; Qwen3-8B and 32B (4-bit only)</a:t>
             </a:r>
           </a:p>
         </p:txBody>

</xml_diff>

<commit_message>
Address review: narrower claims, timing caveats, readable slides
- Report: say "implementation" (method, activation path, engine) where
  the old text credited the kernel alone; note that LLM.int8() and
  GPTQ-INT8 differ in more than the kernel.
- Report: give both the 95th percentile (0.7%) and the maximum (2.3%)
  of the run-to-run variation.
- Report: the HF vs. vLLM serving gap is a serving-stack effect, and the
  two stacks are timed differently (HF: no warm-up, TTFT from the start
  of each batch; vLLM: 8 warm-ups, client-side TTFT). Details in App. C.
- README: run_all.sh is executable; the report build runs in a subshell
  so the slide build path still works.
- Slides: tile text 12-22 pt with the details moved to speaker notes;
  slides use the print-size report figures (larger text) and Figure 1
  on the Q2 slide; setup and team slides at 10-11.5 pt minimum; the
  setup slide now quotes the same 1.61 TB/s read bandwidth as the report.
</commit_message>
<xml_diff>
--- a/final_project/slides/final_presentation.pptx
+++ b/final_project/slides/final_presentation.pptx
@@ -791,7 +791,13 @@
           <a:lstStyle/>
           <a:p>
             <a:r>
-              <a:t>Six rules: plan memory with the real ratio; for interactive serving use 4-bit weights with a fused kernel; for throughput use FP8 W8A8; treat bitsandbytes as a memory tool, not a speed-up; 8-bit formats with good kernels preserve quality while 4-bit costs one to three MMLU points; and at a fixed memory budget a larger 4-bit model beats a smaller 16-bit one.</a:t>
+              <a:t>Qwen3-8B reproduces the decode speedups of AWQ and FP8 and the LLM.int8() slowdown within a few percent. NF4 turns from a small gain into a loss because the 36-layer model is host-bound at batch 1, exactly like the 36-layer Qwen2.5-3B.</a:t>
+            </a:r>
+          </a:p>
+          <a:p/>
+          <a:p>
+            <a:r>
+              <a:t>Numbers on this slide: 2.33× vs 2.44×: AWQ speedup: Qwen3 vs Qwen2.5 (Qwen3-8B vs Qwen2.5-7B at B=1; FP8 1.54× vs 1.59×); 0.90×: NF4 on Qwen3-8B (36 layers) (36 layers → host-bound, as on Qwen2.5-3B); 78.1% vs 69.6%: MMLU: 32B 4-bit vs 8B BF16 (19.6 vs 16.4 GB; BF16 32B needs 66 GB).</a:t>
             </a:r>
           </a:p>
         </p:txBody>
@@ -861,6 +867,76 @@
           <a:lstStyle/>
           <a:p>
             <a:r>
+              <a:t>Six rules: plan memory with the real ratio; for interactive serving use 4-bit weights with a fused kernel; for throughput use FP8 W8A8; treat bitsandbytes as a memory tool, not a speed-up; 8-bit formats with good kernels preserve quality while 4-bit costs one to three MMLU points; and at a fixed memory budget a larger 4-bit model beats a smaller 16-bit one.</a:t>
+            </a:r>
+          </a:p>
+        </p:txBody>
+      </p:sp>
+      <p:sp>
+        <p:nvSpPr>
+          <p:cNvPr id="4" name="Slide Number Placeholder 3"/>
+          <p:cNvSpPr>
+            <a:spLocks noGrp="1"/>
+          </p:cNvSpPr>
+          <p:nvPr>
+            <p:ph type="sldNum" idx="5" sz="quarter"/>
+          </p:nvPr>
+        </p:nvSpPr>
+        <p:spPr/>
+      </p:sp>
+    </p:spTree>
+  </p:cSld>
+  <p:clrMapOvr>
+    <a:masterClrMapping/>
+  </p:clrMapOvr>
+</p:notes>
+</file>
+
+<file path=ppt/notesSlides/notesSlide12.xml><?xml version="1.0" encoding="utf-8"?>
+<p:notes xmlns:a="http://schemas.openxmlformats.org/drawingml/2006/main" xmlns:p="http://schemas.openxmlformats.org/presentationml/2006/main" xmlns:r="http://schemas.openxmlformats.org/officeDocument/2006/relationships">
+  <p:cSld>
+    <p:spTree>
+      <p:nvGrpSpPr>
+        <p:cNvPr id="1" name=""/>
+        <p:cNvGrpSpPr/>
+        <p:nvPr/>
+      </p:nvGrpSpPr>
+      <p:grpSpPr>
+        <a:xfrm>
+          <a:off x="0" y="0"/>
+          <a:ext cx="0" cy="0"/>
+          <a:chOff x="0" y="0"/>
+          <a:chExt cx="0" cy="0"/>
+        </a:xfrm>
+      </p:grpSpPr>
+      <p:sp>
+        <p:nvSpPr>
+          <p:cNvPr id="2" name="Slide Image Placeholder 1"/>
+          <p:cNvSpPr>
+            <a:spLocks noGrp="1"/>
+          </p:cNvSpPr>
+          <p:nvPr>
+            <p:ph type="sldImg" idx="2"/>
+          </p:nvPr>
+        </p:nvSpPr>
+        <p:spPr/>
+      </p:sp>
+      <p:sp>
+        <p:nvSpPr>
+          <p:cNvPr id="3" name="Notes Placeholder 2"/>
+          <p:cNvSpPr>
+            <a:spLocks noGrp="1"/>
+          </p:cNvSpPr>
+          <p:nvPr>
+            <p:ph type="body" idx="3" sz="quarter"/>
+          </p:nvPr>
+        </p:nvSpPr>
+        <p:spPr/>
+        <p:txBody>
+          <a:bodyPr/>
+          <a:lstStyle/>
+          <a:p>
+            <a:r>
               <a:t>Division of work as planned in the proposal; everyone shared analysis and writing.</a:t>
             </a:r>
           </a:p>
@@ -1004,6 +1080,12 @@
               <a:t>Weights: NF4 saves 2.60x instead of 4x, INT8 1.75x instead of 2x, because the embedding and LM head stay in 16-bit and NF4 stores a scale per 64 weights. At run time the KV cache and activations are not quantized, so the end-to-end saving shrinks toward 1x as batch and context grow.</a:t>
             </a:r>
           </a:p>
+          <a:p/>
+          <a:p>
+            <a:r>
+              <a:t>Numbers on this slide: 2.60×: NF4 weight saving (7B), not 4× (nominal 4× — LM head + embeddings stay 16-bit); 1.49×: NF4 total saving, B=32, L=2048 (KV cache and activations are not quantized); 1.90×: more KV-cache tokens (vLLM AWQ) (freed memory = more concurrent requests).</a:t>
+            </a:r>
+          </a:p>
         </p:txBody>
       </p:sp>
       <p:sp>
@@ -1074,6 +1156,12 @@
               <a:t>Left: prefill is compute-bound, so only formats that quantize activations (FP8) cut TTFT. Middle: decode at small batch is memory-bound; vLLM's fused kernels turn fewer bytes into speed, bitsandbytes does not. Right: at high batch only FP8 still raises throughput.</a:t>
             </a:r>
           </a:p>
+          <a:p/>
+          <a:p>
+            <a:r>
+              <a:t>Numbers on this slide: 2.44× faster: AWQ-INT4 on vLLM, batch 1 (Marlin kernel: fewer bytes = less time); 3.4× slower: LLM.int8() on HF, batch 1 (different method, activation path and engine, not only a different kernel); 1.73×: FP8 throughput at batch 256 (AWQ-INT4 there: no faster than BF16).</a:t>
+            </a:r>
+          </a:p>
         </p:txBody>
       </p:sp>
       <p:sp>
@@ -1144,6 +1232,12 @@
               <a:t>Blue cells: quantized is faster; red: slower. Weight-only 4-bit wins big at small batches and short prompts and fades out with batch size; FP8 wins everywhere; LLM.int8 never wins.</a:t>
             </a:r>
           </a:p>
+          <a:p/>
+          <a:p>
+            <a:r>
+              <a:t>Numbers on this slide: B ≈ 175: AWQ-INT4 stops winning (prompt 512; decode turns compute-bound, dequant no longer hidden); 1.6–1.8×: FP8 faster in every cell (halves bytes and raises the compute roof); 0.27–0.71×: LLM.int8() slower in every cell (never pays off on this GPU).</a:t>
+            </a:r>
+          </a:p>
         </p:txBody>
       </p:sp>
       <p:sp>
@@ -1214,6 +1308,12 @@
               <a:t>Weight-only 4-bit cuts the bytes 4x, so at small M it climbs the bandwidth roof 4x faster. It also reaches the compute roof at a 4x smaller M; from there the math still runs in BF16 and dequantization is pure overhead. FP8 W8A8 raises the compute roof itself.</a:t>
             </a:r>
           </a:p>
+          <a:p/>
+          <a:p>
+            <a:r>
+              <a:t>Numbers on this slide: 3.2×: Marlin W4A16 vs BF16 at M = 1 (memory-bound: 4x fewer bytes); M ≈ 333: W4A16 gain falls below 5% (compute-bound: dequant no longer hidden); 1.9×: FP8 W8A8 at M = 8192 (higher compute roof than BF16 (645 vs 218 TFLOP/s)).</a:t>
+            </a:r>
+          </a:p>
         </p:txBody>
       </p:sp>
       <p:sp>
@@ -1284,6 +1384,12 @@
               <a:t>LLM.int8() splits every matmul into casts, outlier extraction, INT8 quantization and two GEMMs. The GPU work is small; the Python and kernel-launch overhead dominates the step.</a:t>
             </a:r>
           </a:p>
+          <a:p/>
+          <a:p>
+            <a:r>
+              <a:t>Numbers on this slide: 97% → 28%: GPU busy: BF16 → INT8 (the rest of the step the GPU waits for the CPU); 3.7×: more kernel launches (INT8) (casts, outliers, quantize, 2 GEMMs per layer); 1.13×: NF4 vs BF16, whole model (its GEMV kernel alone: 2.4×; GPU busy 49%).</a:t>
+            </a:r>
+          </a:p>
         </p:txBody>
       </p:sp>
       <p:sp>
@@ -1354,6 +1460,12 @@
               <a:t>Same 300 requests, same output lengths for every configuration. Continuous batching and fused kernels matter more than the number format; among vLLM formats FP8 scales best.</a:t>
             </a:r>
           </a:p>
+          <a:p/>
+          <a:p>
+            <a:r>
+              <a:t>Numbers on this slide: 2.36×: lower TPOT, AWQ-INT4, 1 client (4.1 vs 9.6 ms per token); 5,388: tokens/s, FP8, 64 clients (BF16: 3,537 · AWQ: 5,180); 5.3×: vLLM vs HF, both BF16 (a serving-stack gap, not a quantization effect; the two stacks are also timed differently (HF has no warm-up and its TTFT excludes queueing)).</a:t>
+            </a:r>
+          </a:p>
         </p:txBody>
       </p:sp>
       <p:sp>
@@ -1421,7 +1533,7 @@
           <a:lstStyle/>
           <a:p>
             <a:r>
-              <a:t>Qwen3-8B reproduces the decode speedups of AWQ and FP8 and the LLM.int8() slowdown within a few percent. NF4 turns from a small gain into a loss because the 36-layer model is host-bound at batch 1, exactly like the 36-layer Qwen2.5-3B.</a:t>
+              <a:t>Numbers on this slide: ≤ 0.9 pp: 8-bit (GPTQ-INT8, FP8) vs BF16 (all sizes, GSM8K and MMLU; only LLM.int8() on 3B loses (−1.1 MMLU pp)); −2.8 to −0.6 pp: MMLU change, 4-bit formats (3B −2.8…−2.2 · 7B −1.6…−0.6 · 14B −1.9…−0.6); +3.1 / +3.7 pp: 14B 4-bit vs 7B BF16 (GSM8K / MMLU; 0.66× the weight memory, McNemar p &lt; 0.001).</a:t>
             </a:r>
           </a:p>
         </p:txBody>
@@ -5365,8 +5477,8 @@
         </p:blipFill>
         <p:spPr>
           <a:xfrm>
-            <a:off x="457200" y="1133856"/>
-            <a:ext cx="8229600" cy="1706585"/>
+            <a:off x="1215993" y="1133856"/>
+            <a:ext cx="6712013" cy="2148840"/>
           </a:xfrm>
           <a:prstGeom prst="rect">
             <a:avLst/>
@@ -5387,12 +5499,12 @@
         </p:nvSpPr>
         <p:spPr>
           <a:xfrm>
-            <a:off x="457200" y="3291839"/>
-            <a:ext cx="2651760" cy="868680"/>
+            <a:off x="457200" y="3374136"/>
+            <a:ext cx="2651760" cy="786384"/>
           </a:xfrm>
           <a:prstGeom prst="roundRect">
             <a:avLst>
-              <a:gd name="adj" fmla="val 8421"/>
+              <a:gd name="adj" fmla="val 9302"/>
             </a:avLst>
           </a:prstGeom>
           <a:solidFill>
@@ -5433,7 +5545,7 @@
         </p:nvSpPr>
         <p:spPr>
           <a:xfrm>
-            <a:off x="585216" y="3364991"/>
+            <a:off x="585216" y="3429000"/>
             <a:ext cx="2432304" cy="384048"/>
           </a:xfrm>
           <a:prstGeom prst="rect">
@@ -5449,7 +5561,7 @@
           <a:p>
             <a:pPr algn="l"/>
             <a:r>
-              <a:rPr sz="2000" b="1" i="0">
+              <a:rPr sz="2200" b="1" i="0">
                 <a:solidFill>
                   <a:srgbClr val="003865"/>
                 </a:solidFill>
@@ -5468,8 +5580,8 @@
         </p:nvSpPr>
         <p:spPr>
           <a:xfrm>
-            <a:off x="585216" y="3749039"/>
-            <a:ext cx="2432304" cy="356615"/>
+            <a:off x="585216" y="3794760"/>
+            <a:ext cx="2432304" cy="329184"/>
           </a:xfrm>
           <a:prstGeom prst="rect">
             <a:avLst/>
@@ -5482,31 +5594,15 @@
           </a:bodyPr>
           <a:lstStyle/>
           <a:p>
-            <a:pPr algn="l">
-              <a:spcAft>
-                <a:spcPts val="200"/>
-              </a:spcAft>
-            </a:pPr>
-            <a:r>
-              <a:rPr sz="850" b="0" i="0">
+            <a:pPr algn="l"/>
+            <a:r>
+              <a:rPr sz="1200" b="0" i="0">
                 <a:solidFill>
                   <a:srgbClr val="1F2933"/>
                 </a:solidFill>
                 <a:latin typeface="Arial"/>
               </a:rPr>
-              <a:t>AWQ-INT4 decode speedup at B=1</a:t>
-            </a:r>
-          </a:p>
-          <a:p>
-            <a:pPr algn="l"/>
-            <a:r>
-              <a:rPr sz="750" b="0" i="0">
-                <a:solidFill>
-                  <a:srgbClr val="5B6770"/>
-                </a:solidFill>
-                <a:latin typeface="Arial"/>
-              </a:rPr>
-              <a:t>Qwen3-8B vs Qwen2.5-7B; FP8 1.54× vs 1.59×</a:t>
+              <a:t>AWQ speedup: Qwen3 vs Qwen2.5</a:t>
             </a:r>
           </a:p>
         </p:txBody>
@@ -5525,12 +5621,12 @@
         </p:nvSpPr>
         <p:spPr>
           <a:xfrm>
-            <a:off x="3246120" y="3291839"/>
-            <a:ext cx="2651760" cy="868680"/>
+            <a:off x="3246120" y="3374136"/>
+            <a:ext cx="2651760" cy="786384"/>
           </a:xfrm>
           <a:prstGeom prst="roundRect">
             <a:avLst>
-              <a:gd name="adj" fmla="val 8421"/>
+              <a:gd name="adj" fmla="val 9302"/>
             </a:avLst>
           </a:prstGeom>
           <a:solidFill>
@@ -5571,7 +5667,7 @@
         </p:nvSpPr>
         <p:spPr>
           <a:xfrm>
-            <a:off x="3374136" y="3364991"/>
+            <a:off x="3374136" y="3429000"/>
             <a:ext cx="2432304" cy="384048"/>
           </a:xfrm>
           <a:prstGeom prst="rect">
@@ -5587,7 +5683,7 @@
           <a:p>
             <a:pPr algn="l"/>
             <a:r>
-              <a:rPr sz="2000" b="1" i="0">
+              <a:rPr sz="2200" b="1" i="0">
                 <a:solidFill>
                   <a:srgbClr val="003865"/>
                 </a:solidFill>
@@ -5606,8 +5702,8 @@
         </p:nvSpPr>
         <p:spPr>
           <a:xfrm>
-            <a:off x="3374136" y="3749039"/>
-            <a:ext cx="2432304" cy="356615"/>
+            <a:off x="3374136" y="3794760"/>
+            <a:ext cx="2432304" cy="329184"/>
           </a:xfrm>
           <a:prstGeom prst="rect">
             <a:avLst/>
@@ -5620,31 +5716,15 @@
           </a:bodyPr>
           <a:lstStyle/>
           <a:p>
-            <a:pPr algn="l">
-              <a:spcAft>
-                <a:spcPts val="200"/>
-              </a:spcAft>
-            </a:pPr>
-            <a:r>
-              <a:rPr sz="850" b="0" i="0">
+            <a:pPr algn="l"/>
+            <a:r>
+              <a:rPr sz="1200" b="0" i="0">
                 <a:solidFill>
                   <a:srgbClr val="1F2933"/>
                 </a:solidFill>
                 <a:latin typeface="Arial"/>
               </a:rPr>
-              <a:t>NF4 at B=1 on Qwen3-8B</a:t>
-            </a:r>
-          </a:p>
-          <a:p>
-            <a:pPr algn="l"/>
-            <a:r>
-              <a:rPr sz="750" b="0" i="0">
-                <a:solidFill>
-                  <a:srgbClr val="5B6770"/>
-                </a:solidFill>
-                <a:latin typeface="Arial"/>
-              </a:rPr>
-              <a:t>36 layers → host-bound, as on Qwen2.5-3B</a:t>
+              <a:t>NF4 on Qwen3-8B (36 layers)</a:t>
             </a:r>
           </a:p>
         </p:txBody>
@@ -5663,12 +5743,12 @@
         </p:nvSpPr>
         <p:spPr>
           <a:xfrm>
-            <a:off x="6035040" y="3291839"/>
-            <a:ext cx="2651760" cy="868680"/>
+            <a:off x="6035040" y="3374136"/>
+            <a:ext cx="2651760" cy="786384"/>
           </a:xfrm>
           <a:prstGeom prst="roundRect">
             <a:avLst>
-              <a:gd name="adj" fmla="val 8421"/>
+              <a:gd name="adj" fmla="val 9302"/>
             </a:avLst>
           </a:prstGeom>
           <a:solidFill>
@@ -5709,7 +5789,7 @@
         </p:nvSpPr>
         <p:spPr>
           <a:xfrm>
-            <a:off x="6163055" y="3364991"/>
+            <a:off x="6163055" y="3429000"/>
             <a:ext cx="2432304" cy="384048"/>
           </a:xfrm>
           <a:prstGeom prst="rect">
@@ -5725,7 +5805,7 @@
           <a:p>
             <a:pPr algn="l"/>
             <a:r>
-              <a:rPr sz="2000" b="1" i="0">
+              <a:rPr sz="2200" b="1" i="0">
                 <a:solidFill>
                   <a:srgbClr val="003865"/>
                 </a:solidFill>
@@ -5744,8 +5824,8 @@
         </p:nvSpPr>
         <p:spPr>
           <a:xfrm>
-            <a:off x="6163055" y="3749039"/>
-            <a:ext cx="2432304" cy="356615"/>
+            <a:off x="6163055" y="3794760"/>
+            <a:ext cx="2432304" cy="329184"/>
           </a:xfrm>
           <a:prstGeom prst="rect">
             <a:avLst/>
@@ -5758,31 +5838,15 @@
           </a:bodyPr>
           <a:lstStyle/>
           <a:p>
-            <a:pPr algn="l">
-              <a:spcAft>
-                <a:spcPts val="200"/>
-              </a:spcAft>
-            </a:pPr>
-            <a:r>
-              <a:rPr sz="850" b="0" i="0">
+            <a:pPr algn="l"/>
+            <a:r>
+              <a:rPr sz="1200" b="0" i="0">
                 <a:solidFill>
                   <a:srgbClr val="1F2933"/>
                 </a:solidFill>
                 <a:latin typeface="Arial"/>
               </a:rPr>
-              <a:t>MMLU: 32B AWQ-INT4 vs 8B BF16</a:t>
-            </a:r>
-          </a:p>
-          <a:p>
-            <a:pPr algn="l"/>
-            <a:r>
-              <a:rPr sz="750" b="0" i="0">
-                <a:solidFill>
-                  <a:srgbClr val="5B6770"/>
-                </a:solidFill>
-                <a:latin typeface="Arial"/>
-              </a:rPr>
-              <a:t>19.6 vs 16.4 GB; BF16 32B needs 66 GB</a:t>
+              <a:t>MMLU: 32B 4-bit vs 8B BF16</a:t>
             </a:r>
           </a:p>
         </p:txBody>
@@ -5854,7 +5918,7 @@
           <a:p>
             <a:r>
               <a:rPr sz="1400"/>
-              <a:t>Bit-width alone predicts little — the kernel and the regime decide</a:t>
+              <a:t>Bit-width alone predicts little — the implementation and the regime decide</a:t>
             </a:r>
           </a:p>
         </p:txBody>
@@ -6015,13 +6079,13 @@
           <a:p>
             <a:pPr algn="l"/>
             <a:r>
-              <a:rPr sz="1050" b="1" i="0">
+              <a:rPr sz="1300" b="1" i="0">
                 <a:solidFill>
                   <a:srgbClr val="003865"/>
                 </a:solidFill>
                 <a:latin typeface="Arial"/>
               </a:rPr>
-              <a:t>Plan memory with the real ratio</a:t>
+              <a:t>Plan with the real ratio</a:t>
             </a:r>
           </a:p>
         </p:txBody>
@@ -6034,8 +6098,8 @@
         </p:nvSpPr>
         <p:spPr>
           <a:xfrm>
-            <a:off x="585216" y="1682495"/>
-            <a:ext cx="914400" cy="731520"/>
+            <a:off x="585216" y="1664207"/>
+            <a:ext cx="1188720" cy="777240"/>
           </a:xfrm>
           <a:prstGeom prst="rect">
             <a:avLst/>
@@ -6050,7 +6114,7 @@
           <a:p>
             <a:pPr algn="l"/>
             <a:r>
-              <a:rPr sz="1900" b="1" i="0">
+              <a:rPr sz="2200" b="1" i="0">
                 <a:solidFill>
                   <a:srgbClr val="00599B"/>
                 </a:solidFill>
@@ -6069,8 +6133,8 @@
         </p:nvSpPr>
         <p:spPr>
           <a:xfrm>
-            <a:off x="1499616" y="1645920"/>
-            <a:ext cx="1545336" cy="850392"/>
+            <a:off x="1792224" y="1664207"/>
+            <a:ext cx="1252728" cy="813816"/>
           </a:xfrm>
           <a:prstGeom prst="rect">
             <a:avLst/>
@@ -6085,13 +6149,13 @@
           <a:p>
             <a:pPr algn="l"/>
             <a:r>
-              <a:rPr sz="850" b="0" i="0">
+              <a:rPr sz="1200" b="0" i="0">
                 <a:solidFill>
                   <a:srgbClr val="1F2933"/>
                 </a:solidFill>
                 <a:latin typeface="Arial"/>
               </a:rPr>
-              <a:t>4-bit weight saving on Qwen2.5-7B, not 4×; KV cache and activations stay 16-bit</a:t>
+              <a:t>4-bit weight saving, not 4×</a:t>
             </a:r>
           </a:p>
         </p:txBody>
@@ -6252,13 +6316,13 @@
           <a:p>
             <a:pPr algn="l"/>
             <a:r>
-              <a:rPr sz="1050" b="1" i="0">
+              <a:rPr sz="1300" b="1" i="0">
                 <a:solidFill>
                   <a:srgbClr val="003865"/>
                 </a:solidFill>
                 <a:latin typeface="Arial"/>
               </a:rPr>
-              <a:t>Few users: 4-bit + fused kernel</a:t>
+              <a:t>Few users: 4-bit + Marlin</a:t>
             </a:r>
           </a:p>
         </p:txBody>
@@ -6271,8 +6335,8 @@
         </p:nvSpPr>
         <p:spPr>
           <a:xfrm>
-            <a:off x="3383280" y="1682495"/>
-            <a:ext cx="914400" cy="731520"/>
+            <a:off x="3383280" y="1664207"/>
+            <a:ext cx="1188720" cy="777240"/>
           </a:xfrm>
           <a:prstGeom prst="rect">
             <a:avLst/>
@@ -6287,7 +6351,7 @@
           <a:p>
             <a:pPr algn="l"/>
             <a:r>
-              <a:rPr sz="1900" b="1" i="0">
+              <a:rPr sz="2200" b="1" i="0">
                 <a:solidFill>
                   <a:srgbClr val="00599B"/>
                 </a:solidFill>
@@ -6306,8 +6370,8 @@
         </p:nvSpPr>
         <p:spPr>
           <a:xfrm>
-            <a:off x="4297680" y="1645920"/>
-            <a:ext cx="1545336" cy="850392"/>
+            <a:off x="4590288" y="1664207"/>
+            <a:ext cx="1252728" cy="813816"/>
           </a:xfrm>
           <a:prstGeom prst="rect">
             <a:avLst/>
@@ -6322,13 +6386,13 @@
           <a:p>
             <a:pPr algn="l"/>
             <a:r>
-              <a:rPr sz="850" b="0" i="0">
+              <a:rPr sz="1200" b="0" i="0">
                 <a:solidFill>
                   <a:srgbClr val="1F2933"/>
                 </a:solidFill>
                 <a:latin typeface="Arial"/>
               </a:rPr>
-              <a:t>faster decode with AWQ-INT4 + Marlin at batch size 1</a:t>
+              <a:t>faster decode at batch 1</a:t>
             </a:r>
           </a:p>
         </p:txBody>
@@ -6489,13 +6553,13 @@
           <a:p>
             <a:pPr algn="l"/>
             <a:r>
-              <a:rPr sz="1050" b="1" i="0">
+              <a:rPr sz="1300" b="1" i="0">
                 <a:solidFill>
                   <a:srgbClr val="003865"/>
                 </a:solidFill>
                 <a:latin typeface="Arial"/>
               </a:rPr>
-              <a:t>High throughput: FP8 W8A8</a:t>
+              <a:t>Many users: FP8 W8A8</a:t>
             </a:r>
           </a:p>
         </p:txBody>
@@ -6508,8 +6572,8 @@
         </p:nvSpPr>
         <p:spPr>
           <a:xfrm>
-            <a:off x="6181344" y="1682495"/>
-            <a:ext cx="914400" cy="731520"/>
+            <a:off x="6181344" y="1664207"/>
+            <a:ext cx="1188720" cy="777240"/>
           </a:xfrm>
           <a:prstGeom prst="rect">
             <a:avLst/>
@@ -6524,7 +6588,7 @@
           <a:p>
             <a:pPr algn="l"/>
             <a:r>
-              <a:rPr sz="1900" b="1" i="0">
+              <a:rPr sz="2200" b="1" i="0">
                 <a:solidFill>
                   <a:srgbClr val="00599B"/>
                 </a:solidFill>
@@ -6543,8 +6607,8 @@
         </p:nvSpPr>
         <p:spPr>
           <a:xfrm>
-            <a:off x="7095744" y="1645920"/>
-            <a:ext cx="1545336" cy="850392"/>
+            <a:off x="7388352" y="1664207"/>
+            <a:ext cx="1252728" cy="813816"/>
           </a:xfrm>
           <a:prstGeom prst="rect">
             <a:avLst/>
@@ -6559,13 +6623,13 @@
           <a:p>
             <a:pPr algn="l"/>
             <a:r>
-              <a:rPr sz="850" b="0" i="0">
+              <a:rPr sz="1200" b="0" i="0">
                 <a:solidFill>
                   <a:srgbClr val="1F2933"/>
                 </a:solidFill>
                 <a:latin typeface="Arial"/>
               </a:rPr>
-              <a:t>the BF16 throughput at batch 256, where 4-bit weight-only gains have vanished</a:t>
+              <a:t>BF16 throughput at batch 256</a:t>
             </a:r>
           </a:p>
         </p:txBody>
@@ -6726,13 +6790,13 @@
           <a:p>
             <a:pPr algn="l"/>
             <a:r>
-              <a:rPr sz="1050" b="1" i="0">
+              <a:rPr sz="1300" b="1" i="0">
                 <a:solidFill>
                   <a:srgbClr val="003865"/>
                 </a:solidFill>
                 <a:latin typeface="Arial"/>
               </a:rPr>
-              <a:t>bitsandbytes: memory, not speed</a:t>
+              <a:t>bitsandbytes: memory only</a:t>
             </a:r>
           </a:p>
         </p:txBody>
@@ -6745,8 +6809,8 @@
         </p:nvSpPr>
         <p:spPr>
           <a:xfrm>
-            <a:off x="585216" y="3227832"/>
-            <a:ext cx="914400" cy="731520"/>
+            <a:off x="585216" y="3209544"/>
+            <a:ext cx="1188720" cy="777240"/>
           </a:xfrm>
           <a:prstGeom prst="rect">
             <a:avLst/>
@@ -6761,7 +6825,7 @@
           <a:p>
             <a:pPr algn="l"/>
             <a:r>
-              <a:rPr sz="1900" b="1" i="0">
+              <a:rPr sz="2200" b="1" i="0">
                 <a:solidFill>
                   <a:srgbClr val="00599B"/>
                 </a:solidFill>
@@ -6780,8 +6844,8 @@
         </p:nvSpPr>
         <p:spPr>
           <a:xfrm>
-            <a:off x="1499616" y="3191256"/>
-            <a:ext cx="1545336" cy="850392"/>
+            <a:off x="1792224" y="3209544"/>
+            <a:ext cx="1252728" cy="813816"/>
           </a:xfrm>
           <a:prstGeom prst="rect">
             <a:avLst/>
@@ -6796,13 +6860,13 @@
           <a:p>
             <a:pPr algn="l"/>
             <a:r>
-              <a:rPr sz="850" b="0" i="0">
+              <a:rPr sz="1200" b="0" i="0">
                 <a:solidFill>
                   <a:srgbClr val="1F2933"/>
                 </a:solidFill>
                 <a:latin typeface="Arial"/>
               </a:rPr>
-              <a:t>slower decode with LLM.int8() at batch size 1; NF4 helps only tiny batches</a:t>
+              <a:t>slower decode with LLM.int8()</a:t>
             </a:r>
           </a:p>
         </p:txBody>
@@ -6963,13 +7027,13 @@
           <a:p>
             <a:pPr algn="l"/>
             <a:r>
-              <a:rPr sz="1050" b="1" i="0">
+              <a:rPr sz="1300" b="1" i="0">
                 <a:solidFill>
                   <a:srgbClr val="003865"/>
                 </a:solidFill>
                 <a:latin typeface="Arial"/>
               </a:rPr>
-              <a:t>Quality: small, but per model</a:t>
+              <a:t>Quality: check per model</a:t>
             </a:r>
           </a:p>
         </p:txBody>
@@ -6982,8 +7046,8 @@
         </p:nvSpPr>
         <p:spPr>
           <a:xfrm>
-            <a:off x="3383280" y="3227832"/>
-            <a:ext cx="914400" cy="731520"/>
+            <a:off x="3383280" y="3209544"/>
+            <a:ext cx="1188720" cy="777240"/>
           </a:xfrm>
           <a:prstGeom prst="rect">
             <a:avLst/>
@@ -6998,7 +7062,7 @@
           <a:p>
             <a:pPr algn="l"/>
             <a:r>
-              <a:rPr sz="1900" b="1" i="0">
+              <a:rPr sz="2200" b="1" i="0">
                 <a:solidFill>
                   <a:srgbClr val="00599B"/>
                 </a:solidFill>
@@ -7017,8 +7081,8 @@
         </p:nvSpPr>
         <p:spPr>
           <a:xfrm>
-            <a:off x="4297680" y="3191256"/>
-            <a:ext cx="1545336" cy="850392"/>
+            <a:off x="4590288" y="3209544"/>
+            <a:ext cx="1252728" cy="813816"/>
           </a:xfrm>
           <a:prstGeom prst="rect">
             <a:avLst/>
@@ -7033,13 +7097,13 @@
           <a:p>
             <a:pPr algn="l"/>
             <a:r>
-              <a:rPr sz="850" b="0" i="0">
+              <a:rPr sz="1200" b="0" i="0">
                 <a:solidFill>
                   <a:srgbClr val="1F2933"/>
                 </a:solidFill>
                 <a:latin typeface="Arial"/>
               </a:rPr>
-              <a:t>worst 4-bit MMLU loss (Qwen2.5-3B); 8-bit within 0.9 pp, yet FP8 = AWQ on Qwen3-8B — measure it</a:t>
+              <a:t>worst 4-bit MMLU loss (3B)</a:t>
             </a:r>
           </a:p>
         </p:txBody>
@@ -7200,7 +7264,7 @@
           <a:p>
             <a:pPr algn="l"/>
             <a:r>
-              <a:rPr sz="1050" b="1" i="0">
+              <a:rPr sz="1300" b="1" i="0">
                 <a:solidFill>
                   <a:srgbClr val="003865"/>
                 </a:solidFill>
@@ -7219,8 +7283,8 @@
         </p:nvSpPr>
         <p:spPr>
           <a:xfrm>
-            <a:off x="6181344" y="3227832"/>
-            <a:ext cx="914400" cy="731520"/>
+            <a:off x="6181344" y="3209544"/>
+            <a:ext cx="1188720" cy="777240"/>
           </a:xfrm>
           <a:prstGeom prst="rect">
             <a:avLst/>
@@ -7235,7 +7299,7 @@
           <a:p>
             <a:pPr algn="l"/>
             <a:r>
-              <a:rPr sz="1900" b="1" i="0">
+              <a:rPr sz="2200" b="1" i="0">
                 <a:solidFill>
                   <a:srgbClr val="00599B"/>
                 </a:solidFill>
@@ -7254,8 +7318,8 @@
         </p:nvSpPr>
         <p:spPr>
           <a:xfrm>
-            <a:off x="7095744" y="3191256"/>
-            <a:ext cx="1545336" cy="850392"/>
+            <a:off x="7388352" y="3209544"/>
+            <a:ext cx="1252728" cy="813816"/>
           </a:xfrm>
           <a:prstGeom prst="rect">
             <a:avLst/>
@@ -7270,13 +7334,13 @@
           <a:p>
             <a:pPr algn="l"/>
             <a:r>
-              <a:rPr sz="850" b="0" i="0">
+              <a:rPr sz="1200" b="0" i="0">
                 <a:solidFill>
                   <a:srgbClr val="1F2933"/>
                 </a:solidFill>
                 <a:latin typeface="Arial"/>
               </a:rPr>
-              <a:t>MMLU of 14B AWQ-INT4 vs 71.4% for 7B BF16, with less weight memory</a:t>
+              <a:t>MMLU, 14B 4-bit (vs 71.4% 7B BF16)</a:t>
             </a:r>
           </a:p>
         </p:txBody>
@@ -7544,13 +7608,13 @@
           <a:p>
             <a:pPr algn="l"/>
             <a:r>
-              <a:rPr sz="900" b="0" i="0">
+              <a:rPr sz="1100" b="0" i="0">
                 <a:solidFill>
                   <a:srgbClr val="00599B"/>
                 </a:solidFill>
                 <a:latin typeface="Arial"/>
               </a:rPr>
-              <a:t>Baseline + memory (Q1)</a:t>
+              <a:t>Harness + memory (Q1)</a:t>
             </a:r>
           </a:p>
         </p:txBody>
@@ -7563,8 +7627,8 @@
         </p:nvSpPr>
         <p:spPr>
           <a:xfrm>
-            <a:off x="603504" y="1737360"/>
-            <a:ext cx="2377440" cy="329184"/>
+            <a:off x="603504" y="1719072"/>
+            <a:ext cx="2377440" cy="365760"/>
           </a:xfrm>
           <a:prstGeom prst="rect">
             <a:avLst/>
@@ -7579,13 +7643,13 @@
           <a:p>
             <a:pPr algn="l"/>
             <a:r>
-              <a:rPr sz="850" b="0" i="0">
+              <a:rPr sz="1050" b="0" i="0">
                 <a:solidFill>
                   <a:srgbClr val="1F2933"/>
                 </a:solidFill>
                 <a:latin typeface="Arial"/>
               </a:rPr>
-              <a:t>Benchmark harness, memory model, capacity</a:t>
+              <a:t>Harness, memory model, capacity</a:t>
             </a:r>
           </a:p>
         </p:txBody>
@@ -7781,13 +7845,13 @@
           <a:p>
             <a:pPr algn="l"/>
             <a:r>
-              <a:rPr sz="900" b="0" i="0">
+              <a:rPr sz="1100" b="0" i="0">
                 <a:solidFill>
                   <a:srgbClr val="00599B"/>
                 </a:solidFill>
                 <a:latin typeface="Arial"/>
               </a:rPr>
-              <a:t>Controlled sweeps (Q2)</a:t>
+              <a:t>Sweeps + kernels (Q2, Q3)</a:t>
             </a:r>
           </a:p>
         </p:txBody>
@@ -7800,8 +7864,8 @@
         </p:nvSpPr>
         <p:spPr>
           <a:xfrm>
-            <a:off x="3392424" y="1737360"/>
-            <a:ext cx="2377440" cy="329184"/>
+            <a:off x="3392424" y="1719072"/>
+            <a:ext cx="2377440" cy="365760"/>
           </a:xfrm>
           <a:prstGeom prst="rect">
             <a:avLst/>
@@ -7816,13 +7880,13 @@
           <a:p>
             <a:pPr algn="l"/>
             <a:r>
-              <a:rPr sz="850" b="0" i="0">
+              <a:rPr sz="1050" b="0" i="0">
                 <a:solidFill>
                   <a:srgbClr val="1F2933"/>
                 </a:solidFill>
                 <a:latin typeface="Arial"/>
               </a:rPr>
-              <a:t>Precision × batch × length grids, kernels, profiling</a:t>
+              <a:t>Speed grids, kernels, profiling</a:t>
             </a:r>
           </a:p>
         </p:txBody>
@@ -8018,13 +8082,13 @@
           <a:p>
             <a:pPr algn="l"/>
             <a:r>
-              <a:rPr sz="900" b="0" i="0">
+              <a:rPr sz="1100" b="0" i="0">
                 <a:solidFill>
                   <a:srgbClr val="00599B"/>
                 </a:solidFill>
                 <a:latin typeface="Arial"/>
               </a:rPr>
-              <a:t>Real workload + quality (Q3, Q4)</a:t>
+              <a:t>Traffic + quality (Q4)</a:t>
             </a:r>
           </a:p>
         </p:txBody>
@@ -8037,8 +8101,8 @@
         </p:nvSpPr>
         <p:spPr>
           <a:xfrm>
-            <a:off x="6181344" y="1737360"/>
-            <a:ext cx="2377440" cy="329184"/>
+            <a:off x="6181344" y="1719072"/>
+            <a:ext cx="2377440" cy="365760"/>
           </a:xfrm>
           <a:prstGeom prst="rect">
             <a:avLst/>
@@ -8053,13 +8117,13 @@
           <a:p>
             <a:pPr algn="l"/>
             <a:r>
-              <a:rPr sz="850" b="0" i="0">
+              <a:rPr sz="1050" b="0" i="0">
                 <a:solidFill>
                   <a:srgbClr val="1F2933"/>
                 </a:solidFill>
                 <a:latin typeface="Arial"/>
               </a:rPr>
-              <a:t>ShareGPT serving, WikiText-2, GSM8K, MMLU</a:t>
+              <a:t>ShareGPT, WikiText-2, GSM8K, MMLU</a:t>
             </a:r>
           </a:p>
         </p:txBody>
@@ -8203,11 +8267,11 @@
           <a:p>
             <a:pPr algn="l">
               <a:spcAft>
-                <a:spcPts val="400"/>
+                <a:spcPts val="300"/>
               </a:spcAft>
             </a:pPr>
             <a:r>
-              <a:rPr sz="850" b="0" i="0">
+              <a:rPr sz="1000" b="0" i="0">
                 <a:solidFill>
                   <a:srgbClr val="1F2933"/>
                 </a:solidFill>
@@ -8219,11 +8283,11 @@
           <a:p>
             <a:pPr algn="l">
               <a:spcAft>
-                <a:spcPts val="400"/>
+                <a:spcPts val="300"/>
               </a:spcAft>
             </a:pPr>
             <a:r>
-              <a:rPr sz="850" b="0" i="0">
+              <a:rPr sz="1000" b="0" i="0">
                 <a:solidFill>
                   <a:srgbClr val="1F2933"/>
                 </a:solidFill>
@@ -8235,45 +8299,45 @@
           <a:p>
             <a:pPr algn="l">
               <a:spcAft>
-                <a:spcPts val="400"/>
+                <a:spcPts val="300"/>
               </a:spcAft>
             </a:pPr>
             <a:r>
-              <a:rPr sz="850" b="0" i="0">
+              <a:rPr sz="1000" b="0" i="0">
                 <a:solidFill>
                   <a:srgbClr val="1F2933"/>
                 </a:solidFill>
                 <a:latin typeface="Arial"/>
               </a:rPr>
-              <a:t>Frantar et al., MARLIN mixed-precision kernels, PPoPP 2025  ·  Kwon et al., vLLM / PagedAttention, SOSP 2023</a:t>
+              <a:t>Frantar et al., MARLIN, PPoPP 2025  ·  Kwon et al., vLLM, SOSP 2023  ·  Lin et al., QServe, MLSys 2025</a:t>
             </a:r>
           </a:p>
           <a:p>
             <a:pPr algn="l">
               <a:spcAft>
-                <a:spcPts val="400"/>
+                <a:spcPts val="300"/>
               </a:spcAft>
             </a:pPr>
             <a:r>
-              <a:rPr sz="850" b="0" i="0">
+              <a:rPr sz="1000" b="0" i="0">
                 <a:solidFill>
                   <a:srgbClr val="1F2933"/>
                 </a:solidFill>
                 <a:latin typeface="Arial"/>
               </a:rPr>
-              <a:t>Micikevicius et al., FP8 Formats for Deep Learning, 2022  ·  Williams et al., Roofline, CACM 2009</a:t>
+              <a:t>Micikevicius et al., FP8 Formats, 2022  ·  Williams et al., Roofline, CACM 2009  ·  Kurtic et al., 2024</a:t>
             </a:r>
           </a:p>
           <a:p>
             <a:pPr algn="l"/>
             <a:r>
-              <a:rPr sz="850" b="0" i="0">
+              <a:rPr sz="1000" b="0" i="0">
                 <a:solidFill>
                   <a:srgbClr val="1F2933"/>
                 </a:solidFill>
                 <a:latin typeface="Arial"/>
               </a:rPr>
-              <a:t>Qwen Team, Qwen2.5 / Qwen3 Technical Reports, 2024/2025  ·  Merity et al., WikiText (ICLR 2017)  ·  Cobbe et al., GSM8K, 2021  ·  Hendrycks et al., MMLU (ICLR 2021)</a:t>
+              <a:t>Qwen2.5 / Qwen3 Technical Reports  ·  WikiText-2, GSM8K, MMLU benchmarks</a:t>
             </a:r>
           </a:p>
         </p:txBody>
@@ -8286,8 +8350,8 @@
         </p:nvSpPr>
         <p:spPr>
           <a:xfrm>
-            <a:off x="5486400" y="4343400"/>
-            <a:ext cx="3200400" cy="457200"/>
+            <a:off x="4754880" y="4315968"/>
+            <a:ext cx="3931920" cy="457200"/>
           </a:xfrm>
           <a:prstGeom prst="rect">
             <a:avLst/>
@@ -8302,7 +8366,7 @@
           <a:p>
             <a:pPr algn="l"/>
             <a:r>
-              <a:rPr sz="800" b="1" i="0">
+              <a:rPr sz="1000" b="1" i="0">
                 <a:solidFill>
                   <a:srgbClr val="003865"/>
                 </a:solidFill>
@@ -8311,7 +8375,7 @@
               <a:t>Code, data and report: </a:t>
             </a:r>
             <a:r>
-              <a:rPr sz="800" b="0" i="0">
+              <a:rPr sz="1000" b="0" i="0">
                 <a:solidFill>
                   <a:srgbClr val="5B6770"/>
                 </a:solidFill>
@@ -8585,11 +8649,11 @@
           <a:p>
             <a:pPr algn="l">
               <a:spcAft>
-                <a:spcPts val="400"/>
+                <a:spcPts val="600"/>
               </a:spcAft>
             </a:pPr>
             <a:r>
-              <a:rPr sz="950" b="1" i="0">
+              <a:rPr sz="1150" b="1" i="0">
                 <a:solidFill>
                   <a:srgbClr val="003865"/>
                 </a:solidFill>
@@ -8597,40 +8661,31 @@
               </a:rPr>
               <a:t>NVIDIA RTX 5090</a:t>
             </a:r>
-            <a:r>
-              <a:rPr sz="950" b="0" i="0">
+          </a:p>
+          <a:p>
+            <a:pPr algn="l">
+              <a:spcAft>
+                <a:spcPts val="600"/>
+              </a:spcAft>
+            </a:pPr>
+            <a:r>
+              <a:rPr sz="1150" b="0" i="0">
                 <a:solidFill>
                   <a:srgbClr val="1F2933"/>
                 </a:solidFill>
                 <a:latin typeface="Arial"/>
               </a:rPr>
-              <a:t> (Blackwell, sm_120)</a:t>
+              <a:t>Blackwell, 32 GB, 575 W</a:t>
             </a:r>
           </a:p>
           <a:p>
             <a:pPr algn="l">
               <a:spcAft>
-                <a:spcPts val="400"/>
+                <a:spcPts val="600"/>
               </a:spcAft>
             </a:pPr>
             <a:r>
-              <a:rPr sz="950" b="0" i="0">
-                <a:solidFill>
-                  <a:srgbClr val="1F2933"/>
-                </a:solidFill>
-                <a:latin typeface="Arial"/>
-              </a:rPr>
-              <a:t>32 GB GDDR7 · 170 SMs · 575 W</a:t>
-            </a:r>
-          </a:p>
-          <a:p>
-            <a:pPr algn="l">
-              <a:spcAft>
-                <a:spcPts val="400"/>
-              </a:spcAft>
-            </a:pPr>
-            <a:r>
-              <a:rPr sz="950" b="1" i="0">
+              <a:rPr sz="1150" b="1" i="0">
                 <a:solidFill>
                   <a:srgbClr val="003865"/>
                 </a:solidFill>
@@ -8639,44 +8694,44 @@
               <a:t>Measured: </a:t>
             </a:r>
             <a:r>
-              <a:rPr sz="950" b="0" i="0">
+              <a:rPr sz="1150" b="0" i="0">
                 <a:solidFill>
                   <a:srgbClr val="1F2933"/>
                 </a:solidFill>
                 <a:latin typeface="Arial"/>
               </a:rPr>
-              <a:t>1.52 TB/s DRAM, 218 TFLOP/s BF16, 645 TFLOP/s FP8</a:t>
+              <a:t>1.61 TB/s, 218 TFLOP/s BF16, 645 FP8</a:t>
             </a:r>
           </a:p>
           <a:p>
             <a:pPr algn="l">
               <a:spcAft>
-                <a:spcPts val="400"/>
+                <a:spcPts val="600"/>
               </a:spcAft>
             </a:pPr>
             <a:r>
-              <a:rPr sz="950" b="1" i="0">
+              <a:rPr sz="1150" b="1" i="0">
                 <a:solidFill>
                   <a:srgbClr val="003865"/>
                 </a:solidFill>
                 <a:latin typeface="Arial"/>
               </a:rPr>
-              <a:t>Software: </a:t>
-            </a:r>
-            <a:r>
-              <a:rPr sz="950" b="0" i="0">
+              <a:t>Stacks: </a:t>
+            </a:r>
+            <a:r>
+              <a:rPr sz="1150" b="0" i="0">
                 <a:solidFill>
                   <a:srgbClr val="1F2933"/>
                 </a:solidFill>
                 <a:latin typeface="Arial"/>
               </a:rPr>
-              <a:t>PyTorch 2.13, Transformers 5.19, bitsandbytes 0.50, vLLM 0.32</a:t>
+              <a:t>Transformers + bitsandbytes; vLLM</a:t>
             </a:r>
           </a:p>
           <a:p>
             <a:pPr algn="l"/>
             <a:r>
-              <a:rPr sz="950" b="1" i="0">
+              <a:rPr sz="1150" b="1" i="0">
                 <a:solidFill>
                   <a:srgbClr val="003865"/>
                 </a:solidFill>
@@ -8685,13 +8740,13 @@
               <a:t>Models: </a:t>
             </a:r>
             <a:r>
-              <a:rPr sz="950" b="0" i="0">
+              <a:rPr sz="1150" b="0" i="0">
                 <a:solidFill>
                   <a:srgbClr val="1F2933"/>
                 </a:solidFill>
                 <a:latin typeface="Arial"/>
               </a:rPr>
-              <a:t>Qwen2.5-3B / 7B / 14B-Instruct; Qwen3-8B and 32B (4-bit only)</a:t>
+              <a:t>Qwen2.5-3B / 7B / 14B; Qwen3-8B, 32B</a:t>
             </a:r>
           </a:p>
         </p:txBody>
@@ -8887,13 +8942,13 @@
           <a:p>
             <a:pPr algn="l"/>
             <a:r>
-              <a:rPr sz="850" b="1" i="0">
+              <a:rPr sz="1100" b="1" i="0">
                 <a:solidFill>
                   <a:srgbClr val="5B6770"/>
                 </a:solidFill>
                 <a:latin typeface="Arial"/>
               </a:rPr>
-              <a:t>Hugging Face (eager) + bitsandbytes, quantized at load</a:t>
+              <a:t>Hugging Face + bitsandbytes</a:t>
             </a:r>
           </a:p>
         </p:txBody>
@@ -8907,7 +8962,7 @@
         <p:spPr>
           <a:xfrm>
             <a:off x="3392424" y="1810512"/>
-            <a:ext cx="515721" cy="237744"/>
+            <a:ext cx="621792" cy="237744"/>
           </a:xfrm>
           <a:prstGeom prst="roundRect">
             <a:avLst>
@@ -9005,7 +9060,7 @@
         <p:spPr>
           <a:xfrm>
             <a:off x="3575304" y="1810512"/>
-            <a:ext cx="332841" cy="237744"/>
+            <a:ext cx="438912" cy="237744"/>
           </a:xfrm>
           <a:prstGeom prst="rect">
             <a:avLst/>
@@ -9020,7 +9075,7 @@
           <a:p>
             <a:pPr algn="l"/>
             <a:r>
-              <a:rPr sz="800" b="0" i="0">
+              <a:rPr sz="1100" b="0" i="0">
                 <a:solidFill>
                   <a:srgbClr val="1F2933"/>
                 </a:solidFill>
@@ -9039,8 +9094,8 @@
         </p:nvSpPr>
         <p:spPr>
           <a:xfrm>
-            <a:off x="3981297" y="1810512"/>
-            <a:ext cx="1239926" cy="237744"/>
+            <a:off x="4087368" y="1810512"/>
+            <a:ext cx="1088136" cy="237744"/>
           </a:xfrm>
           <a:prstGeom prst="roundRect">
             <a:avLst>
@@ -9093,7 +9148,7 @@
         </p:nvSpPr>
         <p:spPr>
           <a:xfrm>
-            <a:off x="4040733" y="1888236"/>
+            <a:off x="4146804" y="1888236"/>
             <a:ext cx="82296" cy="82296"/>
           </a:xfrm>
           <a:prstGeom prst="ellipse">
@@ -9137,8 +9192,8 @@
         </p:nvSpPr>
         <p:spPr>
           <a:xfrm>
-            <a:off x="4164177" y="1810512"/>
-            <a:ext cx="1057046" cy="237744"/>
+            <a:off x="4270248" y="1810512"/>
+            <a:ext cx="905256" cy="237744"/>
           </a:xfrm>
           <a:prstGeom prst="rect">
             <a:avLst/>
@@ -9153,13 +9208,13 @@
           <a:p>
             <a:pPr algn="l"/>
             <a:r>
-              <a:rPr sz="800" b="0" i="0">
+              <a:rPr sz="1100" b="0" i="0">
                 <a:solidFill>
                   <a:srgbClr val="1F2933"/>
                 </a:solidFill>
                 <a:latin typeface="Arial"/>
               </a:rPr>
-              <a:t>INT8  LLM.int8()</a:t>
+              <a:t>LLM.int8()</a:t>
             </a:r>
           </a:p>
         </p:txBody>
@@ -9172,8 +9227,8 @@
         </p:nvSpPr>
         <p:spPr>
           <a:xfrm>
-            <a:off x="5294376" y="1810512"/>
-            <a:ext cx="877824" cy="237744"/>
+            <a:off x="5248656" y="1810512"/>
+            <a:ext cx="544068" cy="237744"/>
           </a:xfrm>
           <a:prstGeom prst="roundRect">
             <a:avLst>
@@ -9226,7 +9281,7 @@
         </p:nvSpPr>
         <p:spPr>
           <a:xfrm>
-            <a:off x="5353812" y="1888236"/>
+            <a:off x="5308092" y="1888236"/>
             <a:ext cx="82296" cy="82296"/>
           </a:xfrm>
           <a:prstGeom prst="ellipse">
@@ -9270,8 +9325,8 @@
         </p:nvSpPr>
         <p:spPr>
           <a:xfrm>
-            <a:off x="5477256" y="1810512"/>
-            <a:ext cx="694944" cy="237744"/>
+            <a:off x="5431536" y="1810512"/>
+            <a:ext cx="361187" cy="237744"/>
           </a:xfrm>
           <a:prstGeom prst="rect">
             <a:avLst/>
@@ -9286,13 +9341,13 @@
           <a:p>
             <a:pPr algn="l"/>
             <a:r>
-              <a:rPr sz="800" b="0" i="0">
+              <a:rPr sz="1100" b="0" i="0">
                 <a:solidFill>
                   <a:srgbClr val="1F2933"/>
                 </a:solidFill>
                 <a:latin typeface="Arial"/>
               </a:rPr>
-              <a:t>NF4  4-bit</a:t>
+              <a:t>NF4</a:t>
             </a:r>
           </a:p>
         </p:txBody>
@@ -9321,13 +9376,13 @@
           <a:p>
             <a:pPr algn="l"/>
             <a:r>
-              <a:rPr sz="850" b="1" i="0">
+              <a:rPr sz="1100" b="1" i="0">
                 <a:solidFill>
                   <a:srgbClr val="5B6770"/>
                 </a:solidFill>
                 <a:latin typeface="Arial"/>
               </a:rPr>
-              <a:t>vLLM (CUDA graphs) + fused kernels, official checkpoints</a:t>
+              <a:t>vLLM + fused kernels</a:t>
             </a:r>
           </a:p>
         </p:txBody>
@@ -9341,7 +9396,7 @@
         <p:spPr>
           <a:xfrm>
             <a:off x="3392424" y="2377439"/>
-            <a:ext cx="515721" cy="237744"/>
+            <a:ext cx="621792" cy="237744"/>
           </a:xfrm>
           <a:prstGeom prst="roundRect">
             <a:avLst>
@@ -9439,7 +9494,7 @@
         <p:spPr>
           <a:xfrm>
             <a:off x="3575304" y="2377439"/>
-            <a:ext cx="332841" cy="237744"/>
+            <a:ext cx="438912" cy="237744"/>
           </a:xfrm>
           <a:prstGeom prst="rect">
             <a:avLst/>
@@ -9454,7 +9509,7 @@
           <a:p>
             <a:pPr algn="l"/>
             <a:r>
-              <a:rPr sz="800" b="0" i="0">
+              <a:rPr sz="1100" b="0" i="0">
                 <a:solidFill>
                   <a:srgbClr val="1F2933"/>
                 </a:solidFill>
@@ -9473,8 +9528,8 @@
         </p:nvSpPr>
         <p:spPr>
           <a:xfrm>
-            <a:off x="3981297" y="2377439"/>
-            <a:ext cx="817473" cy="237744"/>
+            <a:off x="4087368" y="2377439"/>
+            <a:ext cx="544068" cy="237744"/>
           </a:xfrm>
           <a:prstGeom prst="roundRect">
             <a:avLst>
@@ -9527,7 +9582,7 @@
         </p:nvSpPr>
         <p:spPr>
           <a:xfrm>
-            <a:off x="4040733" y="2455164"/>
+            <a:off x="4146804" y="2455164"/>
             <a:ext cx="82296" cy="82296"/>
           </a:xfrm>
           <a:prstGeom prst="ellipse">
@@ -9571,8 +9626,8 @@
         </p:nvSpPr>
         <p:spPr>
           <a:xfrm>
-            <a:off x="4164177" y="2377439"/>
-            <a:ext cx="634593" cy="237744"/>
+            <a:off x="4270248" y="2377439"/>
+            <a:ext cx="361187" cy="237744"/>
           </a:xfrm>
           <a:prstGeom prst="rect">
             <a:avLst/>
@@ -9587,13 +9642,13 @@
           <a:p>
             <a:pPr algn="l"/>
             <a:r>
-              <a:rPr sz="800" b="0" i="0">
+              <a:rPr sz="1100" b="0" i="0">
                 <a:solidFill>
                   <a:srgbClr val="1F2933"/>
                 </a:solidFill>
                 <a:latin typeface="Arial"/>
               </a:rPr>
-              <a:t>FP8  W8A8</a:t>
+              <a:t>FP8</a:t>
             </a:r>
           </a:p>
         </p:txBody>
@@ -9606,8 +9661,8 @@
         </p:nvSpPr>
         <p:spPr>
           <a:xfrm>
-            <a:off x="4871923" y="2377439"/>
-            <a:ext cx="1239926" cy="237744"/>
+            <a:off x="4704588" y="2377439"/>
+            <a:ext cx="1010412" cy="237744"/>
           </a:xfrm>
           <a:prstGeom prst="roundRect">
             <a:avLst>
@@ -9660,7 +9715,7 @@
         </p:nvSpPr>
         <p:spPr>
           <a:xfrm>
-            <a:off x="4931359" y="2455164"/>
+            <a:off x="4764024" y="2455164"/>
             <a:ext cx="82296" cy="82296"/>
           </a:xfrm>
           <a:prstGeom prst="ellipse">
@@ -9704,8 +9759,8 @@
         </p:nvSpPr>
         <p:spPr>
           <a:xfrm>
-            <a:off x="5054803" y="2377439"/>
-            <a:ext cx="1057046" cy="237744"/>
+            <a:off x="4887468" y="2377439"/>
+            <a:ext cx="827532" cy="237744"/>
           </a:xfrm>
           <a:prstGeom prst="rect">
             <a:avLst/>
@@ -9720,13 +9775,13 @@
           <a:p>
             <a:pPr algn="l"/>
             <a:r>
-              <a:rPr sz="800" b="0" i="0">
+              <a:rPr sz="1100" b="0" i="0">
                 <a:solidFill>
                   <a:srgbClr val="1F2933"/>
                 </a:solidFill>
                 <a:latin typeface="Arial"/>
               </a:rPr>
-              <a:t>INT8  GPTQ W8A16</a:t>
+              <a:t>GPTQ-INT8</a:t>
             </a:r>
           </a:p>
         </p:txBody>
@@ -9739,8 +9794,8 @@
         </p:nvSpPr>
         <p:spPr>
           <a:xfrm>
-            <a:off x="6185001" y="2377439"/>
-            <a:ext cx="1602028" cy="237744"/>
+            <a:off x="5788152" y="2377439"/>
+            <a:ext cx="1476756" cy="237744"/>
           </a:xfrm>
           <a:prstGeom prst="roundRect">
             <a:avLst>
@@ -9793,7 +9848,7 @@
         </p:nvSpPr>
         <p:spPr>
           <a:xfrm>
-            <a:off x="6244437" y="2455164"/>
+            <a:off x="5847588" y="2455164"/>
             <a:ext cx="82296" cy="82296"/>
           </a:xfrm>
           <a:prstGeom prst="ellipse">
@@ -9837,8 +9892,8 @@
         </p:nvSpPr>
         <p:spPr>
           <a:xfrm>
-            <a:off x="6367881" y="2377439"/>
-            <a:ext cx="1419148" cy="237744"/>
+            <a:off x="5971032" y="2377439"/>
+            <a:ext cx="1293876" cy="237744"/>
           </a:xfrm>
           <a:prstGeom prst="rect">
             <a:avLst/>
@@ -9853,13 +9908,13 @@
           <a:p>
             <a:pPr algn="l"/>
             <a:r>
-              <a:rPr sz="800" b="0" i="0">
+              <a:rPr sz="1100" b="0" i="0">
                 <a:solidFill>
                   <a:srgbClr val="1F2933"/>
                 </a:solidFill>
                 <a:latin typeface="Arial"/>
               </a:rPr>
-              <a:t>INT4  AWQ / GPTQ W4A16</a:t>
+              <a:t>AWQ / GPTQ-INT4</a:t>
             </a:r>
           </a:p>
         </p:txBody>
@@ -10059,22 +10114,22 @@
               </a:spcAft>
             </a:pPr>
             <a:r>
-              <a:rPr sz="900" b="1" i="0">
+              <a:rPr sz="1150" b="1" i="0">
                 <a:solidFill>
                   <a:srgbClr val="003865"/>
                 </a:solidFill>
                 <a:latin typeface="Arial"/>
               </a:rPr>
-              <a:t>Controlled sweep: </a:t>
-            </a:r>
-            <a:r>
-              <a:rPr sz="900" b="0" i="0">
+              <a:t>Sweep: </a:t>
+            </a:r>
+            <a:r>
+              <a:rPr sz="1150" b="0" i="0">
                 <a:solidFill>
                   <a:srgbClr val="1F2933"/>
                 </a:solidFill>
                 <a:latin typeface="Arial"/>
               </a:rPr>
-              <a:t>batch 1–256 × prompt 128–2048 tokens × 32–512 output tokens</a:t>
+              <a:t>batch 1–256 × prompt 128–2048 tokens</a:t>
             </a:r>
           </a:p>
           <a:p>
@@ -10084,32 +10139,28 @@
               </a:spcAft>
             </a:pPr>
             <a:r>
-              <a:rPr sz="900" b="1" i="0">
+              <a:rPr sz="1150" b="1" i="0">
                 <a:solidFill>
                   <a:srgbClr val="003865"/>
                 </a:solidFill>
                 <a:latin typeface="Arial"/>
               </a:rPr>
-              <a:t>Real workload: </a:t>
-            </a:r>
-            <a:r>
-              <a:rPr sz="900" b="0" i="0">
+              <a:t>Real traffic: </a:t>
+            </a:r>
+            <a:r>
+              <a:rPr sz="1150" b="0" i="0">
                 <a:solidFill>
                   <a:srgbClr val="1F2933"/>
                 </a:solidFill>
                 <a:latin typeface="Arial"/>
               </a:rPr>
-              <a:t>300 ShareGPT requests (fixed seed), 1–64 concurrent clients</a:t>
-            </a:r>
-          </a:p>
-          <a:p>
-            <a:pPr algn="l">
-              <a:spcAft>
-                <a:spcPts val="300"/>
-              </a:spcAft>
-            </a:pPr>
-            <a:r>
-              <a:rPr sz="900" b="1" i="0">
+              <a:t>300 ShareGPT requests, 1–64 clients</a:t>
+            </a:r>
+          </a:p>
+          <a:p>
+            <a:pPr algn="l"/>
+            <a:r>
+              <a:rPr sz="1150" b="1" i="0">
                 <a:solidFill>
                   <a:srgbClr val="003865"/>
                 </a:solidFill>
@@ -10118,34 +10169,13 @@
               <a:t>Quality: </a:t>
             </a:r>
             <a:r>
-              <a:rPr sz="900" b="0" i="0">
+              <a:rPr sz="1150" b="0" i="0">
                 <a:solidFill>
                   <a:srgbClr val="1F2933"/>
                 </a:solidFill>
                 <a:latin typeface="Arial"/>
               </a:rPr>
-              <a:t>WikiText-2 perplexity, GSM8K (1,319 q.), MMLU (14,042 q.), paired McNemar tests</a:t>
-            </a:r>
-          </a:p>
-          <a:p>
-            <a:pPr algn="l"/>
-            <a:r>
-              <a:rPr sz="900" b="1" i="0">
-                <a:solidFill>
-                  <a:srgbClr val="003865"/>
-                </a:solidFill>
-                <a:latin typeface="Arial"/>
-              </a:rPr>
-              <a:t>Metrics: </a:t>
-            </a:r>
-            <a:r>
-              <a:rPr sz="900" b="0" i="0">
-                <a:solidFill>
-                  <a:srgbClr val="1F2933"/>
-                </a:solidFill>
-                <a:latin typeface="Arial"/>
-              </a:rPr>
-              <a:t>peak memory, TTFT, TPOT, tokens/s, energy (J/token); 1 warm-up + 3 repeats</a:t>
+              <a:t>WikiText-2, GSM8K, MMLU; paired tests</a:t>
             </a:r>
           </a:p>
         </p:txBody>
@@ -10224,7 +10254,7 @@
       </p:sp>
       <p:pic>
         <p:nvPicPr>
-          <p:cNvPr id="4" name="Picture 3" descr="Peak memory breakdown and memory saving versus tokens in flight"/>
+          <p:cNvPr id="4" name="Picture 3" descr="Weight memory against the naive estimate, and memory saving versus tokens in flight"/>
           <p:cNvPicPr>
             <a:picLocks noChangeAspect="1"/>
           </p:cNvPicPr>
@@ -10238,8 +10268,8 @@
         </p:blipFill>
         <p:spPr>
           <a:xfrm>
-            <a:off x="457200" y="1543070"/>
-            <a:ext cx="5715000" cy="2208234"/>
+            <a:off x="1241090" y="1133856"/>
+            <a:ext cx="6661818" cy="2148840"/>
           </a:xfrm>
           <a:prstGeom prst="rect">
             <a:avLst/>
@@ -10260,12 +10290,12 @@
         </p:nvSpPr>
         <p:spPr>
           <a:xfrm>
-            <a:off x="6309360" y="1133856"/>
-            <a:ext cx="2377439" cy="947927"/>
+            <a:off x="457200" y="3374136"/>
+            <a:ext cx="2651760" cy="786384"/>
           </a:xfrm>
           <a:prstGeom prst="roundRect">
             <a:avLst>
-              <a:gd name="adj" fmla="val 7717"/>
+              <a:gd name="adj" fmla="val 9302"/>
             </a:avLst>
           </a:prstGeom>
           <a:solidFill>
@@ -10306,8 +10336,8 @@
         </p:nvSpPr>
         <p:spPr>
           <a:xfrm>
-            <a:off x="6437376" y="1207008"/>
-            <a:ext cx="2157983" cy="384048"/>
+            <a:off x="585216" y="3429000"/>
+            <a:ext cx="2432304" cy="384048"/>
           </a:xfrm>
           <a:prstGeom prst="rect">
             <a:avLst/>
@@ -10322,7 +10352,7 @@
           <a:p>
             <a:pPr algn="l"/>
             <a:r>
-              <a:rPr sz="2000" b="1" i="0">
+              <a:rPr sz="2200" b="1" i="0">
                 <a:solidFill>
                   <a:srgbClr val="003865"/>
                 </a:solidFill>
@@ -10341,8 +10371,8 @@
         </p:nvSpPr>
         <p:spPr>
           <a:xfrm>
-            <a:off x="6437376" y="1591056"/>
-            <a:ext cx="2157983" cy="435863"/>
+            <a:off x="585216" y="3794760"/>
+            <a:ext cx="2432304" cy="329184"/>
           </a:xfrm>
           <a:prstGeom prst="rect">
             <a:avLst/>
@@ -10355,31 +10385,15 @@
           </a:bodyPr>
           <a:lstStyle/>
           <a:p>
-            <a:pPr algn="l">
-              <a:spcAft>
-                <a:spcPts val="200"/>
-              </a:spcAft>
-            </a:pPr>
-            <a:r>
-              <a:rPr sz="850" b="0" i="0">
+            <a:pPr algn="l"/>
+            <a:r>
+              <a:rPr sz="1200" b="0" i="0">
                 <a:solidFill>
                   <a:srgbClr val="1F2933"/>
                 </a:solidFill>
                 <a:latin typeface="Arial"/>
               </a:rPr>
-              <a:t>NF4 weight saving on Qwen2.5-7B</a:t>
-            </a:r>
-          </a:p>
-          <a:p>
-            <a:pPr algn="l"/>
-            <a:r>
-              <a:rPr sz="750" b="0" i="0">
-                <a:solidFill>
-                  <a:srgbClr val="5B6770"/>
-                </a:solidFill>
-                <a:latin typeface="Arial"/>
-              </a:rPr>
-              <a:t>nominal 4× — LM head + embeddings stay 16-bit</a:t>
+              <a:t>NF4 weight saving (7B), not 4×</a:t>
             </a:r>
           </a:p>
         </p:txBody>
@@ -10398,12 +10412,12 @@
         </p:nvSpPr>
         <p:spPr>
           <a:xfrm>
-            <a:off x="6309360" y="2173224"/>
-            <a:ext cx="2377439" cy="947927"/>
+            <a:off x="3246120" y="3374136"/>
+            <a:ext cx="2651760" cy="786384"/>
           </a:xfrm>
           <a:prstGeom prst="roundRect">
             <a:avLst>
-              <a:gd name="adj" fmla="val 7717"/>
+              <a:gd name="adj" fmla="val 9302"/>
             </a:avLst>
           </a:prstGeom>
           <a:solidFill>
@@ -10444,8 +10458,8 @@
         </p:nvSpPr>
         <p:spPr>
           <a:xfrm>
-            <a:off x="6437376" y="2246376"/>
-            <a:ext cx="2157983" cy="384048"/>
+            <a:off x="3374136" y="3429000"/>
+            <a:ext cx="2432304" cy="384048"/>
           </a:xfrm>
           <a:prstGeom prst="rect">
             <a:avLst/>
@@ -10460,7 +10474,7 @@
           <a:p>
             <a:pPr algn="l"/>
             <a:r>
-              <a:rPr sz="2000" b="1" i="0">
+              <a:rPr sz="2200" b="1" i="0">
                 <a:solidFill>
                   <a:srgbClr val="003865"/>
                 </a:solidFill>
@@ -10479,8 +10493,8 @@
         </p:nvSpPr>
         <p:spPr>
           <a:xfrm>
-            <a:off x="6437376" y="2630424"/>
-            <a:ext cx="2157983" cy="435863"/>
+            <a:off x="3374136" y="3794760"/>
+            <a:ext cx="2432304" cy="329184"/>
           </a:xfrm>
           <a:prstGeom prst="rect">
             <a:avLst/>
@@ -10493,31 +10507,15 @@
           </a:bodyPr>
           <a:lstStyle/>
           <a:p>
-            <a:pPr algn="l">
-              <a:spcAft>
-                <a:spcPts val="200"/>
-              </a:spcAft>
-            </a:pPr>
-            <a:r>
-              <a:rPr sz="850" b="0" i="0">
+            <a:pPr algn="l"/>
+            <a:r>
+              <a:rPr sz="1200" b="0" i="0">
                 <a:solidFill>
                   <a:srgbClr val="1F2933"/>
                 </a:solidFill>
                 <a:latin typeface="Arial"/>
               </a:rPr>
-              <a:t>NF4 end-to-end saving at B=32, L=2048</a:t>
-            </a:r>
-          </a:p>
-          <a:p>
-            <a:pPr algn="l"/>
-            <a:r>
-              <a:rPr sz="750" b="0" i="0">
-                <a:solidFill>
-                  <a:srgbClr val="5B6770"/>
-                </a:solidFill>
-                <a:latin typeface="Arial"/>
-              </a:rPr>
-              <a:t>KV cache and activations are not quantized</a:t>
+              <a:t>NF4 total saving, B=32, L=2048</a:t>
             </a:r>
           </a:p>
         </p:txBody>
@@ -10536,12 +10534,12 @@
         </p:nvSpPr>
         <p:spPr>
           <a:xfrm>
-            <a:off x="6309360" y="3212591"/>
-            <a:ext cx="2377439" cy="947927"/>
+            <a:off x="6035040" y="3374136"/>
+            <a:ext cx="2651760" cy="786384"/>
           </a:xfrm>
           <a:prstGeom prst="roundRect">
             <a:avLst>
-              <a:gd name="adj" fmla="val 7717"/>
+              <a:gd name="adj" fmla="val 9302"/>
             </a:avLst>
           </a:prstGeom>
           <a:solidFill>
@@ -10582,8 +10580,8 @@
         </p:nvSpPr>
         <p:spPr>
           <a:xfrm>
-            <a:off x="6437376" y="3285743"/>
-            <a:ext cx="2157983" cy="384048"/>
+            <a:off x="6163055" y="3429000"/>
+            <a:ext cx="2432304" cy="384048"/>
           </a:xfrm>
           <a:prstGeom prst="rect">
             <a:avLst/>
@@ -10598,7 +10596,7 @@
           <a:p>
             <a:pPr algn="l"/>
             <a:r>
-              <a:rPr sz="2000" b="1" i="0">
+              <a:rPr sz="2200" b="1" i="0">
                 <a:solidFill>
                   <a:srgbClr val="003865"/>
                 </a:solidFill>
@@ -10617,8 +10615,8 @@
         </p:nvSpPr>
         <p:spPr>
           <a:xfrm>
-            <a:off x="6437376" y="3669791"/>
-            <a:ext cx="2157983" cy="435863"/>
+            <a:off x="6163055" y="3794760"/>
+            <a:ext cx="2432304" cy="329184"/>
           </a:xfrm>
           <a:prstGeom prst="rect">
             <a:avLst/>
@@ -10631,31 +10629,15 @@
           </a:bodyPr>
           <a:lstStyle/>
           <a:p>
-            <a:pPr algn="l">
-              <a:spcAft>
-                <a:spcPts val="200"/>
-              </a:spcAft>
-            </a:pPr>
-            <a:r>
-              <a:rPr sz="850" b="0" i="0">
+            <a:pPr algn="l"/>
+            <a:r>
+              <a:rPr sz="1200" b="0" i="0">
                 <a:solidFill>
                   <a:srgbClr val="1F2933"/>
                 </a:solidFill>
                 <a:latin typeface="Arial"/>
               </a:rPr>
-              <a:t>more KV-cache tokens in vLLM with AWQ-INT4</a:t>
-            </a:r>
-          </a:p>
-          <a:p>
-            <a:pPr algn="l"/>
-            <a:r>
-              <a:rPr sz="750" b="0" i="0">
-                <a:solidFill>
-                  <a:srgbClr val="5B6770"/>
-                </a:solidFill>
-                <a:latin typeface="Arial"/>
-              </a:rPr>
-              <a:t>freed memory = more concurrent requests</a:t>
+              <a:t>more KV-cache tokens (vLLM AWQ)</a:t>
             </a:r>
           </a:p>
         </p:txBody>
@@ -10700,7 +10682,7 @@
           <a:p>
             <a:r>
               <a:rPr sz="2800"/>
-              <a:t>Q2 — Speed Depends on the Kernel</a:t>
+              <a:t>Q2 — Same Bits, Different Speed</a:t>
             </a:r>
           </a:p>
         </p:txBody>
@@ -10727,14 +10709,14 @@
           <a:p>
             <a:r>
               <a:rPr sz="1400"/>
-              <a:t>Qwen2.5-7B at batch 1: low-bit decode ranges from 2.4× faster to 3.4× slower — the kernel decides</a:t>
+              <a:t>Qwen2.5-7B decode: from 2.4× faster to 3.4× slower than BF16 — the implementation decides</a:t>
             </a:r>
           </a:p>
         </p:txBody>
       </p:sp>
       <p:pic>
         <p:nvPicPr>
-          <p:cNvPr id="4" name="Picture 3" descr="TTFT, decode latency and throughput of eight configurations for Qwen2.5-7B"/>
+          <p:cNvPr id="4" name="Picture 3" descr="Decode speedup against weight memory saved, and against batch size"/>
           <p:cNvPicPr>
             <a:picLocks noChangeAspect="1"/>
           </p:cNvPicPr>
@@ -10748,8 +10730,8 @@
         </p:blipFill>
         <p:spPr>
           <a:xfrm>
-            <a:off x="1369613" y="1133856"/>
-            <a:ext cx="6404772" cy="2048255"/>
+            <a:off x="1906643" y="1133856"/>
+            <a:ext cx="5330712" cy="2148840"/>
           </a:xfrm>
           <a:prstGeom prst="rect">
             <a:avLst/>
@@ -10770,12 +10752,12 @@
         </p:nvSpPr>
         <p:spPr>
           <a:xfrm>
-            <a:off x="457200" y="3291839"/>
-            <a:ext cx="2651760" cy="868680"/>
+            <a:off x="457200" y="3374136"/>
+            <a:ext cx="2651760" cy="786384"/>
           </a:xfrm>
           <a:prstGeom prst="roundRect">
             <a:avLst>
-              <a:gd name="adj" fmla="val 8421"/>
+              <a:gd name="adj" fmla="val 9302"/>
             </a:avLst>
           </a:prstGeom>
           <a:solidFill>
@@ -10816,7 +10798,7 @@
         </p:nvSpPr>
         <p:spPr>
           <a:xfrm>
-            <a:off x="585216" y="3364991"/>
+            <a:off x="585216" y="3429000"/>
             <a:ext cx="2432304" cy="384048"/>
           </a:xfrm>
           <a:prstGeom prst="rect">
@@ -10832,7 +10814,7 @@
           <a:p>
             <a:pPr algn="l"/>
             <a:r>
-              <a:rPr sz="2000" b="1" i="0">
+              <a:rPr sz="2200" b="1" i="0">
                 <a:solidFill>
                   <a:srgbClr val="003865"/>
                 </a:solidFill>
@@ -10851,8 +10833,8 @@
         </p:nvSpPr>
         <p:spPr>
           <a:xfrm>
-            <a:off x="585216" y="3749039"/>
-            <a:ext cx="2432304" cy="356615"/>
+            <a:off x="585216" y="3794760"/>
+            <a:ext cx="2432304" cy="329184"/>
           </a:xfrm>
           <a:prstGeom prst="rect">
             <a:avLst/>
@@ -10865,31 +10847,15 @@
           </a:bodyPr>
           <a:lstStyle/>
           <a:p>
-            <a:pPr algn="l">
-              <a:spcAft>
-                <a:spcPts val="200"/>
-              </a:spcAft>
-            </a:pPr>
-            <a:r>
-              <a:rPr sz="850" b="0" i="0">
+            <a:pPr algn="l"/>
+            <a:r>
+              <a:rPr sz="1200" b="0" i="0">
                 <a:solidFill>
                   <a:srgbClr val="1F2933"/>
                 </a:solidFill>
                 <a:latin typeface="Arial"/>
               </a:rPr>
-              <a:t>AWQ-INT4 decode on vLLM (B=1)</a:t>
-            </a:r>
-          </a:p>
-          <a:p>
-            <a:pPr algn="l"/>
-            <a:r>
-              <a:rPr sz="750" b="0" i="0">
-                <a:solidFill>
-                  <a:srgbClr val="5B6770"/>
-                </a:solidFill>
-                <a:latin typeface="Arial"/>
-              </a:rPr>
-              <a:t>Marlin kernel: fewer bytes = less time</a:t>
+              <a:t>AWQ-INT4 on vLLM, batch 1</a:t>
             </a:r>
           </a:p>
         </p:txBody>
@@ -10908,12 +10874,12 @@
         </p:nvSpPr>
         <p:spPr>
           <a:xfrm>
-            <a:off x="3246120" y="3291839"/>
-            <a:ext cx="2651760" cy="868680"/>
+            <a:off x="3246120" y="3374136"/>
+            <a:ext cx="2651760" cy="786384"/>
           </a:xfrm>
           <a:prstGeom prst="roundRect">
             <a:avLst>
-              <a:gd name="adj" fmla="val 8421"/>
+              <a:gd name="adj" fmla="val 9302"/>
             </a:avLst>
           </a:prstGeom>
           <a:solidFill>
@@ -10954,7 +10920,7 @@
         </p:nvSpPr>
         <p:spPr>
           <a:xfrm>
-            <a:off x="3374136" y="3364991"/>
+            <a:off x="3374136" y="3429000"/>
             <a:ext cx="2432304" cy="384048"/>
           </a:xfrm>
           <a:prstGeom prst="rect">
@@ -10970,7 +10936,7 @@
           <a:p>
             <a:pPr algn="l"/>
             <a:r>
-              <a:rPr sz="2000" b="1" i="0">
+              <a:rPr sz="2200" b="1" i="0">
                 <a:solidFill>
                   <a:srgbClr val="003865"/>
                 </a:solidFill>
@@ -10989,8 +10955,8 @@
         </p:nvSpPr>
         <p:spPr>
           <a:xfrm>
-            <a:off x="3374136" y="3749039"/>
-            <a:ext cx="2432304" cy="356615"/>
+            <a:off x="3374136" y="3794760"/>
+            <a:ext cx="2432304" cy="329184"/>
           </a:xfrm>
           <a:prstGeom prst="rect">
             <a:avLst/>
@@ -11003,31 +10969,15 @@
           </a:bodyPr>
           <a:lstStyle/>
           <a:p>
-            <a:pPr algn="l">
-              <a:spcAft>
-                <a:spcPts val="200"/>
-              </a:spcAft>
-            </a:pPr>
-            <a:r>
-              <a:rPr sz="850" b="0" i="0">
+            <a:pPr algn="l"/>
+            <a:r>
+              <a:rPr sz="1200" b="0" i="0">
                 <a:solidFill>
                   <a:srgbClr val="1F2933"/>
                 </a:solidFill>
                 <a:latin typeface="Arial"/>
               </a:rPr>
-              <a:t>LLM.int8() decode on HF (B=1)</a:t>
-            </a:r>
-          </a:p>
-          <a:p>
-            <a:pPr algn="l"/>
-            <a:r>
-              <a:rPr sz="750" b="0" i="0">
-                <a:solidFill>
-                  <a:srgbClr val="5B6770"/>
-                </a:solidFill>
-                <a:latin typeface="Arial"/>
-              </a:rPr>
-              <a:t>outliers + kernel-launch overhead</a:t>
+              <a:t>LLM.int8() on HF, batch 1</a:t>
             </a:r>
           </a:p>
         </p:txBody>
@@ -11046,12 +10996,12 @@
         </p:nvSpPr>
         <p:spPr>
           <a:xfrm>
-            <a:off x="6035040" y="3291839"/>
-            <a:ext cx="2651760" cy="868680"/>
+            <a:off x="6035040" y="3374136"/>
+            <a:ext cx="2651760" cy="786384"/>
           </a:xfrm>
           <a:prstGeom prst="roundRect">
             <a:avLst>
-              <a:gd name="adj" fmla="val 8421"/>
+              <a:gd name="adj" fmla="val 9302"/>
             </a:avLst>
           </a:prstGeom>
           <a:solidFill>
@@ -11092,7 +11042,7 @@
         </p:nvSpPr>
         <p:spPr>
           <a:xfrm>
-            <a:off x="6163055" y="3364991"/>
+            <a:off x="6163055" y="3429000"/>
             <a:ext cx="2432304" cy="384048"/>
           </a:xfrm>
           <a:prstGeom prst="rect">
@@ -11108,7 +11058,7 @@
           <a:p>
             <a:pPr algn="l"/>
             <a:r>
-              <a:rPr sz="2000" b="1" i="0">
+              <a:rPr sz="2200" b="1" i="0">
                 <a:solidFill>
                   <a:srgbClr val="003865"/>
                 </a:solidFill>
@@ -11127,8 +11077,8 @@
         </p:nvSpPr>
         <p:spPr>
           <a:xfrm>
-            <a:off x="6163055" y="3749039"/>
-            <a:ext cx="2432304" cy="356615"/>
+            <a:off x="6163055" y="3794760"/>
+            <a:ext cx="2432304" cy="329184"/>
           </a:xfrm>
           <a:prstGeom prst="rect">
             <a:avLst/>
@@ -11141,31 +11091,15 @@
           </a:bodyPr>
           <a:lstStyle/>
           <a:p>
-            <a:pPr algn="l">
-              <a:spcAft>
-                <a:spcPts val="200"/>
-              </a:spcAft>
-            </a:pPr>
-            <a:r>
-              <a:rPr sz="850" b="0" i="0">
+            <a:pPr algn="l"/>
+            <a:r>
+              <a:rPr sz="1200" b="0" i="0">
                 <a:solidFill>
                   <a:srgbClr val="1F2933"/>
                 </a:solidFill>
                 <a:latin typeface="Arial"/>
               </a:rPr>
-              <a:t>FP8 W8A8 throughput at B=256</a:t>
-            </a:r>
-          </a:p>
-          <a:p>
-            <a:pPr algn="l"/>
-            <a:r>
-              <a:rPr sz="750" b="0" i="0">
-                <a:solidFill>
-                  <a:srgbClr val="5B6770"/>
-                </a:solidFill>
-                <a:latin typeface="Arial"/>
-              </a:rPr>
-              <a:t>AWQ-INT4 there: no faster than BF16</a:t>
+              <a:t>FP8 throughput at batch 256</a:t>
             </a:r>
           </a:p>
         </p:txBody>
@@ -11259,7 +11193,7 @@
         <p:spPr>
           <a:xfrm>
             <a:off x="457200" y="1133856"/>
-            <a:ext cx="5450991" cy="3026663"/>
+            <a:ext cx="6171591" cy="3026664"/>
           </a:xfrm>
           <a:prstGeom prst="rect">
             <a:avLst/>
@@ -11280,8 +11214,8 @@
         </p:nvSpPr>
         <p:spPr>
           <a:xfrm>
-            <a:off x="6045351" y="1133856"/>
-            <a:ext cx="2641448" cy="947927"/>
+            <a:off x="6765951" y="1133856"/>
+            <a:ext cx="1920848" cy="947927"/>
           </a:xfrm>
           <a:prstGeom prst="roundRect">
             <a:avLst>
@@ -11326,8 +11260,8 @@
         </p:nvSpPr>
         <p:spPr>
           <a:xfrm>
-            <a:off x="6173367" y="1207008"/>
-            <a:ext cx="2421992" cy="384048"/>
+            <a:off x="6893967" y="1188720"/>
+            <a:ext cx="1701392" cy="384048"/>
           </a:xfrm>
           <a:prstGeom prst="rect">
             <a:avLst/>
@@ -11342,7 +11276,7 @@
           <a:p>
             <a:pPr algn="l"/>
             <a:r>
-              <a:rPr sz="2000" b="1" i="0">
+              <a:rPr sz="2200" b="1" i="0">
                 <a:solidFill>
                   <a:srgbClr val="003865"/>
                 </a:solidFill>
@@ -11361,8 +11295,8 @@
         </p:nvSpPr>
         <p:spPr>
           <a:xfrm>
-            <a:off x="6173367" y="1591056"/>
-            <a:ext cx="2421992" cy="435863"/>
+            <a:off x="6893967" y="1554480"/>
+            <a:ext cx="1701392" cy="490727"/>
           </a:xfrm>
           <a:prstGeom prst="rect">
             <a:avLst/>
@@ -11375,31 +11309,15 @@
           </a:bodyPr>
           <a:lstStyle/>
           <a:p>
-            <a:pPr algn="l">
-              <a:spcAft>
-                <a:spcPts val="200"/>
-              </a:spcAft>
-            </a:pPr>
-            <a:r>
-              <a:rPr sz="850" b="0" i="0">
+            <a:pPr algn="l"/>
+            <a:r>
+              <a:rPr sz="1200" b="0" i="0">
                 <a:solidFill>
                   <a:srgbClr val="1F2933"/>
                 </a:solidFill>
                 <a:latin typeface="Arial"/>
               </a:rPr>
-              <a:t>AWQ-INT4 stops winning (prompt 512)</a:t>
-            </a:r>
-          </a:p>
-          <a:p>
-            <a:pPr algn="l"/>
-            <a:r>
-              <a:rPr sz="750" b="0" i="0">
-                <a:solidFill>
-                  <a:srgbClr val="5B6770"/>
-                </a:solidFill>
-                <a:latin typeface="Arial"/>
-              </a:rPr>
-              <a:t>decode turns compute-bound; dequant no longer hidden</a:t>
+              <a:t>AWQ-INT4 stops winning</a:t>
             </a:r>
           </a:p>
         </p:txBody>
@@ -11418,8 +11336,8 @@
         </p:nvSpPr>
         <p:spPr>
           <a:xfrm>
-            <a:off x="6045351" y="2173224"/>
-            <a:ext cx="2641448" cy="947927"/>
+            <a:off x="6765951" y="2173224"/>
+            <a:ext cx="1920848" cy="947927"/>
           </a:xfrm>
           <a:prstGeom prst="roundRect">
             <a:avLst>
@@ -11464,8 +11382,8 @@
         </p:nvSpPr>
         <p:spPr>
           <a:xfrm>
-            <a:off x="6173367" y="2246376"/>
-            <a:ext cx="2421992" cy="384048"/>
+            <a:off x="6893967" y="2228088"/>
+            <a:ext cx="1701392" cy="384048"/>
           </a:xfrm>
           <a:prstGeom prst="rect">
             <a:avLst/>
@@ -11480,13 +11398,13 @@
           <a:p>
             <a:pPr algn="l"/>
             <a:r>
-              <a:rPr sz="2000" b="1" i="0">
+              <a:rPr sz="2200" b="1" i="0">
                 <a:solidFill>
                   <a:srgbClr val="003865"/>
                 </a:solidFill>
                 <a:latin typeface="Arial"/>
               </a:rPr>
-              <a:t>1.59–1.80×</a:t>
+              <a:t>1.6–1.8×</a:t>
             </a:r>
           </a:p>
         </p:txBody>
@@ -11499,8 +11417,8 @@
         </p:nvSpPr>
         <p:spPr>
           <a:xfrm>
-            <a:off x="6173367" y="2630424"/>
-            <a:ext cx="2421992" cy="435863"/>
+            <a:off x="6893967" y="2593848"/>
+            <a:ext cx="1701392" cy="490727"/>
           </a:xfrm>
           <a:prstGeom prst="rect">
             <a:avLst/>
@@ -11513,31 +11431,15 @@
           </a:bodyPr>
           <a:lstStyle/>
           <a:p>
-            <a:pPr algn="l">
-              <a:spcAft>
-                <a:spcPts val="200"/>
-              </a:spcAft>
-            </a:pPr>
-            <a:r>
-              <a:rPr sz="850" b="0" i="0">
+            <a:pPr algn="l"/>
+            <a:r>
+              <a:rPr sz="1200" b="0" i="0">
                 <a:solidFill>
                   <a:srgbClr val="1F2933"/>
                 </a:solidFill>
                 <a:latin typeface="Arial"/>
               </a:rPr>
-              <a:t>FP8 W8A8 faster in every cell</a:t>
-            </a:r>
-          </a:p>
-          <a:p>
-            <a:pPr algn="l"/>
-            <a:r>
-              <a:rPr sz="750" b="0" i="0">
-                <a:solidFill>
-                  <a:srgbClr val="5B6770"/>
-                </a:solidFill>
-                <a:latin typeface="Arial"/>
-              </a:rPr>
-              <a:t>halves bytes and doubles tensor-core rate</a:t>
+              <a:t>FP8 faster in every cell</a:t>
             </a:r>
           </a:p>
         </p:txBody>
@@ -11556,8 +11458,8 @@
         </p:nvSpPr>
         <p:spPr>
           <a:xfrm>
-            <a:off x="6045351" y="3212591"/>
-            <a:ext cx="2641448" cy="947927"/>
+            <a:off x="6765951" y="3212591"/>
+            <a:ext cx="1920848" cy="947927"/>
           </a:xfrm>
           <a:prstGeom prst="roundRect">
             <a:avLst>
@@ -11602,8 +11504,8 @@
         </p:nvSpPr>
         <p:spPr>
           <a:xfrm>
-            <a:off x="6173367" y="3285743"/>
-            <a:ext cx="2421992" cy="384048"/>
+            <a:off x="6893967" y="3267455"/>
+            <a:ext cx="1701392" cy="384048"/>
           </a:xfrm>
           <a:prstGeom prst="rect">
             <a:avLst/>
@@ -11618,7 +11520,7 @@
           <a:p>
             <a:pPr algn="l"/>
             <a:r>
-              <a:rPr sz="2000" b="1" i="0">
+              <a:rPr sz="2200" b="1" i="0">
                 <a:solidFill>
                   <a:srgbClr val="003865"/>
                 </a:solidFill>
@@ -11637,8 +11539,8 @@
         </p:nvSpPr>
         <p:spPr>
           <a:xfrm>
-            <a:off x="6173367" y="3669791"/>
-            <a:ext cx="2421992" cy="435863"/>
+            <a:off x="6893967" y="3633215"/>
+            <a:ext cx="1701392" cy="490727"/>
           </a:xfrm>
           <a:prstGeom prst="rect">
             <a:avLst/>
@@ -11651,31 +11553,15 @@
           </a:bodyPr>
           <a:lstStyle/>
           <a:p>
-            <a:pPr algn="l">
-              <a:spcAft>
-                <a:spcPts val="200"/>
-              </a:spcAft>
-            </a:pPr>
-            <a:r>
-              <a:rPr sz="850" b="0" i="0">
+            <a:pPr algn="l"/>
+            <a:r>
+              <a:rPr sz="1200" b="0" i="0">
                 <a:solidFill>
                   <a:srgbClr val="1F2933"/>
                 </a:solidFill>
                 <a:latin typeface="Arial"/>
               </a:rPr>
-              <a:t>bnb LLM.int8(): slower in every cell</a:t>
-            </a:r>
-          </a:p>
-          <a:p>
-            <a:pPr algn="l"/>
-            <a:r>
-              <a:rPr sz="750" b="0" i="0">
-                <a:solidFill>
-                  <a:srgbClr val="5B6770"/>
-                </a:solidFill>
-                <a:latin typeface="Arial"/>
-              </a:rPr>
-              <a:t>never pays off on this GPU</a:t>
+              <a:t>LLM.int8() slower in every cell</a:t>
             </a:r>
           </a:p>
         </p:txBody>
@@ -11768,8 +11654,8 @@
         </p:blipFill>
         <p:spPr>
           <a:xfrm>
-            <a:off x="1841946" y="1133856"/>
-            <a:ext cx="5460106" cy="2048256"/>
+            <a:off x="2061381" y="1133856"/>
+            <a:ext cx="5021237" cy="2148840"/>
           </a:xfrm>
           <a:prstGeom prst="rect">
             <a:avLst/>
@@ -11790,12 +11676,12 @@
         </p:nvSpPr>
         <p:spPr>
           <a:xfrm>
-            <a:off x="457200" y="3291839"/>
-            <a:ext cx="2651760" cy="868680"/>
+            <a:off x="457200" y="3374136"/>
+            <a:ext cx="2651760" cy="786384"/>
           </a:xfrm>
           <a:prstGeom prst="roundRect">
             <a:avLst>
-              <a:gd name="adj" fmla="val 8421"/>
+              <a:gd name="adj" fmla="val 9302"/>
             </a:avLst>
           </a:prstGeom>
           <a:solidFill>
@@ -11836,7 +11722,7 @@
         </p:nvSpPr>
         <p:spPr>
           <a:xfrm>
-            <a:off x="585216" y="3364991"/>
+            <a:off x="585216" y="3429000"/>
             <a:ext cx="2432304" cy="384048"/>
           </a:xfrm>
           <a:prstGeom prst="rect">
@@ -11852,7 +11738,7 @@
           <a:p>
             <a:pPr algn="l"/>
             <a:r>
-              <a:rPr sz="2000" b="1" i="0">
+              <a:rPr sz="2200" b="1" i="0">
                 <a:solidFill>
                   <a:srgbClr val="003865"/>
                 </a:solidFill>
@@ -11871,8 +11757,8 @@
         </p:nvSpPr>
         <p:spPr>
           <a:xfrm>
-            <a:off x="585216" y="3749039"/>
-            <a:ext cx="2432304" cy="356615"/>
+            <a:off x="585216" y="3794760"/>
+            <a:ext cx="2432304" cy="329184"/>
           </a:xfrm>
           <a:prstGeom prst="rect">
             <a:avLst/>
@@ -11885,31 +11771,15 @@
           </a:bodyPr>
           <a:lstStyle/>
           <a:p>
-            <a:pPr algn="l">
-              <a:spcAft>
-                <a:spcPts val="200"/>
-              </a:spcAft>
-            </a:pPr>
-            <a:r>
-              <a:rPr sz="850" b="0" i="0">
+            <a:pPr algn="l"/>
+            <a:r>
+              <a:rPr sz="1200" b="0" i="0">
                 <a:solidFill>
                   <a:srgbClr val="1F2933"/>
                 </a:solidFill>
                 <a:latin typeface="Arial"/>
               </a:rPr>
-              <a:t>Marlin W4A16 vs cuBLAS at M = 1</a:t>
-            </a:r>
-          </a:p>
-          <a:p>
-            <a:pPr algn="l"/>
-            <a:r>
-              <a:rPr sz="750" b="0" i="0">
-                <a:solidFill>
-                  <a:srgbClr val="5B6770"/>
-                </a:solidFill>
-                <a:latin typeface="Arial"/>
-              </a:rPr>
-              <a:t>memory-bound: 4x fewer bytes</a:t>
+              <a:t>Marlin W4A16 vs BF16 at M = 1</a:t>
             </a:r>
           </a:p>
         </p:txBody>
@@ -11928,12 +11798,12 @@
         </p:nvSpPr>
         <p:spPr>
           <a:xfrm>
-            <a:off x="3246120" y="3291839"/>
-            <a:ext cx="2651760" cy="868680"/>
+            <a:off x="3246120" y="3374136"/>
+            <a:ext cx="2651760" cy="786384"/>
           </a:xfrm>
           <a:prstGeom prst="roundRect">
             <a:avLst>
-              <a:gd name="adj" fmla="val 8421"/>
+              <a:gd name="adj" fmla="val 9302"/>
             </a:avLst>
           </a:prstGeom>
           <a:solidFill>
@@ -11974,7 +11844,7 @@
         </p:nvSpPr>
         <p:spPr>
           <a:xfrm>
-            <a:off x="3374136" y="3364991"/>
+            <a:off x="3374136" y="3429000"/>
             <a:ext cx="2432304" cy="384048"/>
           </a:xfrm>
           <a:prstGeom prst="rect">
@@ -11990,7 +11860,7 @@
           <a:p>
             <a:pPr algn="l"/>
             <a:r>
-              <a:rPr sz="2000" b="1" i="0">
+              <a:rPr sz="2200" b="1" i="0">
                 <a:solidFill>
                   <a:srgbClr val="003865"/>
                 </a:solidFill>
@@ -12009,8 +11879,8 @@
         </p:nvSpPr>
         <p:spPr>
           <a:xfrm>
-            <a:off x="3374136" y="3749039"/>
-            <a:ext cx="2432304" cy="356615"/>
+            <a:off x="3374136" y="3794760"/>
+            <a:ext cx="2432304" cy="329184"/>
           </a:xfrm>
           <a:prstGeom prst="rect">
             <a:avLst/>
@@ -12023,31 +11893,15 @@
           </a:bodyPr>
           <a:lstStyle/>
           <a:p>
-            <a:pPr algn="l">
-              <a:spcAft>
-                <a:spcPts val="200"/>
-              </a:spcAft>
-            </a:pPr>
-            <a:r>
-              <a:rPr sz="850" b="0" i="0">
+            <a:pPr algn="l"/>
+            <a:r>
+              <a:rPr sz="1200" b="0" i="0">
                 <a:solidFill>
                   <a:srgbClr val="1F2933"/>
                 </a:solidFill>
                 <a:latin typeface="Arial"/>
               </a:rPr>
-              <a:t>W4A16 advantage shrinks below 5%</a:t>
-            </a:r>
-          </a:p>
-          <a:p>
-            <a:pPr algn="l"/>
-            <a:r>
-              <a:rPr sz="750" b="0" i="0">
-                <a:solidFill>
-                  <a:srgbClr val="5B6770"/>
-                </a:solidFill>
-                <a:latin typeface="Arial"/>
-              </a:rPr>
-              <a:t>compute-bound: dequant no longer hidden</a:t>
+              <a:t>W4A16 gain falls below 5%</a:t>
             </a:r>
           </a:p>
         </p:txBody>
@@ -12066,12 +11920,12 @@
         </p:nvSpPr>
         <p:spPr>
           <a:xfrm>
-            <a:off x="6035040" y="3291839"/>
-            <a:ext cx="2651760" cy="868680"/>
+            <a:off x="6035040" y="3374136"/>
+            <a:ext cx="2651760" cy="786384"/>
           </a:xfrm>
           <a:prstGeom prst="roundRect">
             <a:avLst>
-              <a:gd name="adj" fmla="val 8421"/>
+              <a:gd name="adj" fmla="val 9302"/>
             </a:avLst>
           </a:prstGeom>
           <a:solidFill>
@@ -12112,7 +11966,7 @@
         </p:nvSpPr>
         <p:spPr>
           <a:xfrm>
-            <a:off x="6163055" y="3364991"/>
+            <a:off x="6163055" y="3429000"/>
             <a:ext cx="2432304" cy="384048"/>
           </a:xfrm>
           <a:prstGeom prst="rect">
@@ -12128,7 +11982,7 @@
           <a:p>
             <a:pPr algn="l"/>
             <a:r>
-              <a:rPr sz="2000" b="1" i="0">
+              <a:rPr sz="2200" b="1" i="0">
                 <a:solidFill>
                   <a:srgbClr val="003865"/>
                 </a:solidFill>
@@ -12147,8 +12001,8 @@
         </p:nvSpPr>
         <p:spPr>
           <a:xfrm>
-            <a:off x="6163055" y="3749039"/>
-            <a:ext cx="2432304" cy="356615"/>
+            <a:off x="6163055" y="3794760"/>
+            <a:ext cx="2432304" cy="329184"/>
           </a:xfrm>
           <a:prstGeom prst="rect">
             <a:avLst/>
@@ -12161,31 +12015,15 @@
           </a:bodyPr>
           <a:lstStyle/>
           <a:p>
-            <a:pPr algn="l">
-              <a:spcAft>
-                <a:spcPts val="200"/>
-              </a:spcAft>
-            </a:pPr>
-            <a:r>
-              <a:rPr sz="850" b="0" i="0">
+            <a:pPr algn="l"/>
+            <a:r>
+              <a:rPr sz="1200" b="0" i="0">
                 <a:solidFill>
                   <a:srgbClr val="1F2933"/>
                 </a:solidFill>
                 <a:latin typeface="Arial"/>
               </a:rPr>
               <a:t>FP8 W8A8 at M = 8192</a:t>
-            </a:r>
-          </a:p>
-          <a:p>
-            <a:pPr algn="l"/>
-            <a:r>
-              <a:rPr sz="750" b="0" i="0">
-                <a:solidFill>
-                  <a:srgbClr val="5B6770"/>
-                </a:solidFill>
-                <a:latin typeface="Arial"/>
-              </a:rPr>
-              <a:t>8-bit tensor cores: 2x the BF16 rate</a:t>
             </a:r>
           </a:p>
         </p:txBody>
@@ -12278,8 +12116,8 @@
         </p:blipFill>
         <p:spPr>
           <a:xfrm>
-            <a:off x="457200" y="1397618"/>
-            <a:ext cx="5577840" cy="2499138"/>
+            <a:off x="457200" y="1133856"/>
+            <a:ext cx="8229600" cy="1726884"/>
           </a:xfrm>
           <a:prstGeom prst="rect">
             <a:avLst/>
@@ -12300,12 +12138,12 @@
         </p:nvSpPr>
         <p:spPr>
           <a:xfrm>
-            <a:off x="6172200" y="1133856"/>
-            <a:ext cx="2514600" cy="947927"/>
+            <a:off x="457200" y="3291839"/>
+            <a:ext cx="2651760" cy="868680"/>
           </a:xfrm>
           <a:prstGeom prst="roundRect">
             <a:avLst>
-              <a:gd name="adj" fmla="val 7717"/>
+              <a:gd name="adj" fmla="val 8421"/>
             </a:avLst>
           </a:prstGeom>
           <a:solidFill>
@@ -12346,8 +12184,8 @@
         </p:nvSpPr>
         <p:spPr>
           <a:xfrm>
-            <a:off x="6300216" y="1207008"/>
-            <a:ext cx="2295144" cy="384048"/>
+            <a:off x="585216" y="3346703"/>
+            <a:ext cx="2432304" cy="384048"/>
           </a:xfrm>
           <a:prstGeom prst="rect">
             <a:avLst/>
@@ -12362,7 +12200,7 @@
           <a:p>
             <a:pPr algn="l"/>
             <a:r>
-              <a:rPr sz="2000" b="1" i="0">
+              <a:rPr sz="2200" b="1" i="0">
                 <a:solidFill>
                   <a:srgbClr val="003865"/>
                 </a:solidFill>
@@ -12381,8 +12219,8 @@
         </p:nvSpPr>
         <p:spPr>
           <a:xfrm>
-            <a:off x="6300216" y="1591056"/>
-            <a:ext cx="2295144" cy="435863"/>
+            <a:off x="585216" y="3712463"/>
+            <a:ext cx="2432304" cy="411479"/>
           </a:xfrm>
           <a:prstGeom prst="rect">
             <a:avLst/>
@@ -12395,31 +12233,15 @@
           </a:bodyPr>
           <a:lstStyle/>
           <a:p>
-            <a:pPr algn="l">
-              <a:spcAft>
-                <a:spcPts val="200"/>
-              </a:spcAft>
-            </a:pPr>
-            <a:r>
-              <a:rPr sz="850" b="0" i="0">
+            <a:pPr algn="l"/>
+            <a:r>
+              <a:rPr sz="1200" b="0" i="0">
                 <a:solidFill>
                   <a:srgbClr val="1F2933"/>
                 </a:solidFill>
                 <a:latin typeface="Arial"/>
               </a:rPr>
-              <a:t>GPU busy time per step: BF16 → INT8 (B=1)</a:t>
-            </a:r>
-          </a:p>
-          <a:p>
-            <a:pPr algn="l"/>
-            <a:r>
-              <a:rPr sz="750" b="0" i="0">
-                <a:solidFill>
-                  <a:srgbClr val="5B6770"/>
-                </a:solidFill>
-                <a:latin typeface="Arial"/>
-              </a:rPr>
-              <a:t>the rest is host overhead</a:t>
+              <a:t>GPU busy: BF16 → INT8</a:t>
             </a:r>
           </a:p>
         </p:txBody>
@@ -12438,12 +12260,12 @@
         </p:nvSpPr>
         <p:spPr>
           <a:xfrm>
-            <a:off x="6172200" y="2173224"/>
-            <a:ext cx="2514600" cy="947927"/>
+            <a:off x="3246120" y="3291839"/>
+            <a:ext cx="2651760" cy="868680"/>
           </a:xfrm>
           <a:prstGeom prst="roundRect">
             <a:avLst>
-              <a:gd name="adj" fmla="val 7717"/>
+              <a:gd name="adj" fmla="val 8421"/>
             </a:avLst>
           </a:prstGeom>
           <a:solidFill>
@@ -12484,8 +12306,8 @@
         </p:nvSpPr>
         <p:spPr>
           <a:xfrm>
-            <a:off x="6300216" y="2246376"/>
-            <a:ext cx="2295144" cy="384048"/>
+            <a:off x="3374136" y="3346703"/>
+            <a:ext cx="2432304" cy="384048"/>
           </a:xfrm>
           <a:prstGeom prst="rect">
             <a:avLst/>
@@ -12500,7 +12322,7 @@
           <a:p>
             <a:pPr algn="l"/>
             <a:r>
-              <a:rPr sz="2000" b="1" i="0">
+              <a:rPr sz="2200" b="1" i="0">
                 <a:solidFill>
                   <a:srgbClr val="003865"/>
                 </a:solidFill>
@@ -12519,8 +12341,8 @@
         </p:nvSpPr>
         <p:spPr>
           <a:xfrm>
-            <a:off x="6300216" y="2630424"/>
-            <a:ext cx="2295144" cy="435863"/>
+            <a:off x="3374136" y="3712463"/>
+            <a:ext cx="2432304" cy="411479"/>
           </a:xfrm>
           <a:prstGeom prst="rect">
             <a:avLst/>
@@ -12533,31 +12355,15 @@
           </a:bodyPr>
           <a:lstStyle/>
           <a:p>
-            <a:pPr algn="l">
-              <a:spcAft>
-                <a:spcPts val="200"/>
-              </a:spcAft>
-            </a:pPr>
-            <a:r>
-              <a:rPr sz="850" b="0" i="0">
+            <a:pPr algn="l"/>
+            <a:r>
+              <a:rPr sz="1200" b="0" i="0">
                 <a:solidFill>
                   <a:srgbClr val="1F2933"/>
                 </a:solidFill>
                 <a:latin typeface="Arial"/>
               </a:rPr>
-              <a:t>more kernel launches per step with LLM.int8()</a:t>
-            </a:r>
-          </a:p>
-          <a:p>
-            <a:pPr algn="l"/>
-            <a:r>
-              <a:rPr sz="750" b="0" i="0">
-                <a:solidFill>
-                  <a:srgbClr val="5B6770"/>
-                </a:solidFill>
-                <a:latin typeface="Arial"/>
-              </a:rPr>
-              <a:t>casts, outliers, quantize, 2 GEMMs per layer</a:t>
+              <a:t>more kernel launches (INT8)</a:t>
             </a:r>
           </a:p>
         </p:txBody>
@@ -12576,12 +12382,12 @@
         </p:nvSpPr>
         <p:spPr>
           <a:xfrm>
-            <a:off x="6172200" y="3212591"/>
-            <a:ext cx="2514600" cy="947927"/>
+            <a:off x="6035040" y="3291839"/>
+            <a:ext cx="2651760" cy="868680"/>
           </a:xfrm>
           <a:prstGeom prst="roundRect">
             <a:avLst>
-              <a:gd name="adj" fmla="val 7717"/>
+              <a:gd name="adj" fmla="val 8421"/>
             </a:avLst>
           </a:prstGeom>
           <a:solidFill>
@@ -12622,8 +12428,8 @@
         </p:nvSpPr>
         <p:spPr>
           <a:xfrm>
-            <a:off x="6300216" y="3285743"/>
-            <a:ext cx="2295144" cy="384048"/>
+            <a:off x="6163055" y="3346703"/>
+            <a:ext cx="2432304" cy="384048"/>
           </a:xfrm>
           <a:prstGeom prst="rect">
             <a:avLst/>
@@ -12638,7 +12444,7 @@
           <a:p>
             <a:pPr algn="l"/>
             <a:r>
-              <a:rPr sz="2000" b="1" i="0">
+              <a:rPr sz="2200" b="1" i="0">
                 <a:solidFill>
                   <a:srgbClr val="003865"/>
                 </a:solidFill>
@@ -12657,8 +12463,8 @@
         </p:nvSpPr>
         <p:spPr>
           <a:xfrm>
-            <a:off x="6300216" y="3669791"/>
-            <a:ext cx="2295144" cy="435863"/>
+            <a:off x="6163055" y="3712463"/>
+            <a:ext cx="2432304" cy="411479"/>
           </a:xfrm>
           <a:prstGeom prst="rect">
             <a:avLst/>
@@ -12671,31 +12477,15 @@
           </a:bodyPr>
           <a:lstStyle/>
           <a:p>
-            <a:pPr algn="l">
-              <a:spcAft>
-                <a:spcPts val="200"/>
-              </a:spcAft>
-            </a:pPr>
-            <a:r>
-              <a:rPr sz="850" b="0" i="0">
+            <a:pPr algn="l"/>
+            <a:r>
+              <a:rPr sz="1200" b="0" i="0">
                 <a:solidFill>
                   <a:srgbClr val="1F2933"/>
                 </a:solidFill>
                 <a:latin typeface="Arial"/>
               </a:rPr>
-              <a:t>NF4 end-to-end vs BF16 (7B, B=1)</a:t>
-            </a:r>
-          </a:p>
-          <a:p>
-            <a:pPr algn="l"/>
-            <a:r>
-              <a:rPr sz="750" b="0" i="0">
-                <a:solidFill>
-                  <a:srgbClr val="5B6770"/>
-                </a:solidFill>
-                <a:latin typeface="Arial"/>
-              </a:rPr>
-              <a:t>its GEMV kernel alone: 2.4×; GPU busy 49%</a:t>
+              <a:t>NF4 vs BF16, whole model</a:t>
             </a:r>
           </a:p>
         </p:txBody>
@@ -12788,8 +12578,8 @@
         </p:blipFill>
         <p:spPr>
           <a:xfrm>
-            <a:off x="1498211" y="1133856"/>
-            <a:ext cx="6147577" cy="2048256"/>
+            <a:off x="1735798" y="1133856"/>
+            <a:ext cx="5672403" cy="2148840"/>
           </a:xfrm>
           <a:prstGeom prst="rect">
             <a:avLst/>
@@ -12810,12 +12600,12 @@
         </p:nvSpPr>
         <p:spPr>
           <a:xfrm>
-            <a:off x="457200" y="3291839"/>
-            <a:ext cx="2651760" cy="868680"/>
+            <a:off x="457200" y="3374136"/>
+            <a:ext cx="2651760" cy="786384"/>
           </a:xfrm>
           <a:prstGeom prst="roundRect">
             <a:avLst>
-              <a:gd name="adj" fmla="val 8421"/>
+              <a:gd name="adj" fmla="val 9302"/>
             </a:avLst>
           </a:prstGeom>
           <a:solidFill>
@@ -12856,7 +12646,7 @@
         </p:nvSpPr>
         <p:spPr>
           <a:xfrm>
-            <a:off x="585216" y="3364991"/>
+            <a:off x="585216" y="3429000"/>
             <a:ext cx="2432304" cy="384048"/>
           </a:xfrm>
           <a:prstGeom prst="rect">
@@ -12872,7 +12662,7 @@
           <a:p>
             <a:pPr algn="l"/>
             <a:r>
-              <a:rPr sz="2000" b="1" i="0">
+              <a:rPr sz="2200" b="1" i="0">
                 <a:solidFill>
                   <a:srgbClr val="003865"/>
                 </a:solidFill>
@@ -12891,8 +12681,8 @@
         </p:nvSpPr>
         <p:spPr>
           <a:xfrm>
-            <a:off x="585216" y="3749039"/>
-            <a:ext cx="2432304" cy="356615"/>
+            <a:off x="585216" y="3794760"/>
+            <a:ext cx="2432304" cy="329184"/>
           </a:xfrm>
           <a:prstGeom prst="rect">
             <a:avLst/>
@@ -12905,31 +12695,15 @@
           </a:bodyPr>
           <a:lstStyle/>
           <a:p>
-            <a:pPr algn="l">
-              <a:spcAft>
-                <a:spcPts val="200"/>
-              </a:spcAft>
-            </a:pPr>
-            <a:r>
-              <a:rPr sz="850" b="0" i="0">
+            <a:pPr algn="l"/>
+            <a:r>
+              <a:rPr sz="1200" b="0" i="0">
                 <a:solidFill>
                   <a:srgbClr val="1F2933"/>
                 </a:solidFill>
                 <a:latin typeface="Arial"/>
               </a:rPr>
-              <a:t>lower median TPOT with AWQ-INT4 (1 client)</a:t>
-            </a:r>
-          </a:p>
-          <a:p>
-            <a:pPr algn="l"/>
-            <a:r>
-              <a:rPr sz="750" b="0" i="0">
-                <a:solidFill>
-                  <a:srgbClr val="5B6770"/>
-                </a:solidFill>
-                <a:latin typeface="Arial"/>
-              </a:rPr>
-              <a:t>4.1 vs 9.6 ms per token</a:t>
+              <a:t>lower TPOT, AWQ-INT4, 1 client</a:t>
             </a:r>
           </a:p>
         </p:txBody>
@@ -12948,12 +12722,12 @@
         </p:nvSpPr>
         <p:spPr>
           <a:xfrm>
-            <a:off x="3246120" y="3291839"/>
-            <a:ext cx="2651760" cy="868680"/>
+            <a:off x="3246120" y="3374136"/>
+            <a:ext cx="2651760" cy="786384"/>
           </a:xfrm>
           <a:prstGeom prst="roundRect">
             <a:avLst>
-              <a:gd name="adj" fmla="val 8421"/>
+              <a:gd name="adj" fmla="val 9302"/>
             </a:avLst>
           </a:prstGeom>
           <a:solidFill>
@@ -12994,7 +12768,7 @@
         </p:nvSpPr>
         <p:spPr>
           <a:xfrm>
-            <a:off x="3374136" y="3364991"/>
+            <a:off x="3374136" y="3429000"/>
             <a:ext cx="2432304" cy="384048"/>
           </a:xfrm>
           <a:prstGeom prst="rect">
@@ -13010,7 +12784,7 @@
           <a:p>
             <a:pPr algn="l"/>
             <a:r>
-              <a:rPr sz="2000" b="1" i="0">
+              <a:rPr sz="2200" b="1" i="0">
                 <a:solidFill>
                   <a:srgbClr val="003865"/>
                 </a:solidFill>
@@ -13029,8 +12803,8 @@
         </p:nvSpPr>
         <p:spPr>
           <a:xfrm>
-            <a:off x="3374136" y="3749039"/>
-            <a:ext cx="2432304" cy="356615"/>
+            <a:off x="3374136" y="3794760"/>
+            <a:ext cx="2432304" cy="329184"/>
           </a:xfrm>
           <a:prstGeom prst="rect">
             <a:avLst/>
@@ -13043,31 +12817,15 @@
           </a:bodyPr>
           <a:lstStyle/>
           <a:p>
-            <a:pPr algn="l">
-              <a:spcAft>
-                <a:spcPts val="200"/>
-              </a:spcAft>
-            </a:pPr>
-            <a:r>
-              <a:rPr sz="850" b="0" i="0">
+            <a:pPr algn="l"/>
+            <a:r>
+              <a:rPr sz="1200" b="0" i="0">
                 <a:solidFill>
                   <a:srgbClr val="1F2933"/>
                 </a:solidFill>
                 <a:latin typeface="Arial"/>
               </a:rPr>
-              <a:t>tokens/s with FP8 at 64 clients</a:t>
-            </a:r>
-          </a:p>
-          <a:p>
-            <a:pPr algn="l"/>
-            <a:r>
-              <a:rPr sz="750" b="0" i="0">
-                <a:solidFill>
-                  <a:srgbClr val="5B6770"/>
-                </a:solidFill>
-                <a:latin typeface="Arial"/>
-              </a:rPr>
-              <a:t>BF16: 3,537 · AWQ: 5,180</a:t>
+              <a:t>tokens/s, FP8, 64 clients</a:t>
             </a:r>
           </a:p>
         </p:txBody>
@@ -13086,12 +12844,12 @@
         </p:nvSpPr>
         <p:spPr>
           <a:xfrm>
-            <a:off x="6035040" y="3291839"/>
-            <a:ext cx="2651760" cy="868680"/>
+            <a:off x="6035040" y="3374136"/>
+            <a:ext cx="2651760" cy="786384"/>
           </a:xfrm>
           <a:prstGeom prst="roundRect">
             <a:avLst>
-              <a:gd name="adj" fmla="val 8421"/>
+              <a:gd name="adj" fmla="val 9302"/>
             </a:avLst>
           </a:prstGeom>
           <a:solidFill>
@@ -13132,7 +12890,7 @@
         </p:nvSpPr>
         <p:spPr>
           <a:xfrm>
-            <a:off x="6163055" y="3364991"/>
+            <a:off x="6163055" y="3429000"/>
             <a:ext cx="2432304" cy="384048"/>
           </a:xfrm>
           <a:prstGeom prst="rect">
@@ -13148,7 +12906,7 @@
           <a:p>
             <a:pPr algn="l"/>
             <a:r>
-              <a:rPr sz="2000" b="1" i="0">
+              <a:rPr sz="2200" b="1" i="0">
                 <a:solidFill>
                   <a:srgbClr val="003865"/>
                 </a:solidFill>
@@ -13167,8 +12925,8 @@
         </p:nvSpPr>
         <p:spPr>
           <a:xfrm>
-            <a:off x="6163055" y="3749039"/>
-            <a:ext cx="2432304" cy="356615"/>
+            <a:off x="6163055" y="3794760"/>
+            <a:ext cx="2432304" cy="329184"/>
           </a:xfrm>
           <a:prstGeom prst="rect">
             <a:avLst/>
@@ -13181,31 +12939,15 @@
           </a:bodyPr>
           <a:lstStyle/>
           <a:p>
-            <a:pPr algn="l">
-              <a:spcAft>
-                <a:spcPts val="200"/>
-              </a:spcAft>
-            </a:pPr>
-            <a:r>
-              <a:rPr sz="850" b="0" i="0">
+            <a:pPr algn="l"/>
+            <a:r>
+              <a:rPr sz="1200" b="0" i="0">
                 <a:solidFill>
                   <a:srgbClr val="1F2933"/>
                 </a:solidFill>
                 <a:latin typeface="Arial"/>
               </a:rPr>
-              <a:t>vLLM BF16 vs HF BF16 throughput at 16 in flight</a:t>
-            </a:r>
-          </a:p>
-          <a:p>
-            <a:pPr algn="l"/>
-            <a:r>
-              <a:rPr sz="750" b="0" i="0">
-                <a:solidFill>
-                  <a:srgbClr val="5B6770"/>
-                </a:solidFill>
-                <a:latin typeface="Arial"/>
-              </a:rPr>
-              <a:t>the serving stack outweighs the bit-width</a:t>
+              <a:t>vLLM vs HF, both BF16</a:t>
             </a:r>
           </a:p>
         </p:txBody>
@@ -13298,8 +13040,8 @@
         </p:blipFill>
         <p:spPr>
           <a:xfrm>
-            <a:off x="457200" y="1133856"/>
-            <a:ext cx="8229600" cy="2035639"/>
+            <a:off x="1824220" y="1133856"/>
+            <a:ext cx="5495558" cy="2148840"/>
           </a:xfrm>
           <a:prstGeom prst="rect">
             <a:avLst/>
@@ -13320,12 +13062,12 @@
         </p:nvSpPr>
         <p:spPr>
           <a:xfrm>
-            <a:off x="457200" y="3291839"/>
-            <a:ext cx="2651760" cy="868680"/>
+            <a:off x="457200" y="3374136"/>
+            <a:ext cx="2651760" cy="786384"/>
           </a:xfrm>
           <a:prstGeom prst="roundRect">
             <a:avLst>
-              <a:gd name="adj" fmla="val 8421"/>
+              <a:gd name="adj" fmla="val 9302"/>
             </a:avLst>
           </a:prstGeom>
           <a:solidFill>
@@ -13366,7 +13108,7 @@
         </p:nvSpPr>
         <p:spPr>
           <a:xfrm>
-            <a:off x="585216" y="3364991"/>
+            <a:off x="585216" y="3429000"/>
             <a:ext cx="2432304" cy="384048"/>
           </a:xfrm>
           <a:prstGeom prst="rect">
@@ -13382,7 +13124,7 @@
           <a:p>
             <a:pPr algn="l"/>
             <a:r>
-              <a:rPr sz="2000" b="1" i="0">
+              <a:rPr sz="2200" b="1" i="0">
                 <a:solidFill>
                   <a:srgbClr val="003865"/>
                 </a:solidFill>
@@ -13401,8 +13143,8 @@
         </p:nvSpPr>
         <p:spPr>
           <a:xfrm>
-            <a:off x="585216" y="3749039"/>
-            <a:ext cx="2432304" cy="356615"/>
+            <a:off x="585216" y="3794760"/>
+            <a:ext cx="2432304" cy="329184"/>
           </a:xfrm>
           <a:prstGeom prst="rect">
             <a:avLst/>
@@ -13415,31 +13157,15 @@
           </a:bodyPr>
           <a:lstStyle/>
           <a:p>
-            <a:pPr algn="l">
-              <a:spcAft>
-                <a:spcPts val="200"/>
-              </a:spcAft>
-            </a:pPr>
-            <a:r>
-              <a:rPr sz="850" b="0" i="0">
+            <a:pPr algn="l"/>
+            <a:r>
+              <a:rPr sz="1200" b="0" i="0">
                 <a:solidFill>
                   <a:srgbClr val="1F2933"/>
                 </a:solidFill>
                 <a:latin typeface="Arial"/>
               </a:rPr>
-              <a:t>GPTQ-INT8 / FP8 vs BF16, GSM8K + MMLU</a:t>
-            </a:r>
-          </a:p>
-          <a:p>
-            <a:pPr algn="l"/>
-            <a:r>
-              <a:rPr sz="750" b="0" i="0">
-                <a:solidFill>
-                  <a:srgbClr val="5B6770"/>
-                </a:solidFill>
-                <a:latin typeface="Arial"/>
-              </a:rPr>
-              <a:t>all sizes; only LLM.int8() on 3B loses (−1.1 MMLU pp)</a:t>
+              <a:t>8-bit (GPTQ-INT8, FP8) vs BF16</a:t>
             </a:r>
           </a:p>
         </p:txBody>
@@ -13458,12 +13184,12 @@
         </p:nvSpPr>
         <p:spPr>
           <a:xfrm>
-            <a:off x="3246120" y="3291839"/>
-            <a:ext cx="2651760" cy="868680"/>
+            <a:off x="3246120" y="3374136"/>
+            <a:ext cx="2651760" cy="786384"/>
           </a:xfrm>
           <a:prstGeom prst="roundRect">
             <a:avLst>
-              <a:gd name="adj" fmla="val 8421"/>
+              <a:gd name="adj" fmla="val 9302"/>
             </a:avLst>
           </a:prstGeom>
           <a:solidFill>
@@ -13504,7 +13230,7 @@
         </p:nvSpPr>
         <p:spPr>
           <a:xfrm>
-            <a:off x="3374136" y="3364991"/>
+            <a:off x="3374136" y="3429000"/>
             <a:ext cx="2432304" cy="384048"/>
           </a:xfrm>
           <a:prstGeom prst="rect">
@@ -13520,7 +13246,7 @@
           <a:p>
             <a:pPr algn="l"/>
             <a:r>
-              <a:rPr sz="2000" b="1" i="0">
+              <a:rPr sz="2200" b="1" i="0">
                 <a:solidFill>
                   <a:srgbClr val="003865"/>
                 </a:solidFill>
@@ -13539,8 +13265,8 @@
         </p:nvSpPr>
         <p:spPr>
           <a:xfrm>
-            <a:off x="3374136" y="3749039"/>
-            <a:ext cx="2432304" cy="356615"/>
+            <a:off x="3374136" y="3794760"/>
+            <a:ext cx="2432304" cy="329184"/>
           </a:xfrm>
           <a:prstGeom prst="rect">
             <a:avLst/>
@@ -13553,31 +13279,15 @@
           </a:bodyPr>
           <a:lstStyle/>
           <a:p>
-            <a:pPr algn="l">
-              <a:spcAft>
-                <a:spcPts val="200"/>
-              </a:spcAft>
-            </a:pPr>
-            <a:r>
-              <a:rPr sz="850" b="0" i="0">
+            <a:pPr algn="l"/>
+            <a:r>
+              <a:rPr sz="1200" b="0" i="0">
                 <a:solidFill>
                   <a:srgbClr val="1F2933"/>
                 </a:solidFill>
                 <a:latin typeface="Arial"/>
               </a:rPr>
-              <a:t>MMLU change with 4-bit formats</a:t>
-            </a:r>
-          </a:p>
-          <a:p>
-            <a:pPr algn="l"/>
-            <a:r>
-              <a:rPr sz="750" b="0" i="0">
-                <a:solidFill>
-                  <a:srgbClr val="5B6770"/>
-                </a:solidFill>
-                <a:latin typeface="Arial"/>
-              </a:rPr>
-              <a:t>3B −2.8…−2.2 · 7B −1.6…−0.6 · 14B −1.9…−0.6</a:t>
+              <a:t>MMLU change, 4-bit formats</a:t>
             </a:r>
           </a:p>
         </p:txBody>
@@ -13596,12 +13306,12 @@
         </p:nvSpPr>
         <p:spPr>
           <a:xfrm>
-            <a:off x="6035040" y="3291839"/>
-            <a:ext cx="2651760" cy="868680"/>
+            <a:off x="6035040" y="3374136"/>
+            <a:ext cx="2651760" cy="786384"/>
           </a:xfrm>
           <a:prstGeom prst="roundRect">
             <a:avLst>
-              <a:gd name="adj" fmla="val 8421"/>
+              <a:gd name="adj" fmla="val 9302"/>
             </a:avLst>
           </a:prstGeom>
           <a:solidFill>
@@ -13642,7 +13352,7 @@
         </p:nvSpPr>
         <p:spPr>
           <a:xfrm>
-            <a:off x="6163055" y="3364991"/>
+            <a:off x="6163055" y="3429000"/>
             <a:ext cx="2432304" cy="384048"/>
           </a:xfrm>
           <a:prstGeom prst="rect">
@@ -13658,7 +13368,7 @@
           <a:p>
             <a:pPr algn="l"/>
             <a:r>
-              <a:rPr sz="2000" b="1" i="0">
+              <a:rPr sz="2200" b="1" i="0">
                 <a:solidFill>
                   <a:srgbClr val="003865"/>
                 </a:solidFill>
@@ -13677,8 +13387,8 @@
         </p:nvSpPr>
         <p:spPr>
           <a:xfrm>
-            <a:off x="6163055" y="3749039"/>
-            <a:ext cx="2432304" cy="356615"/>
+            <a:off x="6163055" y="3794760"/>
+            <a:ext cx="2432304" cy="329184"/>
           </a:xfrm>
           <a:prstGeom prst="rect">
             <a:avLst/>
@@ -13691,31 +13401,15 @@
           </a:bodyPr>
           <a:lstStyle/>
           <a:p>
-            <a:pPr algn="l">
-              <a:spcAft>
-                <a:spcPts val="200"/>
-              </a:spcAft>
-            </a:pPr>
-            <a:r>
-              <a:rPr sz="850" b="0" i="0">
+            <a:pPr algn="l"/>
+            <a:r>
+              <a:rPr sz="1200" b="0" i="0">
                 <a:solidFill>
                   <a:srgbClr val="1F2933"/>
                 </a:solidFill>
                 <a:latin typeface="Arial"/>
               </a:rPr>
-              <a:t>14B AWQ-INT4 vs 7B BF16 (GSM8K / MMLU)</a:t>
-            </a:r>
-          </a:p>
-          <a:p>
-            <a:pPr algn="l"/>
-            <a:r>
-              <a:rPr sz="750" b="0" i="0">
-                <a:solidFill>
-                  <a:srgbClr val="5B6770"/>
-                </a:solidFill>
-                <a:latin typeface="Arial"/>
-              </a:rPr>
-              <a:t>0.66× the weight memory, McNemar p &lt; 0.001</a:t>
+              <a:t>14B 4-bit vs 7B BF16</a:t>
             </a:r>
           </a:p>
         </p:txBody>

</xml_diff>